<commit_message>
divide supported log devices into individual files
</commit_message>
<xml_diff>
--- a/docs/IFX MSD cases.pptx
+++ b/docs/IFX MSD cases.pptx
@@ -5,10 +5,10 @@
     <p:sldMasterId id="2147483715" r:id="rId5"/>
   </p:sldMasterIdLst>
   <p:notesMasterIdLst>
-    <p:notesMasterId r:id="rId28"/>
+    <p:notesMasterId r:id="rId29"/>
   </p:notesMasterIdLst>
   <p:handoutMasterIdLst>
-    <p:handoutMasterId r:id="rId29"/>
+    <p:handoutMasterId r:id="rId30"/>
   </p:handoutMasterIdLst>
   <p:sldIdLst>
     <p:sldId id="267" r:id="rId6"/>
@@ -29,15 +29,16 @@
     <p:sldId id="2018" r:id="rId21"/>
     <p:sldId id="277" r:id="rId22"/>
     <p:sldId id="276" r:id="rId23"/>
-    <p:sldId id="2014" r:id="rId24"/>
-    <p:sldId id="275" r:id="rId25"/>
-    <p:sldId id="278" r:id="rId26"/>
-    <p:sldId id="257" r:id="rId27"/>
+    <p:sldId id="275" r:id="rId24"/>
+    <p:sldId id="2014" r:id="rId25"/>
+    <p:sldId id="2019" r:id="rId26"/>
+    <p:sldId id="278" r:id="rId27"/>
+    <p:sldId id="257" r:id="rId28"/>
   </p:sldIdLst>
   <p:sldSz cx="12192000" cy="6858000"/>
   <p:notesSz cx="7099300" cy="10234613"/>
   <p:custDataLst>
-    <p:tags r:id="rId30"/>
+    <p:tags r:id="rId31"/>
   </p:custDataLst>
   <p:defaultTextStyle>
     <a:defPPr>
@@ -4143,7 +4144,7 @@
             <a:fld id="{20CF0657-954C-457B-AB6C-2444DAE1F514}" type="datetime3">
               <a:rPr lang="en-GB" smtClean="0"/>
               <a:pPr/>
-              <a:t>24 July, 2023</a:t>
+              <a:t>9 August, 2023</a:t>
             </a:fld>
             <a:r>
               <a:rPr lang="en-GB"/>
@@ -5415,7 +5416,7 @@
             <a:fld id="{20CF0657-954C-457B-AB6C-2444DAE1F514}" type="datetime3">
               <a:rPr lang="en-GB" smtClean="0"/>
               <a:pPr/>
-              <a:t>24 July, 2023</a:t>
+              <a:t>9 August, 2023</a:t>
             </a:fld>
             <a:r>
               <a:rPr lang="en-GB"/>
@@ -7813,7 +7814,7 @@
             <a:fld id="{20CF0657-954C-457B-AB6C-2444DAE1F514}" type="datetime3">
               <a:rPr lang="en-GB" smtClean="0"/>
               <a:pPr/>
-              <a:t>24 July, 2023</a:t>
+              <a:t>9 August, 2023</a:t>
             </a:fld>
             <a:r>
               <a:rPr lang="en-GB"/>
@@ -9113,7 +9114,7 @@
             <a:fld id="{20CF0657-954C-457B-AB6C-2444DAE1F514}" type="datetime3">
               <a:rPr lang="en-GB" smtClean="0"/>
               <a:pPr/>
-              <a:t>24 July, 2023</a:t>
+              <a:t>9 August, 2023</a:t>
             </a:fld>
             <a:r>
               <a:rPr lang="en-GB"/>
@@ -10483,7 +10484,7 @@
             <a:fld id="{20CF0657-954C-457B-AB6C-2444DAE1F514}" type="datetime3">
               <a:rPr lang="en-GB" smtClean="0"/>
               <a:pPr/>
-              <a:t>24 July, 2023</a:t>
+              <a:t>9 August, 2023</a:t>
             </a:fld>
             <a:r>
               <a:rPr lang="en-GB"/>
@@ -11316,7 +11317,7 @@
             <a:fld id="{20CF0657-954C-457B-AB6C-2444DAE1F514}" type="datetime3">
               <a:rPr lang="en-GB" smtClean="0"/>
               <a:pPr/>
-              <a:t>24 July, 2023</a:t>
+              <a:t>9 August, 2023</a:t>
             </a:fld>
             <a:r>
               <a:rPr lang="en-GB"/>
@@ -12447,7 +12448,7 @@
             <a:fld id="{20CF0657-954C-457B-AB6C-2444DAE1F514}" type="datetime3">
               <a:rPr lang="en-GB" smtClean="0"/>
               <a:pPr/>
-              <a:t>24 July, 2023</a:t>
+              <a:t>9 August, 2023</a:t>
             </a:fld>
             <a:r>
               <a:rPr lang="en-GB" dirty="0"/>
@@ -13745,7 +13746,7 @@
             <a:fld id="{20CF0657-954C-457B-AB6C-2444DAE1F514}" type="datetime3">
               <a:rPr lang="en-GB" smtClean="0"/>
               <a:pPr/>
-              <a:t>24 July, 2023</a:t>
+              <a:t>9 August, 2023</a:t>
             </a:fld>
             <a:r>
               <a:rPr lang="en-GB" dirty="0"/>
@@ -15581,7 +15582,7 @@
             <a:fld id="{20CF0657-954C-457B-AB6C-2444DAE1F514}" type="datetime3">
               <a:rPr lang="en-GB" smtClean="0"/>
               <a:pPr/>
-              <a:t>24 July, 2023</a:t>
+              <a:t>9 August, 2023</a:t>
             </a:fld>
             <a:r>
               <a:rPr lang="en-GB"/>
@@ -16556,7 +16557,7 @@
             <a:fld id="{20CF0657-954C-457B-AB6C-2444DAE1F514}" type="datetime3">
               <a:rPr lang="en-GB" smtClean="0"/>
               <a:pPr/>
-              <a:t>24 July, 2023</a:t>
+              <a:t>9 August, 2023</a:t>
             </a:fld>
             <a:r>
               <a:rPr lang="en-GB"/>
@@ -17632,7 +17633,7 @@
             <a:fld id="{20CF0657-954C-457B-AB6C-2444DAE1F514}" type="datetime3">
               <a:rPr lang="en-GB" smtClean="0"/>
               <a:pPr/>
-              <a:t>24 July, 2023</a:t>
+              <a:t>9 August, 2023</a:t>
             </a:fld>
             <a:r>
               <a:rPr lang="en-GB"/>
@@ -19877,7 +19878,7 @@
             <a:fld id="{20CF0657-954C-457B-AB6C-2444DAE1F514}" type="datetime3">
               <a:rPr lang="en-GB" smtClean="0"/>
               <a:pPr/>
-              <a:t>24 July, 2023</a:t>
+              <a:t>9 August, 2023</a:t>
             </a:fld>
             <a:r>
               <a:rPr lang="en-GB"/>
@@ -21892,7 +21893,7 @@
         </p:nvSpPr>
         <p:spPr bwMode="auto">
           <a:xfrm>
-            <a:off x="6096000" y="2280586"/>
+            <a:off x="6096000" y="1631727"/>
             <a:ext cx="213200" cy="184666"/>
           </a:xfrm>
           <a:prstGeom prst="rect">
@@ -21966,668 +21967,7 @@
         </p:nvCxnSpPr>
         <p:spPr>
           <a:xfrm>
-            <a:off x="6959888" y="2064586"/>
-            <a:ext cx="720496" cy="0"/>
-          </a:xfrm>
-          <a:prstGeom prst="straightConnector1">
-            <a:avLst/>
-          </a:prstGeom>
-          <a:ln>
-            <a:tailEnd type="triangle"/>
-          </a:ln>
-        </p:spPr>
-        <p:style>
-          <a:lnRef idx="1">
-            <a:schemeClr val="dk1"/>
-          </a:lnRef>
-          <a:fillRef idx="0">
-            <a:schemeClr val="dk1"/>
-          </a:fillRef>
-          <a:effectRef idx="0">
-            <a:schemeClr val="dk1"/>
-          </a:effectRef>
-          <a:fontRef idx="minor">
-            <a:schemeClr val="tx1"/>
-          </a:fontRef>
-        </p:style>
-      </p:cxnSp>
-      <p:sp>
-        <p:nvSpPr>
-          <p:cNvPr id="41" name="TextBox 40">
-            <a:extLst>
-              <a:ext uri="{FF2B5EF4-FFF2-40B4-BE49-F238E27FC236}">
-                <a16:creationId xmlns:a16="http://schemas.microsoft.com/office/drawing/2014/main" id="{EEE3778E-D02B-37CD-BE51-0898D215975C}"/>
-              </a:ext>
-            </a:extLst>
-          </p:cNvPr>
-          <p:cNvSpPr txBox="1"/>
-          <p:nvPr/>
-        </p:nvSpPr>
-        <p:spPr bwMode="auto">
-          <a:xfrm>
-            <a:off x="7040187" y="1972253"/>
-            <a:ext cx="181140" cy="184666"/>
-          </a:xfrm>
-          <a:prstGeom prst="rect">
-            <a:avLst/>
-          </a:prstGeom>
-          <a:solidFill>
-            <a:schemeClr val="bg1"/>
-          </a:solidFill>
-          <a:ln w="9525">
-            <a:noFill/>
-            <a:miter lim="800000"/>
-            <a:headEnd/>
-            <a:tailEnd/>
-          </a:ln>
-          <a:effectLst/>
-        </p:spPr>
-        <p:txBody>
-          <a:bodyPr wrap="none" lIns="0" tIns="0" rIns="0" bIns="0" rtlCol="0" anchor="t" anchorCtr="0">
-            <a:spAutoFit/>
-          </a:bodyPr>
-          <a:lstStyle/>
-          <a:p>
-            <a:pPr marR="0" algn="l" defTabSz="576000" eaLnBrk="0" fontAlgn="auto" latinLnBrk="0" hangingPunct="0">
-              <a:spcBef>
-                <a:spcPts val="0"/>
-              </a:spcBef>
-              <a:spcAft>
-                <a:spcPts val="0"/>
-              </a:spcAft>
-              <a:buClr>
-                <a:schemeClr val="tx2"/>
-              </a:buClr>
-              <a:buSzTx/>
-              <a:tabLst/>
-            </a:pPr>
-            <a:r>
-              <a:rPr lang="en-GB" sz="1200" kern="0" baseline="0" dirty="0">
-                <a:solidFill>
-                  <a:srgbClr val="FF0000"/>
-                </a:solidFill>
-                <a:latin typeface="Calibri" panose="020F0502020204030204" pitchFamily="34" charset="0"/>
-                <a:cs typeface="Calibri" panose="020F0502020204030204" pitchFamily="34" charset="0"/>
-              </a:rPr>
-              <a:t>No</a:t>
-            </a:r>
-            <a:endParaRPr lang="en-GB" sz="1600" kern="0" baseline="0" dirty="0">
-              <a:solidFill>
-                <a:srgbClr val="FF0000"/>
-              </a:solidFill>
-              <a:latin typeface="Calibri" panose="020F0502020204030204" pitchFamily="34" charset="0"/>
-              <a:cs typeface="Calibri" panose="020F0502020204030204" pitchFamily="34" charset="0"/>
-            </a:endParaRPr>
-          </a:p>
-        </p:txBody>
-      </p:sp>
-      <p:sp>
-        <p:nvSpPr>
-          <p:cNvPr id="3" name="Title 2">
-            <a:extLst>
-              <a:ext uri="{FF2B5EF4-FFF2-40B4-BE49-F238E27FC236}">
-                <a16:creationId xmlns:a16="http://schemas.microsoft.com/office/drawing/2014/main" id="{4281126E-6757-90CE-56A9-3B3BE534AA9B}"/>
-              </a:ext>
-            </a:extLst>
-          </p:cNvPr>
-          <p:cNvSpPr>
-            <a:spLocks noGrp="1"/>
-          </p:cNvSpPr>
-          <p:nvPr>
-            <p:ph type="title"/>
-          </p:nvPr>
-        </p:nvSpPr>
-        <p:spPr/>
-        <p:txBody>
-          <a:bodyPr/>
-          <a:lstStyle/>
-          <a:p>
-            <a:r>
-              <a:rPr lang="en-US" sz="3200" dirty="0">
-                <a:latin typeface="Calibri" panose="020F0502020204030204" pitchFamily="34" charset="0"/>
-                <a:cs typeface="Calibri" panose="020F0502020204030204" pitchFamily="34" charset="0"/>
-              </a:rPr>
-              <a:t>SOP for log collecting – issue report flow </a:t>
-            </a:r>
-            <a:endParaRPr lang="en-GB" sz="3200" dirty="0">
-              <a:latin typeface="Calibri" panose="020F0502020204030204" pitchFamily="34" charset="0"/>
-              <a:cs typeface="Calibri" panose="020F0502020204030204" pitchFamily="34" charset="0"/>
-            </a:endParaRPr>
-          </a:p>
-        </p:txBody>
-      </p:sp>
-      <p:sp>
-        <p:nvSpPr>
-          <p:cNvPr id="4" name="Footer Placeholder 3">
-            <a:extLst>
-              <a:ext uri="{FF2B5EF4-FFF2-40B4-BE49-F238E27FC236}">
-                <a16:creationId xmlns:a16="http://schemas.microsoft.com/office/drawing/2014/main" id="{0312F4E3-32AD-DA55-1A4A-815B1F644D43}"/>
-              </a:ext>
-            </a:extLst>
-          </p:cNvPr>
-          <p:cNvSpPr>
-            <a:spLocks noGrp="1"/>
-          </p:cNvSpPr>
-          <p:nvPr>
-            <p:ph type="ftr" sz="quarter" idx="15"/>
-          </p:nvPr>
-        </p:nvSpPr>
-        <p:spPr/>
-        <p:txBody>
-          <a:bodyPr/>
-          <a:lstStyle/>
-          <a:p>
-            <a:endParaRPr lang="en-US" dirty="0">
-              <a:latin typeface="Calibri" panose="020F0502020204030204" pitchFamily="34" charset="0"/>
-              <a:cs typeface="Calibri" panose="020F0502020204030204" pitchFamily="34" charset="0"/>
-            </a:endParaRPr>
-          </a:p>
-        </p:txBody>
-      </p:sp>
-      <p:sp>
-        <p:nvSpPr>
-          <p:cNvPr id="5" name="Slide Number Placeholder 4">
-            <a:extLst>
-              <a:ext uri="{FF2B5EF4-FFF2-40B4-BE49-F238E27FC236}">
-                <a16:creationId xmlns:a16="http://schemas.microsoft.com/office/drawing/2014/main" id="{5523256E-932F-EFAB-7038-27F280525253}"/>
-              </a:ext>
-            </a:extLst>
-          </p:cNvPr>
-          <p:cNvSpPr>
-            <a:spLocks noGrp="1"/>
-          </p:cNvSpPr>
-          <p:nvPr>
-            <p:ph type="sldNum" sz="quarter" idx="16"/>
-          </p:nvPr>
-        </p:nvSpPr>
-        <p:spPr/>
-        <p:txBody>
-          <a:bodyPr/>
-          <a:lstStyle/>
-          <a:p>
-            <a:r>
-              <a:rPr lang="en-US">
-                <a:latin typeface="Calibri" panose="020F0502020204030204" pitchFamily="34" charset="0"/>
-                <a:cs typeface="Calibri" panose="020F0502020204030204" pitchFamily="34" charset="0"/>
-              </a:rPr>
-              <a:t> </a:t>
-            </a:r>
-            <a:endParaRPr lang="en-US" dirty="0">
-              <a:latin typeface="Calibri" panose="020F0502020204030204" pitchFamily="34" charset="0"/>
-              <a:cs typeface="Calibri" panose="020F0502020204030204" pitchFamily="34" charset="0"/>
-            </a:endParaRPr>
-          </a:p>
-        </p:txBody>
-      </p:sp>
-      <p:sp>
-        <p:nvSpPr>
-          <p:cNvPr id="2" name="Flowchart: Predefined Process 1">
-            <a:extLst>
-              <a:ext uri="{FF2B5EF4-FFF2-40B4-BE49-F238E27FC236}">
-                <a16:creationId xmlns:a16="http://schemas.microsoft.com/office/drawing/2014/main" id="{CEF85EF5-2447-4CE9-3DED-4A719C00AD2F}"/>
-              </a:ext>
-            </a:extLst>
-          </p:cNvPr>
-          <p:cNvSpPr/>
-          <p:nvPr/>
-        </p:nvSpPr>
-        <p:spPr bwMode="auto">
-          <a:xfrm>
-            <a:off x="2351584" y="1196752"/>
-            <a:ext cx="1872000" cy="432000"/>
-          </a:xfrm>
-          <a:prstGeom prst="flowChartPredefinedProcess">
-            <a:avLst/>
-          </a:prstGeom>
-          <a:solidFill>
-            <a:srgbClr val="DCD5D7"/>
-          </a:solidFill>
-          <a:ln w="9525">
-            <a:solidFill>
-              <a:schemeClr val="tx1"/>
-            </a:solidFill>
-            <a:miter lim="800000"/>
-            <a:headEnd/>
-            <a:tailEnd/>
-          </a:ln>
-        </p:spPr>
-        <p:txBody>
-          <a:bodyPr wrap="none" lIns="72000" tIns="72000" rIns="72000" bIns="72000" rtlCol="0" anchor="ctr" anchorCtr="0"/>
-          <a:lstStyle/>
-          <a:p>
-            <a:pPr algn="ctr" defTabSz="576000" eaLnBrk="0" hangingPunct="0"/>
-            <a:r>
-              <a:rPr lang="en-GB" baseline="0" dirty="0">
-                <a:latin typeface="Calibri" panose="020F0502020204030204" pitchFamily="34" charset="0"/>
-                <a:cs typeface="Calibri" panose="020F0502020204030204" pitchFamily="34" charset="0"/>
-              </a:rPr>
-              <a:t>Start</a:t>
-            </a:r>
-          </a:p>
-        </p:txBody>
-      </p:sp>
-      <p:sp>
-        <p:nvSpPr>
-          <p:cNvPr id="6" name="Rectangle 5">
-            <a:extLst>
-              <a:ext uri="{FF2B5EF4-FFF2-40B4-BE49-F238E27FC236}">
-                <a16:creationId xmlns:a16="http://schemas.microsoft.com/office/drawing/2014/main" id="{449C05F1-8264-537F-8A64-B52315767EC3}"/>
-              </a:ext>
-            </a:extLst>
-          </p:cNvPr>
-          <p:cNvSpPr/>
-          <p:nvPr/>
-        </p:nvSpPr>
-        <p:spPr bwMode="auto">
-          <a:xfrm>
-            <a:off x="5087888" y="1196752"/>
-            <a:ext cx="1872000" cy="432000"/>
-          </a:xfrm>
-          <a:prstGeom prst="rect">
-            <a:avLst/>
-          </a:prstGeom>
-          <a:noFill/>
-          <a:ln w="12700">
-            <a:solidFill>
-              <a:schemeClr val="tx1"/>
-            </a:solidFill>
-            <a:miter lim="800000"/>
-            <a:headEnd/>
-            <a:tailEnd/>
-          </a:ln>
-        </p:spPr>
-        <p:txBody>
-          <a:bodyPr wrap="none" lIns="72000" tIns="72000" rIns="72000" bIns="72000" rtlCol="0" anchor="ctr" anchorCtr="0"/>
-          <a:lstStyle/>
-          <a:p>
-            <a:pPr algn="ctr" defTabSz="576000" eaLnBrk="0" hangingPunct="0"/>
-            <a:r>
-              <a:rPr lang="en-GB" dirty="0">
-                <a:latin typeface="Calibri" panose="020F0502020204030204" pitchFamily="34" charset="0"/>
-                <a:cs typeface="Calibri" panose="020F0502020204030204" pitchFamily="34" charset="0"/>
-              </a:rPr>
-              <a:t>Collect issue</a:t>
-            </a:r>
-          </a:p>
-          <a:p>
-            <a:pPr algn="ctr" defTabSz="576000" eaLnBrk="0" hangingPunct="0"/>
-            <a:r>
-              <a:rPr lang="en-GB" dirty="0">
-                <a:latin typeface="Calibri" panose="020F0502020204030204" pitchFamily="34" charset="0"/>
-                <a:cs typeface="Calibri" panose="020F0502020204030204" pitchFamily="34" charset="0"/>
-              </a:rPr>
-              <a:t>information</a:t>
-            </a:r>
-            <a:endParaRPr lang="en-GB" baseline="0" dirty="0">
-              <a:latin typeface="Calibri" panose="020F0502020204030204" pitchFamily="34" charset="0"/>
-              <a:cs typeface="Calibri" panose="020F0502020204030204" pitchFamily="34" charset="0"/>
-            </a:endParaRPr>
-          </a:p>
-        </p:txBody>
-      </p:sp>
-      <p:sp>
-        <p:nvSpPr>
-          <p:cNvPr id="7" name="Rectangle 6">
-            <a:extLst>
-              <a:ext uri="{FF2B5EF4-FFF2-40B4-BE49-F238E27FC236}">
-                <a16:creationId xmlns:a16="http://schemas.microsoft.com/office/drawing/2014/main" id="{F9CE4C56-9A4F-B720-196B-1ADACFF83136}"/>
-              </a:ext>
-            </a:extLst>
-          </p:cNvPr>
-          <p:cNvSpPr/>
-          <p:nvPr/>
-        </p:nvSpPr>
-        <p:spPr bwMode="auto">
-          <a:xfrm>
-            <a:off x="5087888" y="2500420"/>
-            <a:ext cx="1872000" cy="432000"/>
-          </a:xfrm>
-          <a:prstGeom prst="rect">
-            <a:avLst/>
-          </a:prstGeom>
-          <a:noFill/>
-          <a:ln w="12700">
-            <a:solidFill>
-              <a:schemeClr val="tx1"/>
-            </a:solidFill>
-            <a:miter lim="800000"/>
-            <a:headEnd/>
-            <a:tailEnd/>
-          </a:ln>
-        </p:spPr>
-        <p:txBody>
-          <a:bodyPr wrap="none" lIns="72000" tIns="72000" rIns="72000" bIns="72000" rtlCol="0" anchor="ctr" anchorCtr="0"/>
-          <a:lstStyle/>
-          <a:p>
-            <a:pPr algn="ctr" defTabSz="576000" eaLnBrk="0" hangingPunct="0"/>
-            <a:r>
-              <a:rPr lang="en-GB" baseline="0" dirty="0">
-                <a:latin typeface="Calibri" panose="020F0502020204030204" pitchFamily="34" charset="0"/>
-                <a:cs typeface="Calibri" panose="020F0502020204030204" pitchFamily="34" charset="0"/>
-              </a:rPr>
-              <a:t>Collect pass and </a:t>
-            </a:r>
-          </a:p>
-          <a:p>
-            <a:pPr algn="ctr" defTabSz="576000" eaLnBrk="0" hangingPunct="0"/>
-            <a:r>
-              <a:rPr lang="en-GB" baseline="0" dirty="0">
-                <a:latin typeface="Calibri" panose="020F0502020204030204" pitchFamily="34" charset="0"/>
-                <a:cs typeface="Calibri" panose="020F0502020204030204" pitchFamily="34" charset="0"/>
-              </a:rPr>
-              <a:t>fail cases logs</a:t>
-            </a:r>
-          </a:p>
-        </p:txBody>
-      </p:sp>
-      <p:sp>
-        <p:nvSpPr>
-          <p:cNvPr id="9" name="Rectangle 8">
-            <a:extLst>
-              <a:ext uri="{FF2B5EF4-FFF2-40B4-BE49-F238E27FC236}">
-                <a16:creationId xmlns:a16="http://schemas.microsoft.com/office/drawing/2014/main" id="{CE32A520-3563-F4F6-AC00-70DB9E75CC0D}"/>
-              </a:ext>
-            </a:extLst>
-          </p:cNvPr>
-          <p:cNvSpPr/>
-          <p:nvPr/>
-        </p:nvSpPr>
-        <p:spPr bwMode="auto">
-          <a:xfrm>
-            <a:off x="5087888" y="3145622"/>
-            <a:ext cx="1872000" cy="432000"/>
-          </a:xfrm>
-          <a:prstGeom prst="rect">
-            <a:avLst/>
-          </a:prstGeom>
-          <a:noFill/>
-          <a:ln w="12700">
-            <a:solidFill>
-              <a:schemeClr val="tx1"/>
-            </a:solidFill>
-            <a:miter lim="800000"/>
-            <a:headEnd/>
-            <a:tailEnd/>
-          </a:ln>
-        </p:spPr>
-        <p:txBody>
-          <a:bodyPr wrap="none" lIns="72000" tIns="72000" rIns="72000" bIns="72000" rtlCol="0" anchor="ctr" anchorCtr="0"/>
-          <a:lstStyle/>
-          <a:p>
-            <a:pPr algn="ctr" defTabSz="576000" eaLnBrk="0" hangingPunct="0"/>
-            <a:r>
-              <a:rPr lang="en-GB" baseline="0" dirty="0">
-                <a:latin typeface="Calibri" panose="020F0502020204030204" pitchFamily="34" charset="0"/>
-                <a:cs typeface="Calibri" panose="020F0502020204030204" pitchFamily="34" charset="0"/>
-              </a:rPr>
-              <a:t>Submit a MSD case</a:t>
-            </a:r>
-          </a:p>
-        </p:txBody>
-      </p:sp>
-      <p:sp>
-        <p:nvSpPr>
-          <p:cNvPr id="11" name="Rectangle 10">
-            <a:extLst>
-              <a:ext uri="{FF2B5EF4-FFF2-40B4-BE49-F238E27FC236}">
-                <a16:creationId xmlns:a16="http://schemas.microsoft.com/office/drawing/2014/main" id="{298836A3-BFF7-BA62-E5B7-E62AAA04EDCE}"/>
-              </a:ext>
-            </a:extLst>
-          </p:cNvPr>
-          <p:cNvSpPr/>
-          <p:nvPr/>
-        </p:nvSpPr>
-        <p:spPr bwMode="auto">
-          <a:xfrm>
-            <a:off x="5087888" y="3793694"/>
-            <a:ext cx="1872000" cy="432000"/>
-          </a:xfrm>
-          <a:prstGeom prst="rect">
-            <a:avLst/>
-          </a:prstGeom>
-          <a:noFill/>
-          <a:ln w="12700">
-            <a:solidFill>
-              <a:schemeClr val="tx1"/>
-            </a:solidFill>
-            <a:miter lim="800000"/>
-            <a:headEnd/>
-            <a:tailEnd/>
-          </a:ln>
-        </p:spPr>
-        <p:txBody>
-          <a:bodyPr wrap="none" lIns="72000" tIns="72000" rIns="72000" bIns="72000" rtlCol="0" anchor="ctr" anchorCtr="0"/>
-          <a:lstStyle/>
-          <a:p>
-            <a:pPr algn="ctr" defTabSz="576000" eaLnBrk="0" hangingPunct="0"/>
-            <a:r>
-              <a:rPr lang="en-GB" dirty="0">
-                <a:latin typeface="Calibri" panose="020F0502020204030204" pitchFamily="34" charset="0"/>
-                <a:cs typeface="Calibri" panose="020F0502020204030204" pitchFamily="34" charset="0"/>
-              </a:rPr>
-              <a:t>Trial solutions released</a:t>
-            </a:r>
-            <a:endParaRPr lang="en-GB" baseline="0" dirty="0">
-              <a:latin typeface="Calibri" panose="020F0502020204030204" pitchFamily="34" charset="0"/>
-              <a:cs typeface="Calibri" panose="020F0502020204030204" pitchFamily="34" charset="0"/>
-            </a:endParaRPr>
-          </a:p>
-        </p:txBody>
-      </p:sp>
-      <p:sp>
-        <p:nvSpPr>
-          <p:cNvPr id="13" name="Flowchart: Decision 12">
-            <a:extLst>
-              <a:ext uri="{FF2B5EF4-FFF2-40B4-BE49-F238E27FC236}">
-                <a16:creationId xmlns:a16="http://schemas.microsoft.com/office/drawing/2014/main" id="{5864F398-B2BE-6F3E-163F-601DA8C1BFAF}"/>
-              </a:ext>
-            </a:extLst>
-          </p:cNvPr>
-          <p:cNvSpPr/>
-          <p:nvPr/>
-        </p:nvSpPr>
-        <p:spPr bwMode="auto">
-          <a:xfrm>
-            <a:off x="5087888" y="4441766"/>
-            <a:ext cx="1872000" cy="432000"/>
-          </a:xfrm>
-          <a:prstGeom prst="flowChartDecision">
-            <a:avLst/>
-          </a:prstGeom>
-          <a:noFill/>
-          <a:ln w="12700">
-            <a:solidFill>
-              <a:schemeClr val="tx1"/>
-            </a:solidFill>
-            <a:miter lim="800000"/>
-            <a:headEnd/>
-            <a:tailEnd/>
-          </a:ln>
-        </p:spPr>
-        <p:txBody>
-          <a:bodyPr wrap="none" lIns="72000" tIns="72000" rIns="72000" bIns="72000" rtlCol="0" anchor="ctr" anchorCtr="0"/>
-          <a:lstStyle/>
-          <a:p>
-            <a:pPr algn="ctr" defTabSz="576000" eaLnBrk="0" hangingPunct="0"/>
-            <a:r>
-              <a:rPr lang="en-GB" baseline="0" dirty="0">
-                <a:latin typeface="Calibri" panose="020F0502020204030204" pitchFamily="34" charset="0"/>
-                <a:cs typeface="Calibri" panose="020F0502020204030204" pitchFamily="34" charset="0"/>
-              </a:rPr>
-              <a:t>Issue resolved?</a:t>
-            </a:r>
-          </a:p>
-        </p:txBody>
-      </p:sp>
-      <p:sp>
-        <p:nvSpPr>
-          <p:cNvPr id="15" name="Rectangle 14">
-            <a:extLst>
-              <a:ext uri="{FF2B5EF4-FFF2-40B4-BE49-F238E27FC236}">
-                <a16:creationId xmlns:a16="http://schemas.microsoft.com/office/drawing/2014/main" id="{B6006654-AFFD-C2B9-E0F6-38DE30E8A4B2}"/>
-              </a:ext>
-            </a:extLst>
-          </p:cNvPr>
-          <p:cNvSpPr/>
-          <p:nvPr/>
-        </p:nvSpPr>
-        <p:spPr bwMode="auto">
-          <a:xfrm>
-            <a:off x="5087888" y="5089838"/>
-            <a:ext cx="1872000" cy="432000"/>
-          </a:xfrm>
-          <a:prstGeom prst="rect">
-            <a:avLst/>
-          </a:prstGeom>
-          <a:noFill/>
-          <a:ln w="12700">
-            <a:solidFill>
-              <a:schemeClr val="tx1"/>
-            </a:solidFill>
-            <a:miter lim="800000"/>
-            <a:headEnd/>
-            <a:tailEnd/>
-          </a:ln>
-        </p:spPr>
-        <p:txBody>
-          <a:bodyPr wrap="none" lIns="72000" tIns="72000" rIns="72000" bIns="72000" rtlCol="0" anchor="ctr" anchorCtr="0"/>
-          <a:lstStyle/>
-          <a:p>
-            <a:pPr algn="ctr" defTabSz="576000" eaLnBrk="0" hangingPunct="0"/>
-            <a:r>
-              <a:rPr lang="en-GB" dirty="0">
-                <a:latin typeface="Calibri" panose="020F0502020204030204" pitchFamily="34" charset="0"/>
-                <a:cs typeface="Calibri" panose="020F0502020204030204" pitchFamily="34" charset="0"/>
-              </a:rPr>
-              <a:t>Confirmations from </a:t>
-            </a:r>
-          </a:p>
-          <a:p>
-            <a:pPr algn="ctr" defTabSz="576000" eaLnBrk="0" hangingPunct="0"/>
-            <a:r>
-              <a:rPr lang="en-GB" dirty="0">
-                <a:latin typeface="Calibri" panose="020F0502020204030204" pitchFamily="34" charset="0"/>
-                <a:cs typeface="Calibri" panose="020F0502020204030204" pitchFamily="34" charset="0"/>
-              </a:rPr>
-              <a:t>ODM/OEM</a:t>
-            </a:r>
-            <a:endParaRPr lang="en-GB" baseline="0" dirty="0">
-              <a:latin typeface="Calibri" panose="020F0502020204030204" pitchFamily="34" charset="0"/>
-              <a:cs typeface="Calibri" panose="020F0502020204030204" pitchFamily="34" charset="0"/>
-            </a:endParaRPr>
-          </a:p>
-        </p:txBody>
-      </p:sp>
-      <p:sp>
-        <p:nvSpPr>
-          <p:cNvPr id="17" name="Rectangle 16">
-            <a:extLst>
-              <a:ext uri="{FF2B5EF4-FFF2-40B4-BE49-F238E27FC236}">
-                <a16:creationId xmlns:a16="http://schemas.microsoft.com/office/drawing/2014/main" id="{14AAC021-6BD4-1ADE-C267-19BD11DEE219}"/>
-              </a:ext>
-            </a:extLst>
-          </p:cNvPr>
-          <p:cNvSpPr/>
-          <p:nvPr/>
-        </p:nvSpPr>
-        <p:spPr bwMode="auto">
-          <a:xfrm>
-            <a:off x="5087888" y="5737910"/>
-            <a:ext cx="1872000" cy="432000"/>
-          </a:xfrm>
-          <a:prstGeom prst="rect">
-            <a:avLst/>
-          </a:prstGeom>
-          <a:noFill/>
-          <a:ln w="12700">
-            <a:solidFill>
-              <a:schemeClr val="tx1"/>
-            </a:solidFill>
-            <a:miter lim="800000"/>
-            <a:headEnd/>
-            <a:tailEnd/>
-          </a:ln>
-        </p:spPr>
-        <p:txBody>
-          <a:bodyPr wrap="none" lIns="72000" tIns="72000" rIns="72000" bIns="72000" rtlCol="0" anchor="ctr" anchorCtr="0"/>
-          <a:lstStyle/>
-          <a:p>
-            <a:pPr algn="ctr" defTabSz="576000" eaLnBrk="0" hangingPunct="0"/>
-            <a:r>
-              <a:rPr lang="en-GB" baseline="0" dirty="0">
-                <a:latin typeface="Calibri" panose="020F0502020204030204" pitchFamily="34" charset="0"/>
-                <a:cs typeface="Calibri" panose="020F0502020204030204" pitchFamily="34" charset="0"/>
-              </a:rPr>
-              <a:t>Official release</a:t>
-            </a:r>
-          </a:p>
-        </p:txBody>
-      </p:sp>
-      <p:sp>
-        <p:nvSpPr>
-          <p:cNvPr id="102" name="Flowchart: Predefined Process 101">
-            <a:extLst>
-              <a:ext uri="{FF2B5EF4-FFF2-40B4-BE49-F238E27FC236}">
-                <a16:creationId xmlns:a16="http://schemas.microsoft.com/office/drawing/2014/main" id="{757F0786-9DEC-7A8B-D90B-449B25A692D3}"/>
-              </a:ext>
-            </a:extLst>
-          </p:cNvPr>
-          <p:cNvSpPr/>
-          <p:nvPr/>
-        </p:nvSpPr>
-        <p:spPr bwMode="auto">
-          <a:xfrm>
-            <a:off x="7680384" y="5737910"/>
-            <a:ext cx="1872000" cy="432000"/>
-          </a:xfrm>
-          <a:prstGeom prst="flowChartPredefinedProcess">
-            <a:avLst/>
-          </a:prstGeom>
-          <a:solidFill>
-            <a:srgbClr val="DCD5D7"/>
-          </a:solidFill>
-          <a:ln w="9525">
-            <a:solidFill>
-              <a:schemeClr val="tx1"/>
-            </a:solidFill>
-            <a:miter lim="800000"/>
-            <a:headEnd/>
-            <a:tailEnd/>
-          </a:ln>
-        </p:spPr>
-        <p:txBody>
-          <a:bodyPr wrap="none" lIns="72000" tIns="72000" rIns="72000" bIns="72000" rtlCol="0" anchor="ctr" anchorCtr="0"/>
-          <a:lstStyle/>
-          <a:p>
-            <a:pPr algn="ctr" defTabSz="576000" eaLnBrk="0" hangingPunct="0"/>
-            <a:r>
-              <a:rPr lang="en-GB" baseline="0" dirty="0">
-                <a:latin typeface="Calibri" panose="020F0502020204030204" pitchFamily="34" charset="0"/>
-                <a:cs typeface="Calibri" panose="020F0502020204030204" pitchFamily="34" charset="0"/>
-              </a:rPr>
-              <a:t>Case closed</a:t>
-            </a:r>
-          </a:p>
-        </p:txBody>
-      </p:sp>
-      <p:cxnSp>
-        <p:nvCxnSpPr>
-          <p:cNvPr id="209" name="Straight Arrow Connector 208">
-            <a:extLst>
-              <a:ext uri="{FF2B5EF4-FFF2-40B4-BE49-F238E27FC236}">
-                <a16:creationId xmlns:a16="http://schemas.microsoft.com/office/drawing/2014/main" id="{6725CF7A-79E5-E694-FDE3-4F3E576DDF09}"/>
-              </a:ext>
-            </a:extLst>
-          </p:cNvPr>
-          <p:cNvCxnSpPr>
-            <a:stCxn id="2" idx="3"/>
-            <a:endCxn id="6" idx="1"/>
-          </p:cNvCxnSpPr>
-          <p:nvPr/>
-        </p:nvCxnSpPr>
-        <p:spPr>
-          <a:xfrm>
-            <a:off x="4223584" y="1412752"/>
+            <a:off x="6959888" y="1412800"/>
             <a:ext cx="864304" cy="0"/>
           </a:xfrm>
           <a:prstGeom prst="straightConnector1">
@@ -22654,47 +21994,68 @@
       </p:cxnSp>
       <p:sp>
         <p:nvSpPr>
-          <p:cNvPr id="8" name="Flowchart: Decision 7">
-            <a:extLst>
-              <a:ext uri="{FF2B5EF4-FFF2-40B4-BE49-F238E27FC236}">
-                <a16:creationId xmlns:a16="http://schemas.microsoft.com/office/drawing/2014/main" id="{8A51A39F-C759-FF5A-7D89-EF8F5D30217E}"/>
-              </a:ext>
-            </a:extLst>
-          </p:cNvPr>
-          <p:cNvSpPr/>
+          <p:cNvPr id="41" name="TextBox 40">
+            <a:extLst>
+              <a:ext uri="{FF2B5EF4-FFF2-40B4-BE49-F238E27FC236}">
+                <a16:creationId xmlns:a16="http://schemas.microsoft.com/office/drawing/2014/main" id="{EEE3778E-D02B-37CD-BE51-0898D215975C}"/>
+              </a:ext>
+            </a:extLst>
+          </p:cNvPr>
+          <p:cNvSpPr txBox="1"/>
           <p:nvPr/>
         </p:nvSpPr>
         <p:spPr bwMode="auto">
           <a:xfrm>
-            <a:off x="5087888" y="1848586"/>
-            <a:ext cx="1872000" cy="432000"/>
+            <a:off x="7040187" y="1320467"/>
+            <a:ext cx="181140" cy="184666"/>
           </a:xfrm>
-          <a:prstGeom prst="flowChartDecision">
+          <a:prstGeom prst="rect">
             <a:avLst/>
           </a:prstGeom>
-          <a:noFill/>
-          <a:ln w="12700">
-            <a:solidFill>
-              <a:schemeClr val="tx1"/>
-            </a:solidFill>
+          <a:solidFill>
+            <a:schemeClr val="bg1"/>
+          </a:solidFill>
+          <a:ln w="9525">
+            <a:noFill/>
             <a:miter lim="800000"/>
             <a:headEnd/>
             <a:tailEnd/>
           </a:ln>
+          <a:effectLst/>
         </p:spPr>
         <p:txBody>
-          <a:bodyPr wrap="none" lIns="72000" tIns="72000" rIns="72000" bIns="72000" rtlCol="0" anchor="ctr" anchorCtr="0"/>
+          <a:bodyPr wrap="none" lIns="0" tIns="0" rIns="0" bIns="0" rtlCol="0" anchor="t" anchorCtr="0">
+            <a:spAutoFit/>
+          </a:bodyPr>
           <a:lstStyle/>
           <a:p>
-            <a:pPr algn="ctr" defTabSz="576000" eaLnBrk="0" hangingPunct="0"/>
-            <a:r>
-              <a:rPr lang="en-GB" dirty="0">
+            <a:pPr marR="0" algn="l" defTabSz="576000" eaLnBrk="0" fontAlgn="auto" latinLnBrk="0" hangingPunct="0">
+              <a:spcBef>
+                <a:spcPts val="0"/>
+              </a:spcBef>
+              <a:spcAft>
+                <a:spcPts val="0"/>
+              </a:spcAft>
+              <a:buClr>
+                <a:schemeClr val="tx2"/>
+              </a:buClr>
+              <a:buSzTx/>
+              <a:tabLst/>
+            </a:pPr>
+            <a:r>
+              <a:rPr lang="en-GB" sz="1200" kern="0" baseline="0" dirty="0">
+                <a:solidFill>
+                  <a:srgbClr val="FF0000"/>
+                </a:solidFill>
                 <a:latin typeface="Calibri" panose="020F0502020204030204" pitchFamily="34" charset="0"/>
                 <a:cs typeface="Calibri" panose="020F0502020204030204" pitchFamily="34" charset="0"/>
               </a:rPr>
-              <a:t>IFX issues?</a:t>
-            </a:r>
-            <a:endParaRPr lang="en-GB" baseline="0" dirty="0">
+              <a:t>No</a:t>
+            </a:r>
+            <a:endParaRPr lang="en-GB" sz="1600" kern="0" baseline="0" dirty="0">
+              <a:solidFill>
+                <a:srgbClr val="FF0000"/>
+              </a:solidFill>
               <a:latin typeface="Calibri" panose="020F0502020204030204" pitchFamily="34" charset="0"/>
               <a:cs typeface="Calibri" panose="020F0502020204030204" pitchFamily="34" charset="0"/>
             </a:endParaRPr>
@@ -22703,10 +22064,108 @@
       </p:sp>
       <p:sp>
         <p:nvSpPr>
-          <p:cNvPr id="18" name="Flowchart: Predefined Process 17">
-            <a:extLst>
-              <a:ext uri="{FF2B5EF4-FFF2-40B4-BE49-F238E27FC236}">
-                <a16:creationId xmlns:a16="http://schemas.microsoft.com/office/drawing/2014/main" id="{346E4798-D3A5-6467-F08E-0ED972A68EF1}"/>
+          <p:cNvPr id="3" name="Title 2">
+            <a:extLst>
+              <a:ext uri="{FF2B5EF4-FFF2-40B4-BE49-F238E27FC236}">
+                <a16:creationId xmlns:a16="http://schemas.microsoft.com/office/drawing/2014/main" id="{4281126E-6757-90CE-56A9-3B3BE534AA9B}"/>
+              </a:ext>
+            </a:extLst>
+          </p:cNvPr>
+          <p:cNvSpPr>
+            <a:spLocks noGrp="1"/>
+          </p:cNvSpPr>
+          <p:nvPr>
+            <p:ph type="title"/>
+          </p:nvPr>
+        </p:nvSpPr>
+        <p:spPr/>
+        <p:txBody>
+          <a:bodyPr/>
+          <a:lstStyle/>
+          <a:p>
+            <a:r>
+              <a:rPr lang="en-US" sz="3200" dirty="0">
+                <a:latin typeface="Calibri" panose="020F0502020204030204" pitchFamily="34" charset="0"/>
+                <a:cs typeface="Calibri" panose="020F0502020204030204" pitchFamily="34" charset="0"/>
+              </a:rPr>
+              <a:t>SOP for log collecting – issue report flow </a:t>
+            </a:r>
+            <a:endParaRPr lang="en-GB" sz="3200" dirty="0">
+              <a:latin typeface="Calibri" panose="020F0502020204030204" pitchFamily="34" charset="0"/>
+              <a:cs typeface="Calibri" panose="020F0502020204030204" pitchFamily="34" charset="0"/>
+            </a:endParaRPr>
+          </a:p>
+        </p:txBody>
+      </p:sp>
+      <p:sp>
+        <p:nvSpPr>
+          <p:cNvPr id="4" name="Footer Placeholder 3">
+            <a:extLst>
+              <a:ext uri="{FF2B5EF4-FFF2-40B4-BE49-F238E27FC236}">
+                <a16:creationId xmlns:a16="http://schemas.microsoft.com/office/drawing/2014/main" id="{0312F4E3-32AD-DA55-1A4A-815B1F644D43}"/>
+              </a:ext>
+            </a:extLst>
+          </p:cNvPr>
+          <p:cNvSpPr>
+            <a:spLocks noGrp="1"/>
+          </p:cNvSpPr>
+          <p:nvPr>
+            <p:ph type="ftr" sz="quarter" idx="15"/>
+          </p:nvPr>
+        </p:nvSpPr>
+        <p:spPr/>
+        <p:txBody>
+          <a:bodyPr/>
+          <a:lstStyle/>
+          <a:p>
+            <a:endParaRPr lang="en-US" dirty="0">
+              <a:latin typeface="Calibri" panose="020F0502020204030204" pitchFamily="34" charset="0"/>
+              <a:cs typeface="Calibri" panose="020F0502020204030204" pitchFamily="34" charset="0"/>
+            </a:endParaRPr>
+          </a:p>
+        </p:txBody>
+      </p:sp>
+      <p:sp>
+        <p:nvSpPr>
+          <p:cNvPr id="5" name="Slide Number Placeholder 4">
+            <a:extLst>
+              <a:ext uri="{FF2B5EF4-FFF2-40B4-BE49-F238E27FC236}">
+                <a16:creationId xmlns:a16="http://schemas.microsoft.com/office/drawing/2014/main" id="{5523256E-932F-EFAB-7038-27F280525253}"/>
+              </a:ext>
+            </a:extLst>
+          </p:cNvPr>
+          <p:cNvSpPr>
+            <a:spLocks noGrp="1"/>
+          </p:cNvSpPr>
+          <p:nvPr>
+            <p:ph type="sldNum" sz="quarter" idx="16"/>
+          </p:nvPr>
+        </p:nvSpPr>
+        <p:spPr/>
+        <p:txBody>
+          <a:bodyPr/>
+          <a:lstStyle/>
+          <a:p>
+            <a:r>
+              <a:rPr lang="en-US">
+                <a:latin typeface="Calibri" panose="020F0502020204030204" pitchFamily="34" charset="0"/>
+                <a:cs typeface="Calibri" panose="020F0502020204030204" pitchFamily="34" charset="0"/>
+              </a:rPr>
+              <a:t> </a:t>
+            </a:r>
+            <a:endParaRPr lang="en-US" dirty="0">
+              <a:latin typeface="Calibri" panose="020F0502020204030204" pitchFamily="34" charset="0"/>
+              <a:cs typeface="Calibri" panose="020F0502020204030204" pitchFamily="34" charset="0"/>
+            </a:endParaRPr>
+          </a:p>
+        </p:txBody>
+      </p:sp>
+      <p:sp>
+        <p:nvSpPr>
+          <p:cNvPr id="2" name="Flowchart: Predefined Process 1">
+            <a:extLst>
+              <a:ext uri="{FF2B5EF4-FFF2-40B4-BE49-F238E27FC236}">
+                <a16:creationId xmlns:a16="http://schemas.microsoft.com/office/drawing/2014/main" id="{CEF85EF5-2447-4CE9-3DED-4A719C00AD2F}"/>
               </a:ext>
             </a:extLst>
           </p:cNvPr>
@@ -22715,7 +22174,7 @@
         </p:nvSpPr>
         <p:spPr bwMode="auto">
           <a:xfrm>
-            <a:off x="7680384" y="1848586"/>
+            <a:off x="2351584" y="1196752"/>
             <a:ext cx="1872000" cy="432000"/>
           </a:xfrm>
           <a:prstGeom prst="flowChartPredefinedProcess">
@@ -22743,6 +22202,502 @@
                 <a:latin typeface="Calibri" panose="020F0502020204030204" pitchFamily="34" charset="0"/>
                 <a:cs typeface="Calibri" panose="020F0502020204030204" pitchFamily="34" charset="0"/>
               </a:rPr>
+              <a:t>Start</a:t>
+            </a:r>
+          </a:p>
+        </p:txBody>
+      </p:sp>
+      <p:sp>
+        <p:nvSpPr>
+          <p:cNvPr id="6" name="Rectangle 5">
+            <a:extLst>
+              <a:ext uri="{FF2B5EF4-FFF2-40B4-BE49-F238E27FC236}">
+                <a16:creationId xmlns:a16="http://schemas.microsoft.com/office/drawing/2014/main" id="{449C05F1-8264-537F-8A64-B52315767EC3}"/>
+              </a:ext>
+            </a:extLst>
+          </p:cNvPr>
+          <p:cNvSpPr/>
+          <p:nvPr/>
+        </p:nvSpPr>
+        <p:spPr bwMode="auto">
+          <a:xfrm>
+            <a:off x="5087888" y="1839204"/>
+            <a:ext cx="1872000" cy="432000"/>
+          </a:xfrm>
+          <a:prstGeom prst="rect">
+            <a:avLst/>
+          </a:prstGeom>
+          <a:noFill/>
+          <a:ln w="12700">
+            <a:solidFill>
+              <a:schemeClr val="tx1"/>
+            </a:solidFill>
+            <a:miter lim="800000"/>
+            <a:headEnd/>
+            <a:tailEnd/>
+          </a:ln>
+        </p:spPr>
+        <p:txBody>
+          <a:bodyPr wrap="none" lIns="72000" tIns="72000" rIns="72000" bIns="72000" rtlCol="0" anchor="ctr" anchorCtr="0"/>
+          <a:lstStyle/>
+          <a:p>
+            <a:pPr algn="ctr" defTabSz="576000" eaLnBrk="0" hangingPunct="0"/>
+            <a:r>
+              <a:rPr lang="en-GB" dirty="0">
+                <a:latin typeface="Calibri" panose="020F0502020204030204" pitchFamily="34" charset="0"/>
+                <a:cs typeface="Calibri" panose="020F0502020204030204" pitchFamily="34" charset="0"/>
+              </a:rPr>
+              <a:t>Fill up </a:t>
+            </a:r>
+          </a:p>
+          <a:p>
+            <a:pPr algn="ctr" defTabSz="576000" eaLnBrk="0" hangingPunct="0"/>
+            <a:r>
+              <a:rPr lang="en-GB" dirty="0">
+                <a:latin typeface="Calibri" panose="020F0502020204030204" pitchFamily="34" charset="0"/>
+                <a:cs typeface="Calibri" panose="020F0502020204030204" pitchFamily="34" charset="0"/>
+              </a:rPr>
+              <a:t>issue tracker form</a:t>
+            </a:r>
+          </a:p>
+        </p:txBody>
+      </p:sp>
+      <p:sp>
+        <p:nvSpPr>
+          <p:cNvPr id="7" name="Rectangle 6">
+            <a:extLst>
+              <a:ext uri="{FF2B5EF4-FFF2-40B4-BE49-F238E27FC236}">
+                <a16:creationId xmlns:a16="http://schemas.microsoft.com/office/drawing/2014/main" id="{F9CE4C56-9A4F-B720-196B-1ADACFF83136}"/>
+              </a:ext>
+            </a:extLst>
+          </p:cNvPr>
+          <p:cNvSpPr/>
+          <p:nvPr/>
+        </p:nvSpPr>
+        <p:spPr bwMode="auto">
+          <a:xfrm>
+            <a:off x="5087888" y="2500420"/>
+            <a:ext cx="1872000" cy="432000"/>
+          </a:xfrm>
+          <a:prstGeom prst="rect">
+            <a:avLst/>
+          </a:prstGeom>
+          <a:noFill/>
+          <a:ln w="12700">
+            <a:solidFill>
+              <a:schemeClr val="tx1"/>
+            </a:solidFill>
+            <a:miter lim="800000"/>
+            <a:headEnd/>
+            <a:tailEnd/>
+          </a:ln>
+        </p:spPr>
+        <p:txBody>
+          <a:bodyPr wrap="none" lIns="72000" tIns="72000" rIns="72000" bIns="72000" rtlCol="0" anchor="ctr" anchorCtr="0"/>
+          <a:lstStyle/>
+          <a:p>
+            <a:pPr algn="ctr" defTabSz="576000" eaLnBrk="0" hangingPunct="0"/>
+            <a:r>
+              <a:rPr lang="en-GB" baseline="0" dirty="0">
+                <a:latin typeface="Calibri" panose="020F0502020204030204" pitchFamily="34" charset="0"/>
+                <a:cs typeface="Calibri" panose="020F0502020204030204" pitchFamily="34" charset="0"/>
+              </a:rPr>
+              <a:t>Collect pass and </a:t>
+            </a:r>
+          </a:p>
+          <a:p>
+            <a:pPr algn="ctr" defTabSz="576000" eaLnBrk="0" hangingPunct="0"/>
+            <a:r>
+              <a:rPr lang="en-GB" baseline="0" dirty="0">
+                <a:latin typeface="Calibri" panose="020F0502020204030204" pitchFamily="34" charset="0"/>
+                <a:cs typeface="Calibri" panose="020F0502020204030204" pitchFamily="34" charset="0"/>
+              </a:rPr>
+              <a:t>fail cases logs</a:t>
+            </a:r>
+          </a:p>
+        </p:txBody>
+      </p:sp>
+      <p:sp>
+        <p:nvSpPr>
+          <p:cNvPr id="9" name="Rectangle 8">
+            <a:extLst>
+              <a:ext uri="{FF2B5EF4-FFF2-40B4-BE49-F238E27FC236}">
+                <a16:creationId xmlns:a16="http://schemas.microsoft.com/office/drawing/2014/main" id="{CE32A520-3563-F4F6-AC00-70DB9E75CC0D}"/>
+              </a:ext>
+            </a:extLst>
+          </p:cNvPr>
+          <p:cNvSpPr/>
+          <p:nvPr/>
+        </p:nvSpPr>
+        <p:spPr bwMode="auto">
+          <a:xfrm>
+            <a:off x="2351584" y="3148420"/>
+            <a:ext cx="1872000" cy="432000"/>
+          </a:xfrm>
+          <a:prstGeom prst="rect">
+            <a:avLst/>
+          </a:prstGeom>
+          <a:noFill/>
+          <a:ln w="12700">
+            <a:solidFill>
+              <a:schemeClr val="tx1"/>
+            </a:solidFill>
+            <a:miter lim="800000"/>
+            <a:headEnd/>
+            <a:tailEnd/>
+          </a:ln>
+        </p:spPr>
+        <p:txBody>
+          <a:bodyPr wrap="none" lIns="72000" tIns="72000" rIns="72000" bIns="72000" rtlCol="0" anchor="ctr" anchorCtr="0"/>
+          <a:lstStyle/>
+          <a:p>
+            <a:pPr algn="ctr" defTabSz="576000" eaLnBrk="0" hangingPunct="0"/>
+            <a:r>
+              <a:rPr lang="en-GB" baseline="0" dirty="0">
+                <a:latin typeface="Calibri" panose="020F0502020204030204" pitchFamily="34" charset="0"/>
+                <a:cs typeface="Calibri" panose="020F0502020204030204" pitchFamily="34" charset="0"/>
+              </a:rPr>
+              <a:t>Submit an MSD case</a:t>
+            </a:r>
+          </a:p>
+        </p:txBody>
+      </p:sp>
+      <p:sp>
+        <p:nvSpPr>
+          <p:cNvPr id="11" name="Rectangle 10">
+            <a:extLst>
+              <a:ext uri="{FF2B5EF4-FFF2-40B4-BE49-F238E27FC236}">
+                <a16:creationId xmlns:a16="http://schemas.microsoft.com/office/drawing/2014/main" id="{298836A3-BFF7-BA62-E5B7-E62AAA04EDCE}"/>
+              </a:ext>
+            </a:extLst>
+          </p:cNvPr>
+          <p:cNvSpPr/>
+          <p:nvPr/>
+        </p:nvSpPr>
+        <p:spPr bwMode="auto">
+          <a:xfrm>
+            <a:off x="5087888" y="3793694"/>
+            <a:ext cx="1872000" cy="432000"/>
+          </a:xfrm>
+          <a:prstGeom prst="rect">
+            <a:avLst/>
+          </a:prstGeom>
+          <a:noFill/>
+          <a:ln w="12700">
+            <a:solidFill>
+              <a:schemeClr val="tx1"/>
+            </a:solidFill>
+            <a:miter lim="800000"/>
+            <a:headEnd/>
+            <a:tailEnd/>
+          </a:ln>
+        </p:spPr>
+        <p:txBody>
+          <a:bodyPr wrap="none" lIns="72000" tIns="72000" rIns="72000" bIns="72000" rtlCol="0" anchor="ctr" anchorCtr="0"/>
+          <a:lstStyle/>
+          <a:p>
+            <a:pPr algn="ctr" defTabSz="576000" eaLnBrk="0" hangingPunct="0"/>
+            <a:r>
+              <a:rPr lang="en-GB" dirty="0">
+                <a:latin typeface="Calibri" panose="020F0502020204030204" pitchFamily="34" charset="0"/>
+                <a:cs typeface="Calibri" panose="020F0502020204030204" pitchFamily="34" charset="0"/>
+              </a:rPr>
+              <a:t>Trial solutions released</a:t>
+            </a:r>
+            <a:endParaRPr lang="en-GB" baseline="0" dirty="0">
+              <a:latin typeface="Calibri" panose="020F0502020204030204" pitchFamily="34" charset="0"/>
+              <a:cs typeface="Calibri" panose="020F0502020204030204" pitchFamily="34" charset="0"/>
+            </a:endParaRPr>
+          </a:p>
+        </p:txBody>
+      </p:sp>
+      <p:sp>
+        <p:nvSpPr>
+          <p:cNvPr id="13" name="Flowchart: Decision 12">
+            <a:extLst>
+              <a:ext uri="{FF2B5EF4-FFF2-40B4-BE49-F238E27FC236}">
+                <a16:creationId xmlns:a16="http://schemas.microsoft.com/office/drawing/2014/main" id="{5864F398-B2BE-6F3E-163F-601DA8C1BFAF}"/>
+              </a:ext>
+            </a:extLst>
+          </p:cNvPr>
+          <p:cNvSpPr/>
+          <p:nvPr/>
+        </p:nvSpPr>
+        <p:spPr bwMode="auto">
+          <a:xfrm>
+            <a:off x="5087888" y="4441766"/>
+            <a:ext cx="1872000" cy="432000"/>
+          </a:xfrm>
+          <a:prstGeom prst="flowChartDecision">
+            <a:avLst/>
+          </a:prstGeom>
+          <a:noFill/>
+          <a:ln w="12700">
+            <a:solidFill>
+              <a:schemeClr val="tx1"/>
+            </a:solidFill>
+            <a:miter lim="800000"/>
+            <a:headEnd/>
+            <a:tailEnd/>
+          </a:ln>
+        </p:spPr>
+        <p:txBody>
+          <a:bodyPr wrap="none" lIns="72000" tIns="72000" rIns="72000" bIns="72000" rtlCol="0" anchor="ctr" anchorCtr="0"/>
+          <a:lstStyle/>
+          <a:p>
+            <a:pPr algn="ctr" defTabSz="576000" eaLnBrk="0" hangingPunct="0"/>
+            <a:r>
+              <a:rPr lang="en-GB" baseline="0" dirty="0">
+                <a:latin typeface="Calibri" panose="020F0502020204030204" pitchFamily="34" charset="0"/>
+                <a:cs typeface="Calibri" panose="020F0502020204030204" pitchFamily="34" charset="0"/>
+              </a:rPr>
+              <a:t>Issue resolved?</a:t>
+            </a:r>
+          </a:p>
+        </p:txBody>
+      </p:sp>
+      <p:sp>
+        <p:nvSpPr>
+          <p:cNvPr id="15" name="Rectangle 14">
+            <a:extLst>
+              <a:ext uri="{FF2B5EF4-FFF2-40B4-BE49-F238E27FC236}">
+                <a16:creationId xmlns:a16="http://schemas.microsoft.com/office/drawing/2014/main" id="{B6006654-AFFD-C2B9-E0F6-38DE30E8A4B2}"/>
+              </a:ext>
+            </a:extLst>
+          </p:cNvPr>
+          <p:cNvSpPr/>
+          <p:nvPr/>
+        </p:nvSpPr>
+        <p:spPr bwMode="auto">
+          <a:xfrm>
+            <a:off x="5087888" y="5089838"/>
+            <a:ext cx="1872000" cy="432000"/>
+          </a:xfrm>
+          <a:prstGeom prst="rect">
+            <a:avLst/>
+          </a:prstGeom>
+          <a:noFill/>
+          <a:ln w="12700">
+            <a:solidFill>
+              <a:schemeClr val="tx1"/>
+            </a:solidFill>
+            <a:miter lim="800000"/>
+            <a:headEnd/>
+            <a:tailEnd/>
+          </a:ln>
+        </p:spPr>
+        <p:txBody>
+          <a:bodyPr wrap="none" lIns="72000" tIns="72000" rIns="72000" bIns="72000" rtlCol="0" anchor="ctr" anchorCtr="0"/>
+          <a:lstStyle/>
+          <a:p>
+            <a:pPr algn="ctr" defTabSz="576000" eaLnBrk="0" hangingPunct="0"/>
+            <a:r>
+              <a:rPr lang="en-GB" dirty="0">
+                <a:latin typeface="Calibri" panose="020F0502020204030204" pitchFamily="34" charset="0"/>
+                <a:cs typeface="Calibri" panose="020F0502020204030204" pitchFamily="34" charset="0"/>
+              </a:rPr>
+              <a:t>Confirmations from </a:t>
+            </a:r>
+          </a:p>
+          <a:p>
+            <a:pPr algn="ctr" defTabSz="576000" eaLnBrk="0" hangingPunct="0"/>
+            <a:r>
+              <a:rPr lang="en-GB" dirty="0">
+                <a:latin typeface="Calibri" panose="020F0502020204030204" pitchFamily="34" charset="0"/>
+                <a:cs typeface="Calibri" panose="020F0502020204030204" pitchFamily="34" charset="0"/>
+              </a:rPr>
+              <a:t>ODM/OEM</a:t>
+            </a:r>
+            <a:endParaRPr lang="en-GB" baseline="0" dirty="0">
+              <a:latin typeface="Calibri" panose="020F0502020204030204" pitchFamily="34" charset="0"/>
+              <a:cs typeface="Calibri" panose="020F0502020204030204" pitchFamily="34" charset="0"/>
+            </a:endParaRPr>
+          </a:p>
+        </p:txBody>
+      </p:sp>
+      <p:sp>
+        <p:nvSpPr>
+          <p:cNvPr id="17" name="Rectangle 16">
+            <a:extLst>
+              <a:ext uri="{FF2B5EF4-FFF2-40B4-BE49-F238E27FC236}">
+                <a16:creationId xmlns:a16="http://schemas.microsoft.com/office/drawing/2014/main" id="{14AAC021-6BD4-1ADE-C267-19BD11DEE219}"/>
+              </a:ext>
+            </a:extLst>
+          </p:cNvPr>
+          <p:cNvSpPr/>
+          <p:nvPr/>
+        </p:nvSpPr>
+        <p:spPr bwMode="auto">
+          <a:xfrm>
+            <a:off x="5087888" y="5737910"/>
+            <a:ext cx="1872000" cy="432000"/>
+          </a:xfrm>
+          <a:prstGeom prst="rect">
+            <a:avLst/>
+          </a:prstGeom>
+          <a:noFill/>
+          <a:ln w="12700">
+            <a:solidFill>
+              <a:schemeClr val="tx1"/>
+            </a:solidFill>
+            <a:miter lim="800000"/>
+            <a:headEnd/>
+            <a:tailEnd/>
+          </a:ln>
+        </p:spPr>
+        <p:txBody>
+          <a:bodyPr wrap="none" lIns="72000" tIns="72000" rIns="72000" bIns="72000" rtlCol="0" anchor="ctr" anchorCtr="0"/>
+          <a:lstStyle/>
+          <a:p>
+            <a:pPr algn="ctr" defTabSz="576000" eaLnBrk="0" hangingPunct="0"/>
+            <a:r>
+              <a:rPr lang="en-GB" baseline="0" dirty="0">
+                <a:latin typeface="Calibri" panose="020F0502020204030204" pitchFamily="34" charset="0"/>
+                <a:cs typeface="Calibri" panose="020F0502020204030204" pitchFamily="34" charset="0"/>
+              </a:rPr>
+              <a:t>Official release</a:t>
+            </a:r>
+          </a:p>
+        </p:txBody>
+      </p:sp>
+      <p:sp>
+        <p:nvSpPr>
+          <p:cNvPr id="102" name="Flowchart: Predefined Process 101">
+            <a:extLst>
+              <a:ext uri="{FF2B5EF4-FFF2-40B4-BE49-F238E27FC236}">
+                <a16:creationId xmlns:a16="http://schemas.microsoft.com/office/drawing/2014/main" id="{757F0786-9DEC-7A8B-D90B-449B25A692D3}"/>
+              </a:ext>
+            </a:extLst>
+          </p:cNvPr>
+          <p:cNvSpPr/>
+          <p:nvPr/>
+        </p:nvSpPr>
+        <p:spPr bwMode="auto">
+          <a:xfrm>
+            <a:off x="7824192" y="5737910"/>
+            <a:ext cx="1872000" cy="432000"/>
+          </a:xfrm>
+          <a:prstGeom prst="flowChartPredefinedProcess">
+            <a:avLst/>
+          </a:prstGeom>
+          <a:solidFill>
+            <a:srgbClr val="DCD5D7"/>
+          </a:solidFill>
+          <a:ln w="9525">
+            <a:solidFill>
+              <a:schemeClr val="tx1"/>
+            </a:solidFill>
+            <a:miter lim="800000"/>
+            <a:headEnd/>
+            <a:tailEnd/>
+          </a:ln>
+        </p:spPr>
+        <p:txBody>
+          <a:bodyPr wrap="none" lIns="72000" tIns="72000" rIns="72000" bIns="72000" rtlCol="0" anchor="ctr" anchorCtr="0"/>
+          <a:lstStyle/>
+          <a:p>
+            <a:pPr algn="ctr" defTabSz="576000" eaLnBrk="0" hangingPunct="0"/>
+            <a:r>
+              <a:rPr lang="en-GB" baseline="0" dirty="0">
+                <a:latin typeface="Calibri" panose="020F0502020204030204" pitchFamily="34" charset="0"/>
+                <a:cs typeface="Calibri" panose="020F0502020204030204" pitchFamily="34" charset="0"/>
+              </a:rPr>
+              <a:t>Case closed</a:t>
+            </a:r>
+          </a:p>
+        </p:txBody>
+      </p:sp>
+      <p:sp>
+        <p:nvSpPr>
+          <p:cNvPr id="8" name="Flowchart: Decision 7">
+            <a:extLst>
+              <a:ext uri="{FF2B5EF4-FFF2-40B4-BE49-F238E27FC236}">
+                <a16:creationId xmlns:a16="http://schemas.microsoft.com/office/drawing/2014/main" id="{8A51A39F-C759-FF5A-7D89-EF8F5D30217E}"/>
+              </a:ext>
+            </a:extLst>
+          </p:cNvPr>
+          <p:cNvSpPr/>
+          <p:nvPr/>
+        </p:nvSpPr>
+        <p:spPr bwMode="auto">
+          <a:xfrm>
+            <a:off x="5087888" y="1196800"/>
+            <a:ext cx="1872000" cy="432000"/>
+          </a:xfrm>
+          <a:prstGeom prst="flowChartDecision">
+            <a:avLst/>
+          </a:prstGeom>
+          <a:noFill/>
+          <a:ln w="12700">
+            <a:solidFill>
+              <a:schemeClr val="tx1"/>
+            </a:solidFill>
+            <a:miter lim="800000"/>
+            <a:headEnd/>
+            <a:tailEnd/>
+          </a:ln>
+        </p:spPr>
+        <p:txBody>
+          <a:bodyPr wrap="none" lIns="72000" tIns="72000" rIns="72000" bIns="72000" rtlCol="0" anchor="ctr" anchorCtr="0"/>
+          <a:lstStyle/>
+          <a:p>
+            <a:pPr algn="ctr" defTabSz="576000" eaLnBrk="0" hangingPunct="0"/>
+            <a:r>
+              <a:rPr lang="en-GB" dirty="0">
+                <a:latin typeface="Calibri" panose="020F0502020204030204" pitchFamily="34" charset="0"/>
+                <a:cs typeface="Calibri" panose="020F0502020204030204" pitchFamily="34" charset="0"/>
+              </a:rPr>
+              <a:t>IFX issues?</a:t>
+            </a:r>
+            <a:endParaRPr lang="en-GB" baseline="0" dirty="0">
+              <a:latin typeface="Calibri" panose="020F0502020204030204" pitchFamily="34" charset="0"/>
+              <a:cs typeface="Calibri" panose="020F0502020204030204" pitchFamily="34" charset="0"/>
+            </a:endParaRPr>
+          </a:p>
+        </p:txBody>
+      </p:sp>
+      <p:sp>
+        <p:nvSpPr>
+          <p:cNvPr id="18" name="Flowchart: Predefined Process 17">
+            <a:extLst>
+              <a:ext uri="{FF2B5EF4-FFF2-40B4-BE49-F238E27FC236}">
+                <a16:creationId xmlns:a16="http://schemas.microsoft.com/office/drawing/2014/main" id="{346E4798-D3A5-6467-F08E-0ED972A68EF1}"/>
+              </a:ext>
+            </a:extLst>
+          </p:cNvPr>
+          <p:cNvSpPr/>
+          <p:nvPr/>
+        </p:nvSpPr>
+        <p:spPr bwMode="auto">
+          <a:xfrm>
+            <a:off x="7824192" y="1196800"/>
+            <a:ext cx="1872000" cy="432000"/>
+          </a:xfrm>
+          <a:prstGeom prst="flowChartPredefinedProcess">
+            <a:avLst/>
+          </a:prstGeom>
+          <a:solidFill>
+            <a:srgbClr val="DCD5D7"/>
+          </a:solidFill>
+          <a:ln w="9525">
+            <a:solidFill>
+              <a:schemeClr val="tx1"/>
+            </a:solidFill>
+            <a:miter lim="800000"/>
+            <a:headEnd/>
+            <a:tailEnd/>
+          </a:ln>
+        </p:spPr>
+        <p:txBody>
+          <a:bodyPr wrap="none" lIns="72000" tIns="72000" rIns="72000" bIns="72000" rtlCol="0" anchor="ctr" anchorCtr="0"/>
+          <a:lstStyle/>
+          <a:p>
+            <a:pPr algn="ctr" defTabSz="576000" eaLnBrk="0" hangingPunct="0"/>
+            <a:r>
+              <a:rPr lang="en-GB" baseline="0" dirty="0">
+                <a:latin typeface="Calibri" panose="020F0502020204030204" pitchFamily="34" charset="0"/>
+                <a:cs typeface="Calibri" panose="020F0502020204030204" pitchFamily="34" charset="0"/>
+              </a:rPr>
               <a:t>Issue transfer</a:t>
             </a:r>
           </a:p>
@@ -22750,149 +22705,24 @@
       </p:sp>
       <p:cxnSp>
         <p:nvCxnSpPr>
-          <p:cNvPr id="20" name="Straight Arrow Connector 19">
-            <a:extLst>
-              <a:ext uri="{FF2B5EF4-FFF2-40B4-BE49-F238E27FC236}">
-                <a16:creationId xmlns:a16="http://schemas.microsoft.com/office/drawing/2014/main" id="{01E4BB3C-4A35-E00D-B831-4E88CF978693}"/>
+          <p:cNvPr id="24" name="Straight Arrow Connector 23">
+            <a:extLst>
+              <a:ext uri="{FF2B5EF4-FFF2-40B4-BE49-F238E27FC236}">
+                <a16:creationId xmlns:a16="http://schemas.microsoft.com/office/drawing/2014/main" id="{1027ECBC-C30B-BC0E-2BFE-0F790668FEEE}"/>
               </a:ext>
             </a:extLst>
           </p:cNvPr>
           <p:cNvCxnSpPr>
-            <a:stCxn id="6" idx="2"/>
-            <a:endCxn id="8" idx="0"/>
+            <a:cxnSpLocks/>
+            <a:stCxn id="8" idx="2"/>
+            <a:endCxn id="6" idx="0"/>
           </p:cNvCxnSpPr>
           <p:nvPr/>
         </p:nvCxnSpPr>
         <p:spPr>
           <a:xfrm>
-            <a:off x="6023888" y="1628752"/>
-            <a:ext cx="0" cy="219834"/>
-          </a:xfrm>
-          <a:prstGeom prst="straightConnector1">
-            <a:avLst/>
-          </a:prstGeom>
-          <a:ln>
-            <a:tailEnd type="triangle"/>
-          </a:ln>
-        </p:spPr>
-        <p:style>
-          <a:lnRef idx="1">
-            <a:schemeClr val="dk1"/>
-          </a:lnRef>
-          <a:fillRef idx="0">
-            <a:schemeClr val="dk1"/>
-          </a:fillRef>
-          <a:effectRef idx="0">
-            <a:schemeClr val="dk1"/>
-          </a:effectRef>
-          <a:fontRef idx="minor">
-            <a:schemeClr val="tx1"/>
-          </a:fontRef>
-        </p:style>
-      </p:cxnSp>
-      <p:cxnSp>
-        <p:nvCxnSpPr>
-          <p:cNvPr id="24" name="Straight Arrow Connector 23">
-            <a:extLst>
-              <a:ext uri="{FF2B5EF4-FFF2-40B4-BE49-F238E27FC236}">
-                <a16:creationId xmlns:a16="http://schemas.microsoft.com/office/drawing/2014/main" id="{1027ECBC-C30B-BC0E-2BFE-0F790668FEEE}"/>
-              </a:ext>
-            </a:extLst>
-          </p:cNvPr>
-          <p:cNvCxnSpPr>
-            <a:stCxn id="8" idx="2"/>
-            <a:endCxn id="7" idx="0"/>
-          </p:cNvCxnSpPr>
-          <p:nvPr/>
-        </p:nvCxnSpPr>
-        <p:spPr>
-          <a:xfrm>
-            <a:off x="6023888" y="2280586"/>
-            <a:ext cx="0" cy="219834"/>
-          </a:xfrm>
-          <a:prstGeom prst="straightConnector1">
-            <a:avLst/>
-          </a:prstGeom>
-          <a:ln>
-            <a:tailEnd type="triangle"/>
-          </a:ln>
-        </p:spPr>
-        <p:style>
-          <a:lnRef idx="1">
-            <a:schemeClr val="dk1"/>
-          </a:lnRef>
-          <a:fillRef idx="0">
-            <a:schemeClr val="dk1"/>
-          </a:fillRef>
-          <a:effectRef idx="0">
-            <a:schemeClr val="dk1"/>
-          </a:effectRef>
-          <a:fontRef idx="minor">
-            <a:schemeClr val="tx1"/>
-          </a:fontRef>
-        </p:style>
-      </p:cxnSp>
-      <p:cxnSp>
-        <p:nvCxnSpPr>
-          <p:cNvPr id="26" name="Straight Arrow Connector 25">
-            <a:extLst>
-              <a:ext uri="{FF2B5EF4-FFF2-40B4-BE49-F238E27FC236}">
-                <a16:creationId xmlns:a16="http://schemas.microsoft.com/office/drawing/2014/main" id="{5178A488-CC02-19D5-0512-575BED3C81D8}"/>
-              </a:ext>
-            </a:extLst>
-          </p:cNvPr>
-          <p:cNvCxnSpPr>
-            <a:stCxn id="7" idx="2"/>
-            <a:endCxn id="9" idx="0"/>
-          </p:cNvCxnSpPr>
-          <p:nvPr/>
-        </p:nvCxnSpPr>
-        <p:spPr>
-          <a:xfrm>
-            <a:off x="6023888" y="2932420"/>
-            <a:ext cx="0" cy="213202"/>
-          </a:xfrm>
-          <a:prstGeom prst="straightConnector1">
-            <a:avLst/>
-          </a:prstGeom>
-          <a:ln>
-            <a:tailEnd type="triangle"/>
-          </a:ln>
-        </p:spPr>
-        <p:style>
-          <a:lnRef idx="1">
-            <a:schemeClr val="dk1"/>
-          </a:lnRef>
-          <a:fillRef idx="0">
-            <a:schemeClr val="dk1"/>
-          </a:fillRef>
-          <a:effectRef idx="0">
-            <a:schemeClr val="dk1"/>
-          </a:effectRef>
-          <a:fontRef idx="minor">
-            <a:schemeClr val="tx1"/>
-          </a:fontRef>
-        </p:style>
-      </p:cxnSp>
-      <p:cxnSp>
-        <p:nvCxnSpPr>
-          <p:cNvPr id="28" name="Straight Arrow Connector 27">
-            <a:extLst>
-              <a:ext uri="{FF2B5EF4-FFF2-40B4-BE49-F238E27FC236}">
-                <a16:creationId xmlns:a16="http://schemas.microsoft.com/office/drawing/2014/main" id="{6BC4F257-D325-A459-D951-4476BCB1F730}"/>
-              </a:ext>
-            </a:extLst>
-          </p:cNvPr>
-          <p:cNvCxnSpPr>
-            <a:stCxn id="9" idx="2"/>
-            <a:endCxn id="11" idx="0"/>
-          </p:cNvCxnSpPr>
-          <p:nvPr/>
-        </p:nvCxnSpPr>
-        <p:spPr>
-          <a:xfrm>
-            <a:off x="6023888" y="3577622"/>
-            <a:ext cx="0" cy="216072"/>
+            <a:off x="6023888" y="1628800"/>
+            <a:ext cx="0" cy="210404"/>
           </a:xfrm>
           <a:prstGeom prst="straightConnector1">
             <a:avLst/>
@@ -23060,7 +22890,7 @@
         <p:spPr>
           <a:xfrm>
             <a:off x="6959888" y="5953910"/>
-            <a:ext cx="720496" cy="0"/>
+            <a:ext cx="864304" cy="0"/>
           </a:xfrm>
           <a:prstGeom prst="straightConnector1">
             <a:avLst/>
@@ -23094,19 +22924,20 @@
             </a:extLst>
           </p:cNvPr>
           <p:cNvCxnSpPr>
+            <a:cxnSpLocks/>
             <a:stCxn id="13" idx="3"/>
-            <a:endCxn id="7" idx="3"/>
+            <a:endCxn id="6" idx="3"/>
           </p:cNvCxnSpPr>
           <p:nvPr/>
         </p:nvCxnSpPr>
         <p:spPr>
           <a:xfrm flipV="1">
-            <a:off x="6959888" y="2716420"/>
-            <a:ext cx="12700" cy="1941346"/>
+            <a:off x="6959888" y="2055204"/>
+            <a:ext cx="12700" cy="2602562"/>
           </a:xfrm>
           <a:prstGeom prst="bentConnector3">
             <a:avLst>
-              <a:gd name="adj1" fmla="val 5655480"/>
+              <a:gd name="adj1" fmla="val 6816772"/>
             </a:avLst>
           </a:prstGeom>
           <a:ln>
@@ -23261,6 +23092,443 @@
             <a:endParaRPr lang="en-GB" sz="1600" kern="0" baseline="0" dirty="0">
               <a:solidFill>
                 <a:schemeClr val="accent1"/>
+              </a:solidFill>
+              <a:latin typeface="Calibri" panose="020F0502020204030204" pitchFamily="34" charset="0"/>
+              <a:cs typeface="Calibri" panose="020F0502020204030204" pitchFamily="34" charset="0"/>
+            </a:endParaRPr>
+          </a:p>
+        </p:txBody>
+      </p:sp>
+      <p:cxnSp>
+        <p:nvCxnSpPr>
+          <p:cNvPr id="19" name="Straight Arrow Connector 18">
+            <a:extLst>
+              <a:ext uri="{FF2B5EF4-FFF2-40B4-BE49-F238E27FC236}">
+                <a16:creationId xmlns:a16="http://schemas.microsoft.com/office/drawing/2014/main" id="{9C933FC4-1638-CF4F-AF42-AC0228F7276E}"/>
+              </a:ext>
+            </a:extLst>
+          </p:cNvPr>
+          <p:cNvCxnSpPr>
+            <a:stCxn id="2" idx="3"/>
+            <a:endCxn id="8" idx="1"/>
+          </p:cNvCxnSpPr>
+          <p:nvPr/>
+        </p:nvCxnSpPr>
+        <p:spPr>
+          <a:xfrm>
+            <a:off x="4223584" y="1412752"/>
+            <a:ext cx="864304" cy="48"/>
+          </a:xfrm>
+          <a:prstGeom prst="straightConnector1">
+            <a:avLst/>
+          </a:prstGeom>
+          <a:ln>
+            <a:tailEnd type="triangle"/>
+          </a:ln>
+        </p:spPr>
+        <p:style>
+          <a:lnRef idx="1">
+            <a:schemeClr val="dk1"/>
+          </a:lnRef>
+          <a:fillRef idx="0">
+            <a:schemeClr val="dk1"/>
+          </a:fillRef>
+          <a:effectRef idx="0">
+            <a:schemeClr val="dk1"/>
+          </a:effectRef>
+          <a:fontRef idx="minor">
+            <a:schemeClr val="tx1"/>
+          </a:fontRef>
+        </p:style>
+      </p:cxnSp>
+      <p:cxnSp>
+        <p:nvCxnSpPr>
+          <p:cNvPr id="23" name="Straight Arrow Connector 22">
+            <a:extLst>
+              <a:ext uri="{FF2B5EF4-FFF2-40B4-BE49-F238E27FC236}">
+                <a16:creationId xmlns:a16="http://schemas.microsoft.com/office/drawing/2014/main" id="{EF00204C-3629-801E-4073-317D94110556}"/>
+              </a:ext>
+            </a:extLst>
+          </p:cNvPr>
+          <p:cNvCxnSpPr>
+            <a:stCxn id="6" idx="2"/>
+            <a:endCxn id="7" idx="0"/>
+          </p:cNvCxnSpPr>
+          <p:nvPr/>
+        </p:nvCxnSpPr>
+        <p:spPr>
+          <a:xfrm>
+            <a:off x="6023888" y="2271204"/>
+            <a:ext cx="0" cy="229216"/>
+          </a:xfrm>
+          <a:prstGeom prst="straightConnector1">
+            <a:avLst/>
+          </a:prstGeom>
+          <a:ln>
+            <a:tailEnd type="triangle"/>
+          </a:ln>
+        </p:spPr>
+        <p:style>
+          <a:lnRef idx="1">
+            <a:schemeClr val="dk1"/>
+          </a:lnRef>
+          <a:fillRef idx="0">
+            <a:schemeClr val="dk1"/>
+          </a:fillRef>
+          <a:effectRef idx="0">
+            <a:schemeClr val="dk1"/>
+          </a:effectRef>
+          <a:fontRef idx="minor">
+            <a:schemeClr val="tx1"/>
+          </a:fontRef>
+        </p:style>
+      </p:cxnSp>
+      <p:sp>
+        <p:nvSpPr>
+          <p:cNvPr id="29" name="Flowchart: Decision 28">
+            <a:extLst>
+              <a:ext uri="{FF2B5EF4-FFF2-40B4-BE49-F238E27FC236}">
+                <a16:creationId xmlns:a16="http://schemas.microsoft.com/office/drawing/2014/main" id="{7E75238B-3A9E-C86C-C827-DCD281C39CFA}"/>
+              </a:ext>
+            </a:extLst>
+          </p:cNvPr>
+          <p:cNvSpPr/>
+          <p:nvPr/>
+        </p:nvSpPr>
+        <p:spPr bwMode="auto">
+          <a:xfrm>
+            <a:off x="5087888" y="3148420"/>
+            <a:ext cx="1872000" cy="432000"/>
+          </a:xfrm>
+          <a:prstGeom prst="flowChartDecision">
+            <a:avLst/>
+          </a:prstGeom>
+          <a:noFill/>
+          <a:ln w="12700">
+            <a:solidFill>
+              <a:schemeClr val="tx1"/>
+            </a:solidFill>
+            <a:miter lim="800000"/>
+            <a:headEnd/>
+            <a:tailEnd/>
+          </a:ln>
+        </p:spPr>
+        <p:txBody>
+          <a:bodyPr wrap="none" lIns="72000" tIns="72000" rIns="72000" bIns="72000" rtlCol="0" anchor="ctr" anchorCtr="0"/>
+          <a:lstStyle/>
+          <a:p>
+            <a:pPr algn="ctr" defTabSz="576000" eaLnBrk="0" hangingPunct="0"/>
+            <a:r>
+              <a:rPr lang="en-GB" baseline="0" dirty="0">
+                <a:latin typeface="Calibri" panose="020F0502020204030204" pitchFamily="34" charset="0"/>
+                <a:cs typeface="Calibri" panose="020F0502020204030204" pitchFamily="34" charset="0"/>
+              </a:rPr>
+              <a:t>MSD case exist?</a:t>
+            </a:r>
+          </a:p>
+        </p:txBody>
+      </p:sp>
+      <p:cxnSp>
+        <p:nvCxnSpPr>
+          <p:cNvPr id="33" name="Straight Arrow Connector 32">
+            <a:extLst>
+              <a:ext uri="{FF2B5EF4-FFF2-40B4-BE49-F238E27FC236}">
+                <a16:creationId xmlns:a16="http://schemas.microsoft.com/office/drawing/2014/main" id="{68D9ACD6-86D6-77A0-DC35-1141D4BE1F64}"/>
+              </a:ext>
+            </a:extLst>
+          </p:cNvPr>
+          <p:cNvCxnSpPr>
+            <a:stCxn id="7" idx="2"/>
+            <a:endCxn id="29" idx="0"/>
+          </p:cNvCxnSpPr>
+          <p:nvPr/>
+        </p:nvCxnSpPr>
+        <p:spPr>
+          <a:xfrm>
+            <a:off x="6023888" y="2932420"/>
+            <a:ext cx="0" cy="216000"/>
+          </a:xfrm>
+          <a:prstGeom prst="straightConnector1">
+            <a:avLst/>
+          </a:prstGeom>
+          <a:ln>
+            <a:tailEnd type="triangle"/>
+          </a:ln>
+        </p:spPr>
+        <p:style>
+          <a:lnRef idx="1">
+            <a:schemeClr val="dk1"/>
+          </a:lnRef>
+          <a:fillRef idx="0">
+            <a:schemeClr val="dk1"/>
+          </a:fillRef>
+          <a:effectRef idx="0">
+            <a:schemeClr val="dk1"/>
+          </a:effectRef>
+          <a:fontRef idx="minor">
+            <a:schemeClr val="tx1"/>
+          </a:fontRef>
+        </p:style>
+      </p:cxnSp>
+      <p:cxnSp>
+        <p:nvCxnSpPr>
+          <p:cNvPr id="37" name="Straight Arrow Connector 36">
+            <a:extLst>
+              <a:ext uri="{FF2B5EF4-FFF2-40B4-BE49-F238E27FC236}">
+                <a16:creationId xmlns:a16="http://schemas.microsoft.com/office/drawing/2014/main" id="{CB532424-6303-2DD0-4D80-3768CA9AA7A1}"/>
+              </a:ext>
+            </a:extLst>
+          </p:cNvPr>
+          <p:cNvCxnSpPr>
+            <a:stCxn id="29" idx="2"/>
+            <a:endCxn id="11" idx="0"/>
+          </p:cNvCxnSpPr>
+          <p:nvPr/>
+        </p:nvCxnSpPr>
+        <p:spPr>
+          <a:xfrm>
+            <a:off x="6023888" y="3580420"/>
+            <a:ext cx="0" cy="213274"/>
+          </a:xfrm>
+          <a:prstGeom prst="straightConnector1">
+            <a:avLst/>
+          </a:prstGeom>
+          <a:ln>
+            <a:tailEnd type="triangle"/>
+          </a:ln>
+        </p:spPr>
+        <p:style>
+          <a:lnRef idx="1">
+            <a:schemeClr val="dk1"/>
+          </a:lnRef>
+          <a:fillRef idx="0">
+            <a:schemeClr val="dk1"/>
+          </a:fillRef>
+          <a:effectRef idx="0">
+            <a:schemeClr val="dk1"/>
+          </a:effectRef>
+          <a:fontRef idx="minor">
+            <a:schemeClr val="tx1"/>
+          </a:fontRef>
+        </p:style>
+      </p:cxnSp>
+      <p:cxnSp>
+        <p:nvCxnSpPr>
+          <p:cNvPr id="44" name="Straight Arrow Connector 43">
+            <a:extLst>
+              <a:ext uri="{FF2B5EF4-FFF2-40B4-BE49-F238E27FC236}">
+                <a16:creationId xmlns:a16="http://schemas.microsoft.com/office/drawing/2014/main" id="{B1E72FD0-6639-4F86-8524-288E1632B904}"/>
+              </a:ext>
+            </a:extLst>
+          </p:cNvPr>
+          <p:cNvCxnSpPr>
+            <a:stCxn id="29" idx="1"/>
+            <a:endCxn id="9" idx="3"/>
+          </p:cNvCxnSpPr>
+          <p:nvPr/>
+        </p:nvCxnSpPr>
+        <p:spPr>
+          <a:xfrm flipH="1">
+            <a:off x="4223584" y="3364420"/>
+            <a:ext cx="864304" cy="0"/>
+          </a:xfrm>
+          <a:prstGeom prst="straightConnector1">
+            <a:avLst/>
+          </a:prstGeom>
+          <a:ln>
+            <a:tailEnd type="triangle"/>
+          </a:ln>
+        </p:spPr>
+        <p:style>
+          <a:lnRef idx="1">
+            <a:schemeClr val="dk1"/>
+          </a:lnRef>
+          <a:fillRef idx="0">
+            <a:schemeClr val="dk1"/>
+          </a:fillRef>
+          <a:effectRef idx="0">
+            <a:schemeClr val="dk1"/>
+          </a:effectRef>
+          <a:fontRef idx="minor">
+            <a:schemeClr val="tx1"/>
+          </a:fontRef>
+        </p:style>
+      </p:cxnSp>
+      <p:cxnSp>
+        <p:nvCxnSpPr>
+          <p:cNvPr id="46" name="Connector: Elbow 45">
+            <a:extLst>
+              <a:ext uri="{FF2B5EF4-FFF2-40B4-BE49-F238E27FC236}">
+                <a16:creationId xmlns:a16="http://schemas.microsoft.com/office/drawing/2014/main" id="{EDED4C08-2E52-9881-DD9B-3F73B855318E}"/>
+              </a:ext>
+            </a:extLst>
+          </p:cNvPr>
+          <p:cNvCxnSpPr>
+            <a:stCxn id="9" idx="2"/>
+            <a:endCxn id="11" idx="1"/>
+          </p:cNvCxnSpPr>
+          <p:nvPr/>
+        </p:nvCxnSpPr>
+        <p:spPr>
+          <a:xfrm rot="16200000" flipH="1">
+            <a:off x="3973099" y="2894905"/>
+            <a:ext cx="429274" cy="1800304"/>
+          </a:xfrm>
+          <a:prstGeom prst="bentConnector2">
+            <a:avLst/>
+          </a:prstGeom>
+          <a:ln>
+            <a:tailEnd type="triangle"/>
+          </a:ln>
+        </p:spPr>
+        <p:style>
+          <a:lnRef idx="1">
+            <a:schemeClr val="dk1"/>
+          </a:lnRef>
+          <a:fillRef idx="0">
+            <a:schemeClr val="dk1"/>
+          </a:fillRef>
+          <a:effectRef idx="0">
+            <a:schemeClr val="dk1"/>
+          </a:effectRef>
+          <a:fontRef idx="minor">
+            <a:schemeClr val="tx1"/>
+          </a:fontRef>
+        </p:style>
+      </p:cxnSp>
+      <p:sp>
+        <p:nvSpPr>
+          <p:cNvPr id="49" name="TextBox 48">
+            <a:extLst>
+              <a:ext uri="{FF2B5EF4-FFF2-40B4-BE49-F238E27FC236}">
+                <a16:creationId xmlns:a16="http://schemas.microsoft.com/office/drawing/2014/main" id="{7674BA98-107C-00F5-144C-94312EAB9CAB}"/>
+              </a:ext>
+            </a:extLst>
+          </p:cNvPr>
+          <p:cNvSpPr txBox="1"/>
+          <p:nvPr/>
+        </p:nvSpPr>
+        <p:spPr bwMode="auto">
+          <a:xfrm>
+            <a:off x="6096000" y="3589877"/>
+            <a:ext cx="213200" cy="184666"/>
+          </a:xfrm>
+          <a:prstGeom prst="rect">
+            <a:avLst/>
+          </a:prstGeom>
+          <a:solidFill>
+            <a:schemeClr val="bg1"/>
+          </a:solidFill>
+          <a:ln w="9525">
+            <a:noFill/>
+            <a:miter lim="800000"/>
+            <a:headEnd/>
+            <a:tailEnd/>
+          </a:ln>
+          <a:effectLst/>
+        </p:spPr>
+        <p:txBody>
+          <a:bodyPr wrap="none" lIns="0" tIns="0" rIns="0" bIns="0" rtlCol="0" anchor="t" anchorCtr="0">
+            <a:spAutoFit/>
+          </a:bodyPr>
+          <a:lstStyle/>
+          <a:p>
+            <a:pPr marR="0" algn="l" defTabSz="576000" eaLnBrk="0" fontAlgn="auto" latinLnBrk="0" hangingPunct="0">
+              <a:spcBef>
+                <a:spcPts val="0"/>
+              </a:spcBef>
+              <a:spcAft>
+                <a:spcPts val="0"/>
+              </a:spcAft>
+              <a:buClr>
+                <a:schemeClr val="tx2"/>
+              </a:buClr>
+              <a:buSzTx/>
+              <a:tabLst/>
+            </a:pPr>
+            <a:r>
+              <a:rPr lang="en-GB" sz="1200" kern="0" baseline="0" dirty="0">
+                <a:solidFill>
+                  <a:schemeClr val="accent1"/>
+                </a:solidFill>
+                <a:latin typeface="Calibri" panose="020F0502020204030204" pitchFamily="34" charset="0"/>
+                <a:cs typeface="Calibri" panose="020F0502020204030204" pitchFamily="34" charset="0"/>
+              </a:rPr>
+              <a:t>Yes</a:t>
+            </a:r>
+            <a:endParaRPr lang="en-GB" sz="1600" kern="0" baseline="0" dirty="0">
+              <a:solidFill>
+                <a:schemeClr val="accent1"/>
+              </a:solidFill>
+              <a:latin typeface="Calibri" panose="020F0502020204030204" pitchFamily="34" charset="0"/>
+              <a:cs typeface="Calibri" panose="020F0502020204030204" pitchFamily="34" charset="0"/>
+            </a:endParaRPr>
+          </a:p>
+        </p:txBody>
+      </p:sp>
+      <p:sp>
+        <p:nvSpPr>
+          <p:cNvPr id="50" name="TextBox 49">
+            <a:extLst>
+              <a:ext uri="{FF2B5EF4-FFF2-40B4-BE49-F238E27FC236}">
+                <a16:creationId xmlns:a16="http://schemas.microsoft.com/office/drawing/2014/main" id="{AD91EB3F-FBE5-924B-7CC3-318ED4F22936}"/>
+              </a:ext>
+            </a:extLst>
+          </p:cNvPr>
+          <p:cNvSpPr txBox="1"/>
+          <p:nvPr/>
+        </p:nvSpPr>
+        <p:spPr bwMode="auto">
+          <a:xfrm>
+            <a:off x="4815665" y="3264152"/>
+            <a:ext cx="181140" cy="184666"/>
+          </a:xfrm>
+          <a:prstGeom prst="rect">
+            <a:avLst/>
+          </a:prstGeom>
+          <a:solidFill>
+            <a:schemeClr val="bg1"/>
+          </a:solidFill>
+          <a:ln w="9525">
+            <a:noFill/>
+            <a:miter lim="800000"/>
+            <a:headEnd/>
+            <a:tailEnd/>
+          </a:ln>
+          <a:effectLst/>
+        </p:spPr>
+        <p:txBody>
+          <a:bodyPr wrap="none" lIns="0" tIns="0" rIns="0" bIns="0" rtlCol="0" anchor="t" anchorCtr="0">
+            <a:spAutoFit/>
+          </a:bodyPr>
+          <a:lstStyle/>
+          <a:p>
+            <a:pPr marR="0" algn="l" defTabSz="576000" eaLnBrk="0" fontAlgn="auto" latinLnBrk="0" hangingPunct="0">
+              <a:spcBef>
+                <a:spcPts val="0"/>
+              </a:spcBef>
+              <a:spcAft>
+                <a:spcPts val="0"/>
+              </a:spcAft>
+              <a:buClr>
+                <a:schemeClr val="tx2"/>
+              </a:buClr>
+              <a:buSzTx/>
+              <a:tabLst/>
+            </a:pPr>
+            <a:r>
+              <a:rPr lang="en-GB" sz="1200" kern="0" baseline="0" dirty="0">
+                <a:solidFill>
+                  <a:srgbClr val="FF0000"/>
+                </a:solidFill>
+                <a:latin typeface="Calibri" panose="020F0502020204030204" pitchFamily="34" charset="0"/>
+                <a:cs typeface="Calibri" panose="020F0502020204030204" pitchFamily="34" charset="0"/>
+              </a:rPr>
+              <a:t>No</a:t>
+            </a:r>
+            <a:endParaRPr lang="en-GB" sz="1600" kern="0" baseline="0" dirty="0">
+              <a:solidFill>
+                <a:srgbClr val="FF0000"/>
               </a:solidFill>
               <a:latin typeface="Calibri" panose="020F0502020204030204" pitchFamily="34" charset="0"/>
               <a:cs typeface="Calibri" panose="020F0502020204030204" pitchFamily="34" charset="0"/>
@@ -23339,7 +23607,7 @@
           <a:p>
             <a:pPr lvl="1"/>
             <a:r>
-              <a:rPr lang="en-GB" sz="2200" dirty="0">
+              <a:rPr lang="en-GB" sz="2000" dirty="0">
                 <a:latin typeface="Calibri" panose="020F0502020204030204" pitchFamily="34" charset="0"/>
                 <a:cs typeface="Calibri" panose="020F0502020204030204" pitchFamily="34" charset="0"/>
               </a:rPr>
@@ -23349,7 +23617,7 @@
           <a:p>
             <a:pPr lvl="1"/>
             <a:r>
-              <a:rPr lang="en-GB" sz="2200" dirty="0">
+              <a:rPr lang="en-GB" sz="2000" dirty="0">
                 <a:latin typeface="Calibri" panose="020F0502020204030204" pitchFamily="34" charset="0"/>
                 <a:cs typeface="Calibri" panose="020F0502020204030204" pitchFamily="34" charset="0"/>
               </a:rPr>
@@ -23359,14 +23627,24 @@
           <a:p>
             <a:pPr lvl="1"/>
             <a:r>
-              <a:rPr lang="en-GB" sz="2200" dirty="0" err="1">
+              <a:rPr lang="en-GB" sz="2000" dirty="0">
+                <a:latin typeface="Calibri" panose="020F0502020204030204" pitchFamily="34" charset="0"/>
+                <a:cs typeface="Calibri" panose="020F0502020204030204" pitchFamily="34" charset="0"/>
+              </a:rPr>
+              <a:t>SALEAE logs</a:t>
+            </a:r>
+          </a:p>
+          <a:p>
+            <a:pPr lvl="1"/>
+            <a:r>
+              <a:rPr lang="en-GB" sz="2000" dirty="0" err="1">
                 <a:latin typeface="Calibri" panose="020F0502020204030204" pitchFamily="34" charset="0"/>
                 <a:cs typeface="Calibri" panose="020F0502020204030204" pitchFamily="34" charset="0"/>
               </a:rPr>
               <a:t>Ellisys</a:t>
             </a:r>
             <a:r>
-              <a:rPr lang="en-GB" sz="2200" dirty="0">
+              <a:rPr lang="en-GB" sz="2000" dirty="0">
                 <a:latin typeface="Calibri" panose="020F0502020204030204" pitchFamily="34" charset="0"/>
                 <a:cs typeface="Calibri" panose="020F0502020204030204" pitchFamily="34" charset="0"/>
               </a:rPr>
@@ -23376,17 +23654,7 @@
           <a:p>
             <a:pPr lvl="1"/>
             <a:r>
-              <a:rPr lang="en-GB" sz="2200" dirty="0">
-                <a:latin typeface="Calibri" panose="020F0502020204030204" pitchFamily="34" charset="0"/>
-                <a:cs typeface="Calibri" panose="020F0502020204030204" pitchFamily="34" charset="0"/>
-              </a:rPr>
-              <a:t>SALEAE logs</a:t>
-            </a:r>
-          </a:p>
-          <a:p>
-            <a:pPr lvl="1"/>
-            <a:r>
-              <a:rPr lang="en-GB" sz="2200" dirty="0">
+              <a:rPr lang="en-GB" sz="2000" dirty="0">
                 <a:latin typeface="Calibri" panose="020F0502020204030204" pitchFamily="34" charset="0"/>
                 <a:cs typeface="Calibri" panose="020F0502020204030204" pitchFamily="34" charset="0"/>
               </a:rPr>
@@ -23850,6 +24118,29 @@
                 <a:latin typeface="Calibri" panose="020F0502020204030204" pitchFamily="34" charset="0"/>
                 <a:cs typeface="Calibri" panose="020F0502020204030204" pitchFamily="34" charset="0"/>
               </a:rPr>
+              <a:t>Saleae Logic/</a:t>
+            </a:r>
+            <a:r>
+              <a:rPr lang="en-GB" sz="2400" dirty="0" err="1">
+                <a:latin typeface="Calibri" panose="020F0502020204030204" pitchFamily="34" charset="0"/>
+                <a:cs typeface="Calibri" panose="020F0502020204030204" pitchFamily="34" charset="0"/>
+              </a:rPr>
+              <a:t>Ellisys</a:t>
+            </a:r>
+            <a:r>
+              <a:rPr lang="en-GB" sz="2400" dirty="0">
+                <a:latin typeface="Calibri" panose="020F0502020204030204" pitchFamily="34" charset="0"/>
+                <a:cs typeface="Calibri" panose="020F0502020204030204" pitchFamily="34" charset="0"/>
+              </a:rPr>
+              <a:t> C-Tracker</a:t>
+            </a:r>
+          </a:p>
+          <a:p>
+            <a:r>
+              <a:rPr lang="en-GB" sz="2400" dirty="0">
+                <a:latin typeface="Calibri" panose="020F0502020204030204" pitchFamily="34" charset="0"/>
+                <a:cs typeface="Calibri" panose="020F0502020204030204" pitchFamily="34" charset="0"/>
+              </a:rPr>
               <a:t>Start Recording</a:t>
             </a:r>
           </a:p>
@@ -24014,7 +24305,7 @@
                 <a:latin typeface="Calibri" panose="020F0502020204030204" pitchFamily="34" charset="0"/>
                 <a:cs typeface="Calibri" panose="020F0502020204030204" pitchFamily="34" charset="0"/>
               </a:rPr>
-              <a:t>A SALEAE 16ch Pro Logic Analyser.</a:t>
+              <a:t>A CY4500.</a:t>
             </a:r>
           </a:p>
           <a:p>
@@ -24023,7 +24314,7 @@
                 <a:latin typeface="Calibri" panose="020F0502020204030204" pitchFamily="34" charset="0"/>
                 <a:cs typeface="Calibri" panose="020F0502020204030204" pitchFamily="34" charset="0"/>
               </a:rPr>
-              <a:t>Install SALEAE Logic2 (v2.4.0+) application.</a:t>
+              <a:t>A SALEAE 16ch Pro Logic Analyser.</a:t>
             </a:r>
           </a:p>
           <a:p>
@@ -24032,21 +24323,21 @@
                 <a:latin typeface="Calibri" panose="020F0502020204030204" pitchFamily="34" charset="0"/>
                 <a:cs typeface="Calibri" panose="020F0502020204030204" pitchFamily="34" charset="0"/>
               </a:rPr>
-              <a:t>Install “</a:t>
+              <a:t>An </a:t>
             </a:r>
             <a:r>
               <a:rPr lang="en-GB" sz="2400" dirty="0" err="1">
                 <a:latin typeface="Calibri" panose="020F0502020204030204" pitchFamily="34" charset="0"/>
                 <a:cs typeface="Calibri" panose="020F0502020204030204" pitchFamily="34" charset="0"/>
               </a:rPr>
-              <a:t>Manchester_PD_CC</a:t>
+              <a:t>Ellisys</a:t>
             </a:r>
             <a:r>
               <a:rPr lang="en-GB" sz="2400" dirty="0">
                 <a:latin typeface="Calibri" panose="020F0502020204030204" pitchFamily="34" charset="0"/>
                 <a:cs typeface="Calibri" panose="020F0502020204030204" pitchFamily="34" charset="0"/>
               </a:rPr>
-              <a:t>” CC analyser plugin.</a:t>
+              <a:t> C-Tracker (optional).</a:t>
             </a:r>
           </a:p>
           <a:p>
@@ -24055,33 +24346,199 @@
                 <a:latin typeface="Calibri" panose="020F0502020204030204" pitchFamily="34" charset="0"/>
                 <a:cs typeface="Calibri" panose="020F0502020204030204" pitchFamily="34" charset="0"/>
               </a:rPr>
-              <a:t>Install “I2C_HPI” I</a:t>
-            </a:r>
-            <a:r>
-              <a:rPr lang="en-GB" sz="2400" baseline="30000" dirty="0">
+              <a:t>EZ-PD Protocol Analyzer Utility v3.1.x.</a:t>
+            </a:r>
+          </a:p>
+          <a:p>
+            <a:r>
+              <a:rPr lang="en-GB" sz="2400" dirty="0">
+                <a:latin typeface="Calibri" panose="020F0502020204030204" pitchFamily="34" charset="0"/>
+                <a:cs typeface="Calibri" panose="020F0502020204030204" pitchFamily="34" charset="0"/>
+              </a:rPr>
+              <a:t>SALEAE Logic2 v2.4.0+.</a:t>
+            </a:r>
+          </a:p>
+          <a:p>
+            <a:pPr lvl="1"/>
+            <a:r>
+              <a:rPr lang="en-GB" sz="2000" dirty="0">
+                <a:latin typeface="Calibri" panose="020F0502020204030204" pitchFamily="34" charset="0"/>
+                <a:cs typeface="Calibri" panose="020F0502020204030204" pitchFamily="34" charset="0"/>
+              </a:rPr>
+              <a:t>“</a:t>
+            </a:r>
+            <a:r>
+              <a:rPr lang="en-GB" sz="2000" dirty="0" err="1">
+                <a:latin typeface="Calibri" panose="020F0502020204030204" pitchFamily="34" charset="0"/>
+                <a:cs typeface="Calibri" panose="020F0502020204030204" pitchFamily="34" charset="0"/>
+              </a:rPr>
+              <a:t>Saleae_PDCC_Release</a:t>
+            </a:r>
+            <a:r>
+              <a:rPr lang="en-GB" sz="2000" dirty="0">
+                <a:latin typeface="Calibri" panose="020F0502020204030204" pitchFamily="34" charset="0"/>
+                <a:cs typeface="Calibri" panose="020F0502020204030204" pitchFamily="34" charset="0"/>
+              </a:rPr>
+              <a:t>” CC analyser plugin.</a:t>
+            </a:r>
+          </a:p>
+          <a:p>
+            <a:pPr lvl="1"/>
+            <a:r>
+              <a:rPr lang="en-GB" sz="2000" dirty="0">
+                <a:latin typeface="Calibri" panose="020F0502020204030204" pitchFamily="34" charset="0"/>
+                <a:cs typeface="Calibri" panose="020F0502020204030204" pitchFamily="34" charset="0"/>
+              </a:rPr>
+              <a:t>“I2C_HPI” I</a:t>
+            </a:r>
+            <a:r>
+              <a:rPr lang="en-GB" sz="2000" baseline="30000" dirty="0">
                 <a:latin typeface="Calibri" panose="020F0502020204030204" pitchFamily="34" charset="0"/>
                 <a:cs typeface="Calibri" panose="020F0502020204030204" pitchFamily="34" charset="0"/>
               </a:rPr>
               <a:t>2</a:t>
             </a:r>
             <a:r>
+              <a:rPr lang="en-GB" sz="2000" dirty="0">
+                <a:latin typeface="Calibri" panose="020F0502020204030204" pitchFamily="34" charset="0"/>
+                <a:cs typeface="Calibri" panose="020F0502020204030204" pitchFamily="34" charset="0"/>
+              </a:rPr>
+              <a:t>C analyser plugin.</a:t>
+            </a:r>
+          </a:p>
+          <a:p>
+            <a:r>
+              <a:rPr lang="en-GB" sz="2400" dirty="0" err="1">
+                <a:latin typeface="Calibri" panose="020F0502020204030204" pitchFamily="34" charset="0"/>
+                <a:cs typeface="Calibri" panose="020F0502020204030204" pitchFamily="34" charset="0"/>
+              </a:rPr>
+              <a:t>Ellisys</a:t>
+            </a:r>
+            <a:r>
               <a:rPr lang="en-GB" sz="2400" dirty="0">
                 <a:latin typeface="Calibri" panose="020F0502020204030204" pitchFamily="34" charset="0"/>
                 <a:cs typeface="Calibri" panose="020F0502020204030204" pitchFamily="34" charset="0"/>
               </a:rPr>
-              <a:t>C analyser plugin.</a:t>
-            </a:r>
-          </a:p>
-          <a:p>
+              <a:t> Type-C Tracker Analyzer.</a:t>
+            </a:r>
+          </a:p>
+          <a:p>
+            <a:pPr marL="0" indent="0">
+              <a:buNone/>
+            </a:pPr>
             <a:endParaRPr lang="en-GB" sz="2400" dirty="0">
               <a:latin typeface="Calibri" panose="020F0502020204030204" pitchFamily="34" charset="0"/>
               <a:cs typeface="Calibri" panose="020F0502020204030204" pitchFamily="34" charset="0"/>
             </a:endParaRPr>
           </a:p>
-          <a:p>
-            <a:pPr marL="0" indent="0">
-              <a:buNone/>
-            </a:pPr>
+        </p:txBody>
+      </p:sp>
+      <p:sp>
+        <p:nvSpPr>
+          <p:cNvPr id="3" name="Title 2">
+            <a:extLst>
+              <a:ext uri="{FF2B5EF4-FFF2-40B4-BE49-F238E27FC236}">
+                <a16:creationId xmlns:a16="http://schemas.microsoft.com/office/drawing/2014/main" id="{4281126E-6757-90CE-56A9-3B3BE534AA9B}"/>
+              </a:ext>
+            </a:extLst>
+          </p:cNvPr>
+          <p:cNvSpPr>
+            <a:spLocks noGrp="1"/>
+          </p:cNvSpPr>
+          <p:nvPr>
+            <p:ph type="title"/>
+          </p:nvPr>
+        </p:nvSpPr>
+        <p:spPr/>
+        <p:txBody>
+          <a:bodyPr/>
+          <a:lstStyle/>
+          <a:p>
+            <a:r>
+              <a:rPr lang="en-GB" sz="3200" dirty="0">
+                <a:latin typeface="Calibri" panose="020F0502020204030204" pitchFamily="34" charset="0"/>
+                <a:cs typeface="Calibri" panose="020F0502020204030204" pitchFamily="34" charset="0"/>
+              </a:rPr>
+              <a:t>Infineon WCS Logger – Prerequisites</a:t>
+            </a:r>
+          </a:p>
+        </p:txBody>
+      </p:sp>
+      <p:sp>
+        <p:nvSpPr>
+          <p:cNvPr id="4" name="Footer Placeholder 3">
+            <a:extLst>
+              <a:ext uri="{FF2B5EF4-FFF2-40B4-BE49-F238E27FC236}">
+                <a16:creationId xmlns:a16="http://schemas.microsoft.com/office/drawing/2014/main" id="{0312F4E3-32AD-DA55-1A4A-815B1F644D43}"/>
+              </a:ext>
+            </a:extLst>
+          </p:cNvPr>
+          <p:cNvSpPr>
+            <a:spLocks noGrp="1"/>
+          </p:cNvSpPr>
+          <p:nvPr>
+            <p:ph type="ftr" sz="quarter" idx="16"/>
+          </p:nvPr>
+        </p:nvSpPr>
+        <p:spPr/>
+        <p:txBody>
+          <a:bodyPr/>
+          <a:lstStyle/>
+          <a:p>
+            <a:endParaRPr lang="en-US" dirty="0"/>
+          </a:p>
+        </p:txBody>
+      </p:sp>
+      <p:sp>
+        <p:nvSpPr>
+          <p:cNvPr id="5" name="Slide Number Placeholder 4">
+            <a:extLst>
+              <a:ext uri="{FF2B5EF4-FFF2-40B4-BE49-F238E27FC236}">
+                <a16:creationId xmlns:a16="http://schemas.microsoft.com/office/drawing/2014/main" id="{5523256E-932F-EFAB-7038-27F280525253}"/>
+              </a:ext>
+            </a:extLst>
+          </p:cNvPr>
+          <p:cNvSpPr>
+            <a:spLocks noGrp="1"/>
+          </p:cNvSpPr>
+          <p:nvPr>
+            <p:ph type="sldNum" sz="quarter" idx="17"/>
+          </p:nvPr>
+        </p:nvSpPr>
+        <p:spPr/>
+        <p:txBody>
+          <a:bodyPr/>
+          <a:lstStyle/>
+          <a:p>
+            <a:r>
+              <a:rPr lang="en-US"/>
+              <a:t> </a:t>
+            </a:r>
+            <a:endParaRPr lang="en-US" dirty="0"/>
+          </a:p>
+        </p:txBody>
+      </p:sp>
+      <p:sp>
+        <p:nvSpPr>
+          <p:cNvPr id="12" name="Content Placeholder 11">
+            <a:extLst>
+              <a:ext uri="{FF2B5EF4-FFF2-40B4-BE49-F238E27FC236}">
+                <a16:creationId xmlns:a16="http://schemas.microsoft.com/office/drawing/2014/main" id="{EBA4D2BE-3340-E9E1-A8A1-8C1BD6680764}"/>
+              </a:ext>
+            </a:extLst>
+          </p:cNvPr>
+          <p:cNvSpPr>
+            <a:spLocks noGrp="1"/>
+          </p:cNvSpPr>
+          <p:nvPr>
+            <p:ph sz="quarter" idx="14"/>
+          </p:nvPr>
+        </p:nvSpPr>
+        <p:spPr/>
+        <p:txBody>
+          <a:bodyPr/>
+          <a:lstStyle/>
+          <a:p>
             <a:r>
               <a:rPr lang="en-GB" sz="2400" dirty="0">
                 <a:latin typeface="Calibri" panose="020F0502020204030204" pitchFamily="34" charset="0"/>
@@ -24104,106 +24561,19 @@
           </a:p>
         </p:txBody>
       </p:sp>
-      <p:sp>
-        <p:nvSpPr>
-          <p:cNvPr id="3" name="Title 2">
-            <a:extLst>
-              <a:ext uri="{FF2B5EF4-FFF2-40B4-BE49-F238E27FC236}">
-                <a16:creationId xmlns:a16="http://schemas.microsoft.com/office/drawing/2014/main" id="{4281126E-6757-90CE-56A9-3B3BE534AA9B}"/>
-              </a:ext>
-            </a:extLst>
-          </p:cNvPr>
-          <p:cNvSpPr>
-            <a:spLocks noGrp="1"/>
-          </p:cNvSpPr>
-          <p:nvPr>
-            <p:ph type="title"/>
-          </p:nvPr>
-        </p:nvSpPr>
-        <p:spPr/>
-        <p:txBody>
-          <a:bodyPr/>
-          <a:lstStyle/>
-          <a:p>
-            <a:r>
-              <a:rPr lang="en-GB" sz="3200" dirty="0">
-                <a:latin typeface="Calibri" panose="020F0502020204030204" pitchFamily="34" charset="0"/>
-                <a:cs typeface="Calibri" panose="020F0502020204030204" pitchFamily="34" charset="0"/>
-              </a:rPr>
-              <a:t>Infineon WCS Logger – Prerequisites</a:t>
-            </a:r>
-          </a:p>
-        </p:txBody>
-      </p:sp>
-      <p:sp>
-        <p:nvSpPr>
-          <p:cNvPr id="4" name="Footer Placeholder 3">
-            <a:extLst>
-              <a:ext uri="{FF2B5EF4-FFF2-40B4-BE49-F238E27FC236}">
-                <a16:creationId xmlns:a16="http://schemas.microsoft.com/office/drawing/2014/main" id="{0312F4E3-32AD-DA55-1A4A-815B1F644D43}"/>
-              </a:ext>
-            </a:extLst>
-          </p:cNvPr>
-          <p:cNvSpPr>
-            <a:spLocks noGrp="1"/>
-          </p:cNvSpPr>
-          <p:nvPr>
-            <p:ph type="ftr" sz="quarter" idx="16"/>
-          </p:nvPr>
-        </p:nvSpPr>
-        <p:spPr/>
-        <p:txBody>
-          <a:bodyPr/>
-          <a:lstStyle/>
-          <a:p>
-            <a:endParaRPr lang="en-US" dirty="0"/>
-          </a:p>
-        </p:txBody>
-      </p:sp>
-      <p:sp>
-        <p:nvSpPr>
-          <p:cNvPr id="5" name="Slide Number Placeholder 4">
-            <a:extLst>
-              <a:ext uri="{FF2B5EF4-FFF2-40B4-BE49-F238E27FC236}">
-                <a16:creationId xmlns:a16="http://schemas.microsoft.com/office/drawing/2014/main" id="{5523256E-932F-EFAB-7038-27F280525253}"/>
-              </a:ext>
-            </a:extLst>
-          </p:cNvPr>
-          <p:cNvSpPr>
-            <a:spLocks noGrp="1"/>
-          </p:cNvSpPr>
-          <p:nvPr>
-            <p:ph type="sldNum" sz="quarter" idx="17"/>
-          </p:nvPr>
-        </p:nvSpPr>
-        <p:spPr/>
-        <p:txBody>
-          <a:bodyPr/>
-          <a:lstStyle/>
-          <a:p>
-            <a:r>
-              <a:rPr lang="en-US"/>
-              <a:t> </a:t>
-            </a:r>
-            <a:endParaRPr lang="en-US" dirty="0"/>
-          </a:p>
-        </p:txBody>
-      </p:sp>
       <p:pic>
         <p:nvPicPr>
-          <p:cNvPr id="9" name="Content Placeholder 8">
-            <a:extLst>
-              <a:ext uri="{FF2B5EF4-FFF2-40B4-BE49-F238E27FC236}">
-                <a16:creationId xmlns:a16="http://schemas.microsoft.com/office/drawing/2014/main" id="{1764F9DF-3315-16BD-09FB-50F517B96243}"/>
+          <p:cNvPr id="6" name="Picture 5" descr="A screenshot of a computer&#10;&#10;Description automatically generated">
+            <a:extLst>
+              <a:ext uri="{FF2B5EF4-FFF2-40B4-BE49-F238E27FC236}">
+                <a16:creationId xmlns:a16="http://schemas.microsoft.com/office/drawing/2014/main" id="{1559E4FC-4581-C7F6-0A2A-65657972B21F}"/>
               </a:ext>
             </a:extLst>
           </p:cNvPr>
           <p:cNvPicPr>
-            <a:picLocks noGrp="1" noChangeAspect="1"/>
+            <a:picLocks noChangeAspect="1"/>
           </p:cNvPicPr>
-          <p:nvPr>
-            <p:ph sz="quarter" idx="14"/>
-          </p:nvPr>
+          <p:nvPr/>
         </p:nvPicPr>
         <p:blipFill>
           <a:blip r:embed="rId3"/>
@@ -24213,8 +24583,8 @@
         </p:blipFill>
         <p:spPr>
           <a:xfrm>
-            <a:off x="6167438" y="1750161"/>
-            <a:ext cx="5689600" cy="4149840"/>
+            <a:off x="6384032" y="3181885"/>
+            <a:ext cx="5399405" cy="3225165"/>
           </a:xfrm>
           <a:prstGeom prst="rect">
             <a:avLst/>
@@ -24231,112 +24601,6 @@
   <p:clrMapOvr>
     <a:masterClrMapping/>
   </p:clrMapOvr>
-  <p:timing>
-    <p:tnLst>
-      <p:par>
-        <p:cTn id="1" dur="indefinite" restart="never" nodeType="tmRoot">
-          <p:childTnLst>
-            <p:seq concurrent="1" nextAc="seek">
-              <p:cTn id="2" dur="indefinite" nodeType="mainSeq">
-                <p:childTnLst>
-                  <p:par>
-                    <p:cTn id="3" fill="hold">
-                      <p:stCondLst>
-                        <p:cond delay="indefinite"/>
-                      </p:stCondLst>
-                      <p:childTnLst>
-                        <p:par>
-                          <p:cTn id="4" fill="hold">
-                            <p:stCondLst>
-                              <p:cond delay="0"/>
-                            </p:stCondLst>
-                            <p:childTnLst>
-                              <p:par>
-                                <p:cTn id="5" presetID="1" presetClass="entr" presetSubtype="0" fill="hold" nodeType="clickEffect">
-                                  <p:stCondLst>
-                                    <p:cond delay="0"/>
-                                  </p:stCondLst>
-                                  <p:childTnLst>
-                                    <p:set>
-                                      <p:cBhvr>
-                                        <p:cTn id="6" dur="1" fill="hold">
-                                          <p:stCondLst>
-                                            <p:cond delay="0"/>
-                                          </p:stCondLst>
-                                        </p:cTn>
-                                        <p:tgtEl>
-                                          <p:spTgt spid="8">
-                                            <p:txEl>
-                                              <p:pRg st="5" end="5"/>
-                                            </p:txEl>
-                                          </p:spTgt>
-                                        </p:tgtEl>
-                                        <p:attrNameLst>
-                                          <p:attrName>style.visibility</p:attrName>
-                                        </p:attrNameLst>
-                                      </p:cBhvr>
-                                      <p:to>
-                                        <p:strVal val="visible"/>
-                                      </p:to>
-                                    </p:set>
-                                  </p:childTnLst>
-                                </p:cTn>
-                              </p:par>
-                              <p:par>
-                                <p:cTn id="7" presetID="1" presetClass="entr" presetSubtype="0" fill="hold" nodeType="withEffect">
-                                  <p:stCondLst>
-                                    <p:cond delay="0"/>
-                                  </p:stCondLst>
-                                  <p:childTnLst>
-                                    <p:set>
-                                      <p:cBhvr>
-                                        <p:cTn id="8" dur="1" fill="hold">
-                                          <p:stCondLst>
-                                            <p:cond delay="0"/>
-                                          </p:stCondLst>
-                                        </p:cTn>
-                                        <p:tgtEl>
-                                          <p:spTgt spid="9"/>
-                                        </p:tgtEl>
-                                        <p:attrNameLst>
-                                          <p:attrName>style.visibility</p:attrName>
-                                        </p:attrNameLst>
-                                      </p:cBhvr>
-                                      <p:to>
-                                        <p:strVal val="visible"/>
-                                      </p:to>
-                                    </p:set>
-                                  </p:childTnLst>
-                                </p:cTn>
-                              </p:par>
-                            </p:childTnLst>
-                          </p:cTn>
-                        </p:par>
-                      </p:childTnLst>
-                    </p:cTn>
-                  </p:par>
-                </p:childTnLst>
-              </p:cTn>
-              <p:prevCondLst>
-                <p:cond evt="onPrev" delay="0">
-                  <p:tgtEl>
-                    <p:sldTgt/>
-                  </p:tgtEl>
-                </p:cond>
-              </p:prevCondLst>
-              <p:nextCondLst>
-                <p:cond evt="onNext" delay="0">
-                  <p:tgtEl>
-                    <p:sldTgt/>
-                  </p:tgtEl>
-                </p:cond>
-              </p:nextCondLst>
-            </p:seq>
-          </p:childTnLst>
-        </p:cTn>
-      </p:par>
-    </p:tnLst>
-  </p:timing>
 </p:sld>
 </file>
 
@@ -24538,7 +24802,7 @@
                 <a:latin typeface="Calibri" panose="020F0502020204030204" pitchFamily="34" charset="0"/>
                 <a:cs typeface="Calibri" panose="020F0502020204030204" pitchFamily="34" charset="0"/>
               </a:rPr>
-              <a:t>Fill all data</a:t>
+              <a:t>Fill up all data</a:t>
             </a:r>
           </a:p>
         </p:txBody>
@@ -24583,20 +24847,7 @@
                 <a:latin typeface="Calibri" panose="020F0502020204030204" pitchFamily="34" charset="0"/>
                 <a:cs typeface="Calibri" panose="020F0502020204030204" pitchFamily="34" charset="0"/>
               </a:rPr>
-              <a:t>Connect SALEAE </a:t>
-            </a:r>
-            <a:br>
-              <a:rPr lang="en-GB" baseline="0" dirty="0">
-                <a:latin typeface="Calibri" panose="020F0502020204030204" pitchFamily="34" charset="0"/>
-                <a:cs typeface="Calibri" panose="020F0502020204030204" pitchFamily="34" charset="0"/>
-              </a:rPr>
-            </a:br>
-            <a:r>
-              <a:rPr lang="en-GB" baseline="0" dirty="0">
-                <a:latin typeface="Calibri" panose="020F0502020204030204" pitchFamily="34" charset="0"/>
-                <a:cs typeface="Calibri" panose="020F0502020204030204" pitchFamily="34" charset="0"/>
-              </a:rPr>
-              <a:t>pins accordingly</a:t>
+              <a:t>Connect pins accordingly</a:t>
             </a:r>
           </a:p>
         </p:txBody>
@@ -26509,6 +26760,16 @@
                 <a:latin typeface="Calibri" panose="020F0502020204030204" pitchFamily="34" charset="0"/>
                 <a:cs typeface="Calibri" panose="020F0502020204030204" pitchFamily="34" charset="0"/>
               </a:rPr>
+              <a:t>CY4500 log files.</a:t>
+            </a:r>
+          </a:p>
+          <a:p>
+            <a:pPr lvl="2"/>
+            <a:r>
+              <a:rPr lang="en-US" sz="2000" dirty="0">
+                <a:latin typeface="Calibri" panose="020F0502020204030204" pitchFamily="34" charset="0"/>
+                <a:cs typeface="Calibri" panose="020F0502020204030204" pitchFamily="34" charset="0"/>
+              </a:rPr>
               <a:t>Setup log: e.g. 20230522.txt</a:t>
             </a:r>
           </a:p>
@@ -26540,7 +26801,7 @@
                 <a:latin typeface="Calibri" panose="020F0502020204030204" pitchFamily="34" charset="0"/>
                 <a:cs typeface="Calibri" panose="020F0502020204030204" pitchFamily="34" charset="0"/>
               </a:rPr>
-              <a:t>Infineon WCS Logger – How to use (1/2)</a:t>
+              <a:t>Infineon WCS Logger – SALEAE use case (1/2)</a:t>
             </a:r>
           </a:p>
         </p:txBody>
@@ -27011,6 +27272,37 @@
                                   </p:childTnLst>
                                 </p:cTn>
                               </p:par>
+                              <p:par>
+                                <p:cTn id="33" presetID="1" presetClass="entr" presetSubtype="0" fill="hold" nodeType="withEffect">
+                                  <p:stCondLst>
+                                    <p:cond delay="0"/>
+                                  </p:stCondLst>
+                                  <p:childTnLst>
+                                    <p:set>
+                                      <p:cBhvr>
+                                        <p:cTn id="34" dur="1" fill="hold">
+                                          <p:stCondLst>
+                                            <p:cond delay="0"/>
+                                          </p:stCondLst>
+                                        </p:cTn>
+                                        <p:tgtEl>
+                                          <p:spTgt spid="8">
+                                            <p:txEl>
+                                              <p:pRg st="10" end="10"/>
+                                            </p:txEl>
+                                          </p:spTgt>
+                                        </p:tgtEl>
+                                        <p:attrNameLst>
+                                          <p:attrName>style.visibility</p:attrName>
+                                        </p:attrNameLst>
+                                      </p:cBhvr>
+                                      <p:to>
+                                        <p:strVal val="visible"/>
+                                      </p:to>
+                                    </p:set>
+                                  </p:childTnLst>
+                                </p:cTn>
+                              </p:par>
                             </p:childTnLst>
                           </p:cTn>
                         </p:par>
@@ -27247,7 +27539,7 @@
                 <a:latin typeface="Calibri" panose="020F0502020204030204" pitchFamily="34" charset="0"/>
                 <a:cs typeface="Calibri" panose="020F0502020204030204" pitchFamily="34" charset="0"/>
               </a:rPr>
-              <a:t>Infineon WCS Logger – How to use (2/2)</a:t>
+              <a:t>Infineon WCS Logger – SALEAE use case (2/2)</a:t>
             </a:r>
           </a:p>
         </p:txBody>
@@ -27590,7 +27882,7 @@
 </file>
 
 <file path=ppt/slides/slide19.xml><?xml version="1.0" encoding="utf-8"?>
-<p:sld xmlns:a="http://schemas.openxmlformats.org/drawingml/2006/main" xmlns:r="http://schemas.openxmlformats.org/officeDocument/2006/relationships" xmlns:p="http://schemas.openxmlformats.org/presentationml/2006/main" show="0">
+<p:sld xmlns:a="http://schemas.openxmlformats.org/drawingml/2006/main" xmlns:r="http://schemas.openxmlformats.org/officeDocument/2006/relationships" xmlns:p="http://schemas.openxmlformats.org/presentationml/2006/main">
   <p:cSld>
     <p:spTree>
       <p:nvGrpSpPr>
@@ -27608,10 +27900,10 @@
       </p:grpSpPr>
       <p:sp>
         <p:nvSpPr>
-          <p:cNvPr id="3" name="Slide Number Placeholder 2">
-            <a:extLst>
-              <a:ext uri="{FF2B5EF4-FFF2-40B4-BE49-F238E27FC236}">
-                <a16:creationId xmlns:a16="http://schemas.microsoft.com/office/drawing/2014/main" id="{20512F5E-112B-C083-9B4A-D9E0E826CF80}"/>
+          <p:cNvPr id="8" name="Content Placeholder 7">
+            <a:extLst>
+              <a:ext uri="{FF2B5EF4-FFF2-40B4-BE49-F238E27FC236}">
+                <a16:creationId xmlns:a16="http://schemas.microsoft.com/office/drawing/2014/main" id="{3B396EB3-BA26-1A5B-25D9-E11B2ED23345}"/>
               </a:ext>
             </a:extLst>
           </p:cNvPr>
@@ -27619,7 +27911,7 @@
             <a:spLocks noGrp="1"/>
           </p:cNvSpPr>
           <p:nvPr>
-            <p:ph type="sldNum" sz="quarter" idx="15"/>
+            <p:ph sz="quarter" idx="13"/>
           </p:nvPr>
         </p:nvSpPr>
         <p:spPr/>
@@ -27627,21 +27919,444 @@
           <a:bodyPr/>
           <a:lstStyle/>
           <a:p>
-            <a:fld id="{ACA6C892-334C-411F-A2F0-15C6AC846B39}" type="slidenum">
-              <a:rPr lang="en-GB" smtClean="0"/>
-              <a:pPr/>
-              <a:t>19</a:t>
-            </a:fld>
-            <a:endParaRPr lang="en-GB"/>
-          </a:p>
-        </p:txBody>
-      </p:sp>
-      <p:sp>
-        <p:nvSpPr>
-          <p:cNvPr id="4" name="Title 3">
-            <a:extLst>
-              <a:ext uri="{FF2B5EF4-FFF2-40B4-BE49-F238E27FC236}">
-                <a16:creationId xmlns:a16="http://schemas.microsoft.com/office/drawing/2014/main" id="{12D197CE-E082-61EC-0B7B-A8AA81CB72CF}"/>
+            <a:pPr marL="0" indent="0">
+              <a:lnSpc>
+                <a:spcPct val="100000"/>
+              </a:lnSpc>
+              <a:buNone/>
+            </a:pPr>
+            <a:r>
+              <a:rPr lang="en-GB" sz="2400" b="1" dirty="0">
+                <a:latin typeface="Calibri" panose="020F0502020204030204" pitchFamily="34" charset="0"/>
+                <a:cs typeface="Calibri" panose="020F0502020204030204" pitchFamily="34" charset="0"/>
+              </a:rPr>
+              <a:t>Conventional log capture flow</a:t>
+            </a:r>
+          </a:p>
+          <a:p>
+            <a:pPr marL="457200" indent="-457200">
+              <a:lnSpc>
+                <a:spcPct val="100000"/>
+              </a:lnSpc>
+              <a:buFont typeface="+mj-lt"/>
+              <a:buAutoNum type="arabicPeriod"/>
+            </a:pPr>
+            <a:r>
+              <a:rPr lang="en-GB" sz="1600" dirty="0">
+                <a:latin typeface="Calibri" panose="020F0502020204030204" pitchFamily="34" charset="0"/>
+                <a:cs typeface="Calibri" panose="020F0502020204030204" pitchFamily="34" charset="0"/>
+              </a:rPr>
+              <a:t>Open issue tracker form</a:t>
+            </a:r>
+          </a:p>
+          <a:p>
+            <a:pPr marL="457200" indent="-457200">
+              <a:lnSpc>
+                <a:spcPct val="100000"/>
+              </a:lnSpc>
+              <a:buFont typeface="+mj-lt"/>
+              <a:buAutoNum type="arabicPeriod"/>
+            </a:pPr>
+            <a:r>
+              <a:rPr lang="en-GB" sz="1600" dirty="0">
+                <a:latin typeface="Calibri" panose="020F0502020204030204" pitchFamily="34" charset="0"/>
+                <a:cs typeface="Calibri" panose="020F0502020204030204" pitchFamily="34" charset="0"/>
+              </a:rPr>
+              <a:t>Fill up all fields except “waveforms”, 14 fields in total</a:t>
+            </a:r>
+          </a:p>
+          <a:p>
+            <a:pPr marL="457200" indent="-457200">
+              <a:lnSpc>
+                <a:spcPct val="100000"/>
+              </a:lnSpc>
+              <a:buFont typeface="+mj-lt"/>
+              <a:buAutoNum type="arabicPeriod"/>
+            </a:pPr>
+            <a:r>
+              <a:rPr lang="en-GB" sz="1600" dirty="0">
+                <a:latin typeface="Calibri" panose="020F0502020204030204" pitchFamily="34" charset="0"/>
+                <a:cs typeface="Calibri" panose="020F0502020204030204" pitchFamily="34" charset="0"/>
+              </a:rPr>
+              <a:t>Run/Select EZ-PD Protocol Analyzer Utility</a:t>
+            </a:r>
+          </a:p>
+          <a:p>
+            <a:pPr marL="457200" indent="-457200">
+              <a:lnSpc>
+                <a:spcPct val="100000"/>
+              </a:lnSpc>
+              <a:buFont typeface="+mj-lt"/>
+              <a:buAutoNum type="arabicPeriod"/>
+            </a:pPr>
+            <a:r>
+              <a:rPr lang="en-GB" sz="1600" dirty="0">
+                <a:latin typeface="Calibri" panose="020F0502020204030204" pitchFamily="34" charset="0"/>
+                <a:cs typeface="Calibri" panose="020F0502020204030204" pitchFamily="34" charset="0"/>
+              </a:rPr>
+              <a:t>Click “Start”</a:t>
+            </a:r>
+          </a:p>
+          <a:p>
+            <a:pPr marL="457200" indent="-457200">
+              <a:lnSpc>
+                <a:spcPct val="100000"/>
+              </a:lnSpc>
+              <a:buFont typeface="+mj-lt"/>
+              <a:buAutoNum type="arabicPeriod"/>
+            </a:pPr>
+            <a:r>
+              <a:rPr lang="en-GB" sz="1600" dirty="0">
+                <a:latin typeface="Calibri" panose="020F0502020204030204" pitchFamily="34" charset="0"/>
+                <a:cs typeface="Calibri" panose="020F0502020204030204" pitchFamily="34" charset="0"/>
+              </a:rPr>
+              <a:t>Run/Select Saleae Logic2</a:t>
+            </a:r>
+          </a:p>
+          <a:p>
+            <a:pPr marL="457200" indent="-457200">
+              <a:lnSpc>
+                <a:spcPct val="100000"/>
+              </a:lnSpc>
+              <a:buFont typeface="+mj-lt"/>
+              <a:buAutoNum type="arabicPeriod"/>
+            </a:pPr>
+            <a:r>
+              <a:rPr lang="en-GB" sz="1600" dirty="0">
+                <a:latin typeface="Calibri" panose="020F0502020204030204" pitchFamily="34" charset="0"/>
+                <a:cs typeface="Calibri" panose="020F0502020204030204" pitchFamily="34" charset="0"/>
+              </a:rPr>
+              <a:t>Setup channels, mode, bitrate</a:t>
+            </a:r>
+          </a:p>
+          <a:p>
+            <a:pPr marL="457200" indent="-457200">
+              <a:lnSpc>
+                <a:spcPct val="100000"/>
+              </a:lnSpc>
+              <a:buFont typeface="+mj-lt"/>
+              <a:buAutoNum type="arabicPeriod"/>
+            </a:pPr>
+            <a:r>
+              <a:rPr lang="en-GB" sz="1600" dirty="0">
+                <a:latin typeface="Calibri" panose="020F0502020204030204" pitchFamily="34" charset="0"/>
+                <a:cs typeface="Calibri" panose="020F0502020204030204" pitchFamily="34" charset="0"/>
+              </a:rPr>
+              <a:t>Click “Start”</a:t>
+            </a:r>
+          </a:p>
+          <a:p>
+            <a:pPr marL="457200" indent="-457200">
+              <a:lnSpc>
+                <a:spcPct val="100000"/>
+              </a:lnSpc>
+              <a:buFont typeface="+mj-lt"/>
+              <a:buAutoNum type="arabicPeriod"/>
+            </a:pPr>
+            <a:r>
+              <a:rPr lang="en-GB" sz="1600" dirty="0">
+                <a:latin typeface="Calibri" panose="020F0502020204030204" pitchFamily="34" charset="0"/>
+                <a:cs typeface="Calibri" panose="020F0502020204030204" pitchFamily="34" charset="0"/>
+              </a:rPr>
+              <a:t>Reproduce issues</a:t>
+            </a:r>
+          </a:p>
+          <a:p>
+            <a:pPr marL="457200" indent="-457200">
+              <a:lnSpc>
+                <a:spcPct val="100000"/>
+              </a:lnSpc>
+              <a:buFont typeface="+mj-lt"/>
+              <a:buAutoNum type="arabicPeriod"/>
+            </a:pPr>
+            <a:r>
+              <a:rPr lang="en-GB" sz="1600" dirty="0">
+                <a:latin typeface="Calibri" panose="020F0502020204030204" pitchFamily="34" charset="0"/>
+                <a:cs typeface="Calibri" panose="020F0502020204030204" pitchFamily="34" charset="0"/>
+              </a:rPr>
+              <a:t>In EZ-PD Protocol Analyzer Utility</a:t>
+            </a:r>
+          </a:p>
+          <a:p>
+            <a:pPr marL="709200" lvl="1" indent="-457200">
+              <a:lnSpc>
+                <a:spcPct val="100000"/>
+              </a:lnSpc>
+              <a:buFont typeface="+mj-lt"/>
+              <a:buAutoNum type="alphaLcPeriod"/>
+            </a:pPr>
+            <a:r>
+              <a:rPr lang="en-GB" sz="1400" dirty="0">
+                <a:latin typeface="Calibri" panose="020F0502020204030204" pitchFamily="34" charset="0"/>
+                <a:cs typeface="Calibri" panose="020F0502020204030204" pitchFamily="34" charset="0"/>
+              </a:rPr>
+              <a:t>Click “Stop”</a:t>
+            </a:r>
+          </a:p>
+          <a:p>
+            <a:pPr marL="709200" lvl="1" indent="-457200">
+              <a:lnSpc>
+                <a:spcPct val="100000"/>
+              </a:lnSpc>
+              <a:buFont typeface="+mj-lt"/>
+              <a:buAutoNum type="alphaLcPeriod"/>
+            </a:pPr>
+            <a:r>
+              <a:rPr lang="en-GB" sz="1400" dirty="0">
+                <a:latin typeface="Calibri" panose="020F0502020204030204" pitchFamily="34" charset="0"/>
+                <a:cs typeface="Calibri" panose="020F0502020204030204" pitchFamily="34" charset="0"/>
+              </a:rPr>
+              <a:t>Click “Save”</a:t>
+            </a:r>
+          </a:p>
+          <a:p>
+            <a:pPr marL="709200" lvl="1" indent="-457200">
+              <a:lnSpc>
+                <a:spcPct val="100000"/>
+              </a:lnSpc>
+              <a:buFont typeface="+mj-lt"/>
+              <a:buAutoNum type="alphaLcPeriod"/>
+            </a:pPr>
+            <a:r>
+              <a:rPr lang="en-GB" sz="1400" dirty="0">
+                <a:latin typeface="Calibri" panose="020F0502020204030204" pitchFamily="34" charset="0"/>
+                <a:cs typeface="Calibri" panose="020F0502020204030204" pitchFamily="34" charset="0"/>
+              </a:rPr>
+              <a:t>Type file name and save</a:t>
+            </a:r>
+          </a:p>
+          <a:p>
+            <a:pPr marL="709200" lvl="1" indent="-457200">
+              <a:lnSpc>
+                <a:spcPct val="100000"/>
+              </a:lnSpc>
+              <a:buFont typeface="+mj-lt"/>
+              <a:buAutoNum type="alphaLcPeriod"/>
+            </a:pPr>
+            <a:r>
+              <a:rPr lang="en-GB" sz="1400" dirty="0">
+                <a:latin typeface="Calibri" panose="020F0502020204030204" pitchFamily="34" charset="0"/>
+                <a:cs typeface="Calibri" panose="020F0502020204030204" pitchFamily="34" charset="0"/>
+              </a:rPr>
+              <a:t>Click “OK” to close the confirmation dialog</a:t>
+            </a:r>
+          </a:p>
+          <a:p>
+            <a:pPr marL="457200" indent="-457200">
+              <a:lnSpc>
+                <a:spcPct val="100000"/>
+              </a:lnSpc>
+              <a:buFont typeface="+mj-lt"/>
+              <a:buAutoNum type="arabicPeriod"/>
+            </a:pPr>
+            <a:r>
+              <a:rPr lang="en-GB" sz="1600" dirty="0">
+                <a:latin typeface="Calibri" panose="020F0502020204030204" pitchFamily="34" charset="0"/>
+                <a:cs typeface="Calibri" panose="020F0502020204030204" pitchFamily="34" charset="0"/>
+              </a:rPr>
+              <a:t>In Saleae Logic2</a:t>
+            </a:r>
+          </a:p>
+          <a:p>
+            <a:pPr marL="709200" lvl="1" indent="-457200">
+              <a:lnSpc>
+                <a:spcPct val="100000"/>
+              </a:lnSpc>
+              <a:buFont typeface="+mj-lt"/>
+              <a:buAutoNum type="alphaLcPeriod"/>
+            </a:pPr>
+            <a:r>
+              <a:rPr lang="en-GB" sz="1400" dirty="0">
+                <a:latin typeface="Calibri" panose="020F0502020204030204" pitchFamily="34" charset="0"/>
+                <a:cs typeface="Calibri" panose="020F0502020204030204" pitchFamily="34" charset="0"/>
+              </a:rPr>
+              <a:t>Click “Stop”</a:t>
+            </a:r>
+          </a:p>
+          <a:p>
+            <a:pPr marL="709200" lvl="1" indent="-457200">
+              <a:lnSpc>
+                <a:spcPct val="100000"/>
+              </a:lnSpc>
+              <a:buFont typeface="+mj-lt"/>
+              <a:buAutoNum type="alphaLcPeriod"/>
+            </a:pPr>
+            <a:r>
+              <a:rPr lang="en-GB" sz="1400" dirty="0">
+                <a:latin typeface="Calibri" panose="020F0502020204030204" pitchFamily="34" charset="0"/>
+                <a:cs typeface="Calibri" panose="020F0502020204030204" pitchFamily="34" charset="0"/>
+              </a:rPr>
+              <a:t>Assign I2C, UART and CC analysers to channels</a:t>
+            </a:r>
+          </a:p>
+          <a:p>
+            <a:pPr marL="709200" lvl="1" indent="-457200">
+              <a:lnSpc>
+                <a:spcPct val="100000"/>
+              </a:lnSpc>
+              <a:buFont typeface="+mj-lt"/>
+              <a:buAutoNum type="alphaLcPeriod"/>
+            </a:pPr>
+            <a:r>
+              <a:rPr lang="en-GB" sz="1400" dirty="0">
+                <a:latin typeface="Calibri" panose="020F0502020204030204" pitchFamily="34" charset="0"/>
+                <a:cs typeface="Calibri" panose="020F0502020204030204" pitchFamily="34" charset="0"/>
+              </a:rPr>
+              <a:t>Type file name and save</a:t>
+            </a:r>
+          </a:p>
+          <a:p>
+            <a:pPr marL="457200" indent="-457200">
+              <a:lnSpc>
+                <a:spcPct val="100000"/>
+              </a:lnSpc>
+              <a:buFont typeface="+mj-lt"/>
+              <a:buAutoNum type="arabicPeriod"/>
+            </a:pPr>
+            <a:r>
+              <a:rPr lang="en-GB" sz="1600" dirty="0">
+                <a:latin typeface="Calibri" panose="020F0502020204030204" pitchFamily="34" charset="0"/>
+                <a:cs typeface="Calibri" panose="020F0502020204030204" pitchFamily="34" charset="0"/>
+              </a:rPr>
+              <a:t>Fill up “waveforms” field in issue tracker forms with all saved log filenames</a:t>
+            </a:r>
+          </a:p>
+          <a:p>
+            <a:pPr marL="457200" indent="-457200">
+              <a:lnSpc>
+                <a:spcPct val="100000"/>
+              </a:lnSpc>
+              <a:buFont typeface="+mj-lt"/>
+              <a:buAutoNum type="arabicPeriod"/>
+            </a:pPr>
+            <a:r>
+              <a:rPr lang="en-GB" sz="1600" dirty="0">
+                <a:latin typeface="Calibri" panose="020F0502020204030204" pitchFamily="34" charset="0"/>
+                <a:cs typeface="Calibri" panose="020F0502020204030204" pitchFamily="34" charset="0"/>
+              </a:rPr>
+              <a:t>Go to step4 for another log capture round</a:t>
+            </a:r>
+          </a:p>
+        </p:txBody>
+      </p:sp>
+      <p:sp>
+        <p:nvSpPr>
+          <p:cNvPr id="2" name="Content Placeholder 1">
+            <a:extLst>
+              <a:ext uri="{FF2B5EF4-FFF2-40B4-BE49-F238E27FC236}">
+                <a16:creationId xmlns:a16="http://schemas.microsoft.com/office/drawing/2014/main" id="{764284E2-7488-4D77-DF17-1E0DB2DB1960}"/>
+              </a:ext>
+            </a:extLst>
+          </p:cNvPr>
+          <p:cNvSpPr>
+            <a:spLocks noGrp="1"/>
+          </p:cNvSpPr>
+          <p:nvPr>
+            <p:ph sz="quarter" idx="14"/>
+          </p:nvPr>
+        </p:nvSpPr>
+        <p:spPr/>
+        <p:txBody>
+          <a:bodyPr/>
+          <a:lstStyle/>
+          <a:p>
+            <a:pPr marL="0" indent="0">
+              <a:buNone/>
+            </a:pPr>
+            <a:r>
+              <a:rPr lang="en-GB" sz="2400" b="1" dirty="0">
+                <a:latin typeface="Calibri" panose="020F0502020204030204" pitchFamily="34" charset="0"/>
+                <a:cs typeface="Calibri" panose="020F0502020204030204" pitchFamily="34" charset="0"/>
+              </a:rPr>
+              <a:t>In Infineon automation tool flow</a:t>
+            </a:r>
+          </a:p>
+          <a:p>
+            <a:pPr marL="457200" indent="-457200">
+              <a:buFont typeface="+mj-lt"/>
+              <a:buAutoNum type="arabicPeriod"/>
+            </a:pPr>
+            <a:r>
+              <a:rPr lang="en-GB" sz="2400" dirty="0">
+                <a:latin typeface="Calibri" panose="020F0502020204030204" pitchFamily="34" charset="0"/>
+                <a:cs typeface="Calibri" panose="020F0502020204030204" pitchFamily="34" charset="0"/>
+              </a:rPr>
+              <a:t>Run WCS Logger</a:t>
+            </a:r>
+          </a:p>
+          <a:p>
+            <a:pPr marL="457200" indent="-457200">
+              <a:buFont typeface="+mj-lt"/>
+              <a:buAutoNum type="arabicPeriod"/>
+            </a:pPr>
+            <a:r>
+              <a:rPr lang="en-GB" sz="2400" dirty="0">
+                <a:latin typeface="Calibri" panose="020F0502020204030204" pitchFamily="34" charset="0"/>
+                <a:cs typeface="Calibri" panose="020F0502020204030204" pitchFamily="34" charset="0"/>
+              </a:rPr>
+              <a:t>Fill up all blank fields, 10 – 12 in total</a:t>
+            </a:r>
+          </a:p>
+          <a:p>
+            <a:pPr marL="457200" indent="-457200">
+              <a:buFont typeface="+mj-lt"/>
+              <a:buAutoNum type="arabicPeriod"/>
+            </a:pPr>
+            <a:r>
+              <a:rPr lang="en-GB" sz="2400" dirty="0">
+                <a:latin typeface="Calibri" panose="020F0502020204030204" pitchFamily="34" charset="0"/>
+                <a:cs typeface="Calibri" panose="020F0502020204030204" pitchFamily="34" charset="0"/>
+              </a:rPr>
+              <a:t>Click “Start Recording”</a:t>
+            </a:r>
+          </a:p>
+          <a:p>
+            <a:pPr marL="457200" indent="-457200">
+              <a:buFont typeface="+mj-lt"/>
+              <a:buAutoNum type="arabicPeriod"/>
+            </a:pPr>
+            <a:r>
+              <a:rPr lang="en-GB" sz="2400" dirty="0">
+                <a:latin typeface="Calibri" panose="020F0502020204030204" pitchFamily="34" charset="0"/>
+                <a:cs typeface="Calibri" panose="020F0502020204030204" pitchFamily="34" charset="0"/>
+              </a:rPr>
+              <a:t>Reproduce issues</a:t>
+            </a:r>
+          </a:p>
+          <a:p>
+            <a:pPr marL="457200" indent="-457200">
+              <a:buFont typeface="+mj-lt"/>
+              <a:buAutoNum type="arabicPeriod"/>
+            </a:pPr>
+            <a:r>
+              <a:rPr lang="en-GB" sz="2400" dirty="0">
+                <a:latin typeface="Calibri" panose="020F0502020204030204" pitchFamily="34" charset="0"/>
+                <a:cs typeface="Calibri" panose="020F0502020204030204" pitchFamily="34" charset="0"/>
+              </a:rPr>
+              <a:t>Click “Pass case” or “Fail case”</a:t>
+            </a:r>
+          </a:p>
+          <a:p>
+            <a:pPr marL="457200" indent="-457200">
+              <a:buFont typeface="+mj-lt"/>
+              <a:buAutoNum type="arabicPeriod"/>
+            </a:pPr>
+            <a:r>
+              <a:rPr lang="en-GB" sz="2400" dirty="0">
+                <a:latin typeface="Calibri" panose="020F0502020204030204" pitchFamily="34" charset="0"/>
+                <a:cs typeface="Calibri" panose="020F0502020204030204" pitchFamily="34" charset="0"/>
+              </a:rPr>
+              <a:t>Go to step3 for another log capture round</a:t>
+            </a:r>
+          </a:p>
+        </p:txBody>
+      </p:sp>
+      <p:sp>
+        <p:nvSpPr>
+          <p:cNvPr id="3" name="Title 2">
+            <a:extLst>
+              <a:ext uri="{FF2B5EF4-FFF2-40B4-BE49-F238E27FC236}">
+                <a16:creationId xmlns:a16="http://schemas.microsoft.com/office/drawing/2014/main" id="{4281126E-6757-90CE-56A9-3B3BE534AA9B}"/>
               </a:ext>
             </a:extLst>
           </p:cNvPr>
@@ -27658,56 +28373,25 @@
           <a:lstStyle/>
           <a:p>
             <a:r>
-              <a:rPr lang="en-GB" sz="3200" dirty="0">
+              <a:rPr lang="en-US" sz="3200" dirty="0">
                 <a:latin typeface="Calibri" panose="020F0502020204030204" pitchFamily="34" charset="0"/>
                 <a:cs typeface="Calibri" panose="020F0502020204030204" pitchFamily="34" charset="0"/>
               </a:rPr>
-              <a:t>Logs submission</a:t>
-            </a:r>
-          </a:p>
-        </p:txBody>
-      </p:sp>
-      <p:pic>
-        <p:nvPicPr>
-          <p:cNvPr id="8" name="Content Placeholder 15" descr="Graphical user interface, application, Teams&#10;&#10;Description automatically generated">
-            <a:extLst>
-              <a:ext uri="{FF2B5EF4-FFF2-40B4-BE49-F238E27FC236}">
-                <a16:creationId xmlns:a16="http://schemas.microsoft.com/office/drawing/2014/main" id="{5C97427E-76BD-478F-727B-1FC33AD6B63B}"/>
-              </a:ext>
-            </a:extLst>
-          </p:cNvPr>
-          <p:cNvPicPr>
-            <a:picLocks noGrp="1" noChangeAspect="1"/>
-          </p:cNvPicPr>
-          <p:nvPr>
-            <p:ph sz="quarter" idx="13"/>
-          </p:nvPr>
-        </p:nvPicPr>
-        <p:blipFill>
-          <a:blip r:embed="rId2" cstate="print">
-            <a:extLst>
-              <a:ext uri="{28A0092B-C50C-407E-A947-70E740481C1C}">
-                <a14:useLocalDpi xmlns:a14="http://schemas.microsoft.com/office/drawing/2010/main" val="0"/>
-              </a:ext>
-            </a:extLst>
-          </a:blip>
-          <a:stretch>
-            <a:fillRect/>
-          </a:stretch>
-        </p:blipFill>
-        <p:spPr>
-          <a:xfrm>
-            <a:off x="334433" y="1366638"/>
-            <a:ext cx="5664200" cy="4916359"/>
-          </a:xfrm>
-        </p:spPr>
-      </p:pic>
-      <p:sp>
-        <p:nvSpPr>
-          <p:cNvPr id="2" name="IFXSHAPE">
-            <a:extLst>
-              <a:ext uri="{FF2B5EF4-FFF2-40B4-BE49-F238E27FC236}">
-                <a16:creationId xmlns:a16="http://schemas.microsoft.com/office/drawing/2014/main" id="{1C74157E-BDF0-6BE5-C487-283E455AFBC9}"/>
+              <a:t>SOP for log collecting – automation</a:t>
+            </a:r>
+            <a:endParaRPr lang="en-GB" sz="3200" dirty="0">
+              <a:latin typeface="Calibri" panose="020F0502020204030204" pitchFamily="34" charset="0"/>
+              <a:cs typeface="Calibri" panose="020F0502020204030204" pitchFamily="34" charset="0"/>
+            </a:endParaRPr>
+          </a:p>
+        </p:txBody>
+      </p:sp>
+      <p:sp>
+        <p:nvSpPr>
+          <p:cNvPr id="4" name="Footer Placeholder 3">
+            <a:extLst>
+              <a:ext uri="{FF2B5EF4-FFF2-40B4-BE49-F238E27FC236}">
+                <a16:creationId xmlns:a16="http://schemas.microsoft.com/office/drawing/2014/main" id="{0312F4E3-32AD-DA55-1A4A-815B1F644D43}"/>
               </a:ext>
             </a:extLst>
           </p:cNvPr>
@@ -27715,47 +28399,24 @@
             <a:spLocks noGrp="1"/>
           </p:cNvSpPr>
           <p:nvPr>
-            <p:ph type="ftr" sz="quarter" idx="12"/>
-          </p:nvPr>
-        </p:nvSpPr>
-        <p:spPr>
-          <a:xfrm>
-            <a:off x="5711952" y="6541008"/>
-            <a:ext cx="768096" cy="304800"/>
-          </a:xfrm>
-        </p:spPr>
-        <p:txBody>
-          <a:bodyPr vert="horz" wrap="none" lIns="0" tIns="0" rIns="0" bIns="0" rtlCol="0" anchor="ctr">
-            <a:noAutofit/>
-          </a:bodyPr>
-          <a:lstStyle>
-            <a:lvl1pPr algn="ctr" fontAlgn="t">
-              <a:buClr>
-                <a:schemeClr val="accent2"/>
-              </a:buClr>
-              <a:defRPr sz="933" b="0">
-                <a:solidFill>
-                  <a:schemeClr val="accent2"/>
-                </a:solidFill>
-                <a:latin typeface="Arial" panose="020B0604020202020204" pitchFamily="34" charset="0"/>
-              </a:defRPr>
-            </a:lvl1pPr>
-          </a:lstStyle>
-          <a:p>
-            <a:r>
-              <a:rPr lang="en-US" dirty="0"/>
-              <a:t>Copyright © Infineon Technologies AG 2023. All rights reserved.</a:t>
-            </a:r>
-            <a:endParaRPr lang="en-GB" dirty="0"/>
-          </a:p>
-        </p:txBody>
-      </p:sp>
-      <p:sp>
-        <p:nvSpPr>
-          <p:cNvPr id="6" name="IFXSHAPE">
-            <a:extLst>
-              <a:ext uri="{FF2B5EF4-FFF2-40B4-BE49-F238E27FC236}">
-                <a16:creationId xmlns:a16="http://schemas.microsoft.com/office/drawing/2014/main" id="{282FC0F4-8664-2972-96B1-2C3E3D00C17A}"/>
+            <p:ph type="ftr" sz="quarter" idx="16"/>
+          </p:nvPr>
+        </p:nvSpPr>
+        <p:spPr/>
+        <p:txBody>
+          <a:bodyPr/>
+          <a:lstStyle/>
+          <a:p>
+            <a:endParaRPr lang="en-US" dirty="0"/>
+          </a:p>
+        </p:txBody>
+      </p:sp>
+      <p:sp>
+        <p:nvSpPr>
+          <p:cNvPr id="5" name="Slide Number Placeholder 4">
+            <a:extLst>
+              <a:ext uri="{FF2B5EF4-FFF2-40B4-BE49-F238E27FC236}">
+                <a16:creationId xmlns:a16="http://schemas.microsoft.com/office/drawing/2014/main" id="{5523256E-932F-EFAB-7038-27F280525253}"/>
               </a:ext>
             </a:extLst>
           </p:cNvPr>
@@ -27763,63 +28424,7 @@
             <a:spLocks noGrp="1"/>
           </p:cNvSpPr>
           <p:nvPr>
-            <p:ph type="dt" sz="half" idx="11"/>
-          </p:nvPr>
-        </p:nvSpPr>
-        <p:spPr>
-          <a:xfrm>
-            <a:off x="334432" y="6541008"/>
-            <a:ext cx="384048" cy="304800"/>
-          </a:xfrm>
-        </p:spPr>
-        <p:txBody>
-          <a:bodyPr vert="horz" wrap="none" lIns="0" tIns="0" rIns="0" bIns="0" rtlCol="0" anchor="ctr">
-            <a:noAutofit/>
-          </a:bodyPr>
-          <a:lstStyle>
-            <a:lvl1pPr algn="l" fontAlgn="t">
-              <a:buClr>
-                <a:schemeClr val="accent2"/>
-              </a:buClr>
-              <a:defRPr sz="933" b="0">
-                <a:solidFill>
-                  <a:schemeClr val="accent2"/>
-                </a:solidFill>
-                <a:latin typeface="Arial" panose="020B0604020202020204" pitchFamily="34" charset="0"/>
-              </a:defRPr>
-            </a:lvl1pPr>
-          </a:lstStyle>
-          <a:p>
-            <a:fld id="{20CF0657-954C-457B-AB6C-2444DAE1F514}" type="datetime3">
-              <a:rPr lang="en-GB" smtClean="0"/>
-              <a:pPr/>
-              <a:t>24 July, 2023</a:t>
-            </a:fld>
-            <a:r>
-              <a:rPr lang="en-GB" dirty="0"/>
-              <a:t>             </a:t>
-            </a:r>
-            <a:r>
-              <a:rPr lang="en-GB" b="1" dirty="0"/>
-              <a:t>restricted</a:t>
-            </a:r>
-          </a:p>
-        </p:txBody>
-      </p:sp>
-      <p:sp>
-        <p:nvSpPr>
-          <p:cNvPr id="21" name="Content Placeholder 20">
-            <a:extLst>
-              <a:ext uri="{FF2B5EF4-FFF2-40B4-BE49-F238E27FC236}">
-                <a16:creationId xmlns:a16="http://schemas.microsoft.com/office/drawing/2014/main" id="{D9F315A5-4E42-7F2E-EA6D-A3DDBE80FA1C}"/>
-              </a:ext>
-            </a:extLst>
-          </p:cNvPr>
-          <p:cNvSpPr>
-            <a:spLocks noGrp="1"/>
-          </p:cNvSpPr>
-          <p:nvPr>
-            <p:ph sz="quarter" idx="14"/>
+            <p:ph type="sldNum" sz="quarter" idx="17"/>
           </p:nvPr>
         </p:nvSpPr>
         <p:spPr/>
@@ -27828,75 +28433,288 @@
           <a:lstStyle/>
           <a:p>
             <a:r>
-              <a:rPr lang="en-GB" sz="2400" dirty="0">
-                <a:latin typeface="Calibri" panose="020F0502020204030204" pitchFamily="34" charset="0"/>
-                <a:cs typeface="Calibri" panose="020F0502020204030204" pitchFamily="34" charset="0"/>
-              </a:rPr>
-              <a:t>Zip all files and submit to case</a:t>
-            </a:r>
-          </a:p>
-        </p:txBody>
-      </p:sp>
-      <p:sp>
-        <p:nvSpPr>
-          <p:cNvPr id="23" name="Rectangle: Rounded Corners 22">
-            <a:extLst>
-              <a:ext uri="{FF2B5EF4-FFF2-40B4-BE49-F238E27FC236}">
-                <a16:creationId xmlns:a16="http://schemas.microsoft.com/office/drawing/2014/main" id="{DC250BD8-1DD1-FE09-4598-FE016711DEF2}"/>
-              </a:ext>
-            </a:extLst>
-          </p:cNvPr>
-          <p:cNvSpPr/>
-          <p:nvPr/>
-        </p:nvSpPr>
-        <p:spPr bwMode="auto">
-          <a:xfrm>
-            <a:off x="191344" y="4165609"/>
-            <a:ext cx="1512168" cy="319127"/>
-          </a:xfrm>
-          <a:prstGeom prst="roundRect">
-            <a:avLst/>
-          </a:prstGeom>
-          <a:noFill/>
-          <a:ln w="28575">
-            <a:solidFill>
-              <a:schemeClr val="accent1"/>
-            </a:solidFill>
-            <a:miter lim="800000"/>
-            <a:headEnd/>
-            <a:tailEnd/>
-          </a:ln>
-        </p:spPr>
-        <p:txBody>
-          <a:bodyPr wrap="square" lIns="72000" tIns="72000" rIns="72000" bIns="72000" rtlCol="0" anchor="ctr"/>
-          <a:lstStyle/>
-          <a:p>
-            <a:pPr algn="ctr" defTabSz="576000" eaLnBrk="0" hangingPunct="0">
-              <a:lnSpc>
-                <a:spcPct val="120000"/>
-              </a:lnSpc>
-            </a:pPr>
-            <a:endParaRPr lang="en-GB" sz="1600" baseline="0" dirty="0">
-              <a:solidFill>
-                <a:schemeClr val="bg1"/>
-              </a:solidFill>
-              <a:latin typeface="+mn-lt"/>
-              <a:ea typeface="+mn-ea"/>
-              <a:cs typeface="+mn-cs"/>
-            </a:endParaRPr>
+              <a:rPr lang="en-US"/>
+              <a:t> </a:t>
+            </a:r>
+            <a:endParaRPr lang="en-US" dirty="0"/>
           </a:p>
         </p:txBody>
       </p:sp>
     </p:spTree>
     <p:extLst>
       <p:ext uri="{BB962C8B-B14F-4D97-AF65-F5344CB8AC3E}">
-        <p14:creationId xmlns:p14="http://schemas.microsoft.com/office/powerpoint/2010/main" val="4087149355"/>
+        <p14:creationId xmlns:p14="http://schemas.microsoft.com/office/powerpoint/2010/main" val="3336396546"/>
       </p:ext>
     </p:extLst>
   </p:cSld>
   <p:clrMapOvr>
     <a:masterClrMapping/>
   </p:clrMapOvr>
+  <p:timing>
+    <p:tnLst>
+      <p:par>
+        <p:cTn id="1" dur="indefinite" restart="never" nodeType="tmRoot">
+          <p:childTnLst>
+            <p:seq concurrent="1" nextAc="seek">
+              <p:cTn id="2" dur="indefinite" nodeType="mainSeq">
+                <p:childTnLst>
+                  <p:par>
+                    <p:cTn id="3" fill="hold">
+                      <p:stCondLst>
+                        <p:cond delay="indefinite"/>
+                      </p:stCondLst>
+                      <p:childTnLst>
+                        <p:par>
+                          <p:cTn id="4" fill="hold">
+                            <p:stCondLst>
+                              <p:cond delay="0"/>
+                            </p:stCondLst>
+                            <p:childTnLst>
+                              <p:par>
+                                <p:cTn id="5" presetID="1" presetClass="entr" presetSubtype="0" fill="hold" nodeType="clickEffect">
+                                  <p:stCondLst>
+                                    <p:cond delay="0"/>
+                                  </p:stCondLst>
+                                  <p:childTnLst>
+                                    <p:set>
+                                      <p:cBhvr>
+                                        <p:cTn id="6" dur="1" fill="hold">
+                                          <p:stCondLst>
+                                            <p:cond delay="0"/>
+                                          </p:stCondLst>
+                                        </p:cTn>
+                                        <p:tgtEl>
+                                          <p:spTgt spid="2">
+                                            <p:txEl>
+                                              <p:pRg st="0" end="0"/>
+                                            </p:txEl>
+                                          </p:spTgt>
+                                        </p:tgtEl>
+                                        <p:attrNameLst>
+                                          <p:attrName>style.visibility</p:attrName>
+                                        </p:attrNameLst>
+                                      </p:cBhvr>
+                                      <p:to>
+                                        <p:strVal val="visible"/>
+                                      </p:to>
+                                    </p:set>
+                                  </p:childTnLst>
+                                </p:cTn>
+                              </p:par>
+                              <p:par>
+                                <p:cTn id="7" presetID="1" presetClass="entr" presetSubtype="0" fill="hold" nodeType="withEffect">
+                                  <p:stCondLst>
+                                    <p:cond delay="0"/>
+                                  </p:stCondLst>
+                                  <p:childTnLst>
+                                    <p:set>
+                                      <p:cBhvr>
+                                        <p:cTn id="8" dur="1" fill="hold">
+                                          <p:stCondLst>
+                                            <p:cond delay="0"/>
+                                          </p:stCondLst>
+                                        </p:cTn>
+                                        <p:tgtEl>
+                                          <p:spTgt spid="2">
+                                            <p:txEl>
+                                              <p:pRg st="1" end="1"/>
+                                            </p:txEl>
+                                          </p:spTgt>
+                                        </p:tgtEl>
+                                        <p:attrNameLst>
+                                          <p:attrName>style.visibility</p:attrName>
+                                        </p:attrNameLst>
+                                      </p:cBhvr>
+                                      <p:to>
+                                        <p:strVal val="visible"/>
+                                      </p:to>
+                                    </p:set>
+                                  </p:childTnLst>
+                                </p:cTn>
+                              </p:par>
+                              <p:par>
+                                <p:cTn id="9" presetID="1" presetClass="entr" presetSubtype="0" fill="hold" nodeType="withEffect">
+                                  <p:stCondLst>
+                                    <p:cond delay="0"/>
+                                  </p:stCondLst>
+                                  <p:childTnLst>
+                                    <p:set>
+                                      <p:cBhvr>
+                                        <p:cTn id="10" dur="1" fill="hold">
+                                          <p:stCondLst>
+                                            <p:cond delay="0"/>
+                                          </p:stCondLst>
+                                        </p:cTn>
+                                        <p:tgtEl>
+                                          <p:spTgt spid="2">
+                                            <p:txEl>
+                                              <p:pRg st="2" end="2"/>
+                                            </p:txEl>
+                                          </p:spTgt>
+                                        </p:tgtEl>
+                                        <p:attrNameLst>
+                                          <p:attrName>style.visibility</p:attrName>
+                                        </p:attrNameLst>
+                                      </p:cBhvr>
+                                      <p:to>
+                                        <p:strVal val="visible"/>
+                                      </p:to>
+                                    </p:set>
+                                  </p:childTnLst>
+                                </p:cTn>
+                              </p:par>
+                              <p:par>
+                                <p:cTn id="11" presetID="1" presetClass="entr" presetSubtype="0" fill="hold" nodeType="withEffect">
+                                  <p:stCondLst>
+                                    <p:cond delay="0"/>
+                                  </p:stCondLst>
+                                  <p:childTnLst>
+                                    <p:set>
+                                      <p:cBhvr>
+                                        <p:cTn id="12" dur="1" fill="hold">
+                                          <p:stCondLst>
+                                            <p:cond delay="0"/>
+                                          </p:stCondLst>
+                                        </p:cTn>
+                                        <p:tgtEl>
+                                          <p:spTgt spid="2">
+                                            <p:txEl>
+                                              <p:pRg st="3" end="3"/>
+                                            </p:txEl>
+                                          </p:spTgt>
+                                        </p:tgtEl>
+                                        <p:attrNameLst>
+                                          <p:attrName>style.visibility</p:attrName>
+                                        </p:attrNameLst>
+                                      </p:cBhvr>
+                                      <p:to>
+                                        <p:strVal val="visible"/>
+                                      </p:to>
+                                    </p:set>
+                                  </p:childTnLst>
+                                </p:cTn>
+                              </p:par>
+                              <p:par>
+                                <p:cTn id="13" presetID="1" presetClass="entr" presetSubtype="0" fill="hold" nodeType="withEffect">
+                                  <p:stCondLst>
+                                    <p:cond delay="0"/>
+                                  </p:stCondLst>
+                                  <p:childTnLst>
+                                    <p:set>
+                                      <p:cBhvr>
+                                        <p:cTn id="14" dur="1" fill="hold">
+                                          <p:stCondLst>
+                                            <p:cond delay="0"/>
+                                          </p:stCondLst>
+                                        </p:cTn>
+                                        <p:tgtEl>
+                                          <p:spTgt spid="2">
+                                            <p:txEl>
+                                              <p:pRg st="4" end="4"/>
+                                            </p:txEl>
+                                          </p:spTgt>
+                                        </p:tgtEl>
+                                        <p:attrNameLst>
+                                          <p:attrName>style.visibility</p:attrName>
+                                        </p:attrNameLst>
+                                      </p:cBhvr>
+                                      <p:to>
+                                        <p:strVal val="visible"/>
+                                      </p:to>
+                                    </p:set>
+                                  </p:childTnLst>
+                                </p:cTn>
+                              </p:par>
+                              <p:par>
+                                <p:cTn id="15" presetID="1" presetClass="entr" presetSubtype="0" fill="hold" nodeType="withEffect">
+                                  <p:stCondLst>
+                                    <p:cond delay="0"/>
+                                  </p:stCondLst>
+                                  <p:childTnLst>
+                                    <p:set>
+                                      <p:cBhvr>
+                                        <p:cTn id="16" dur="1" fill="hold">
+                                          <p:stCondLst>
+                                            <p:cond delay="0"/>
+                                          </p:stCondLst>
+                                        </p:cTn>
+                                        <p:tgtEl>
+                                          <p:spTgt spid="2">
+                                            <p:txEl>
+                                              <p:pRg st="5" end="5"/>
+                                            </p:txEl>
+                                          </p:spTgt>
+                                        </p:tgtEl>
+                                        <p:attrNameLst>
+                                          <p:attrName>style.visibility</p:attrName>
+                                        </p:attrNameLst>
+                                      </p:cBhvr>
+                                      <p:to>
+                                        <p:strVal val="visible"/>
+                                      </p:to>
+                                    </p:set>
+                                  </p:childTnLst>
+                                </p:cTn>
+                              </p:par>
+                              <p:par>
+                                <p:cTn id="17" presetID="1" presetClass="entr" presetSubtype="0" fill="hold" nodeType="withEffect">
+                                  <p:stCondLst>
+                                    <p:cond delay="0"/>
+                                  </p:stCondLst>
+                                  <p:childTnLst>
+                                    <p:set>
+                                      <p:cBhvr>
+                                        <p:cTn id="18" dur="1" fill="hold">
+                                          <p:stCondLst>
+                                            <p:cond delay="0"/>
+                                          </p:stCondLst>
+                                        </p:cTn>
+                                        <p:tgtEl>
+                                          <p:spTgt spid="2">
+                                            <p:txEl>
+                                              <p:pRg st="6" end="6"/>
+                                            </p:txEl>
+                                          </p:spTgt>
+                                        </p:tgtEl>
+                                        <p:attrNameLst>
+                                          <p:attrName>style.visibility</p:attrName>
+                                        </p:attrNameLst>
+                                      </p:cBhvr>
+                                      <p:to>
+                                        <p:strVal val="visible"/>
+                                      </p:to>
+                                    </p:set>
+                                  </p:childTnLst>
+                                </p:cTn>
+                              </p:par>
+                            </p:childTnLst>
+                          </p:cTn>
+                        </p:par>
+                      </p:childTnLst>
+                    </p:cTn>
+                  </p:par>
+                </p:childTnLst>
+              </p:cTn>
+              <p:prevCondLst>
+                <p:cond evt="onPrev" delay="0">
+                  <p:tgtEl>
+                    <p:sldTgt/>
+                  </p:tgtEl>
+                </p:cond>
+              </p:prevCondLst>
+              <p:nextCondLst>
+                <p:cond evt="onNext" delay="0">
+                  <p:tgtEl>
+                    <p:sldTgt/>
+                  </p:tgtEl>
+                </p:cond>
+              </p:nextCondLst>
+            </p:seq>
+          </p:childTnLst>
+        </p:cTn>
+      </p:par>
+    </p:tnLst>
+  </p:timing>
 </p:sld>
 </file>
 
@@ -28071,7 +28889,7 @@
             <a:fld id="{20CF0657-954C-457B-AB6C-2444DAE1F514}" type="datetime3">
               <a:rPr lang="en-GB" smtClean="0"/>
               <a:pPr/>
-              <a:t>24 July, 2023</a:t>
+              <a:t>9 August, 2023</a:t>
             </a:fld>
             <a:r>
               <a:rPr lang="en-GB" dirty="0"/>
@@ -28178,7 +28996,7 @@
 </file>
 
 <file path=ppt/slides/slide20.xml><?xml version="1.0" encoding="utf-8"?>
-<p:sld xmlns:a="http://schemas.openxmlformats.org/drawingml/2006/main" xmlns:r="http://schemas.openxmlformats.org/officeDocument/2006/relationships" xmlns:p="http://schemas.openxmlformats.org/presentationml/2006/main">
+<p:sld xmlns:a="http://schemas.openxmlformats.org/drawingml/2006/main" xmlns:r="http://schemas.openxmlformats.org/officeDocument/2006/relationships" xmlns:p="http://schemas.openxmlformats.org/presentationml/2006/main" show="0">
   <p:cSld>
     <p:spTree>
       <p:nvGrpSpPr>
@@ -28196,10 +29014,10 @@
       </p:grpSpPr>
       <p:sp>
         <p:nvSpPr>
-          <p:cNvPr id="8" name="Content Placeholder 7">
-            <a:extLst>
-              <a:ext uri="{FF2B5EF4-FFF2-40B4-BE49-F238E27FC236}">
-                <a16:creationId xmlns:a16="http://schemas.microsoft.com/office/drawing/2014/main" id="{3B396EB3-BA26-1A5B-25D9-E11B2ED23345}"/>
+          <p:cNvPr id="3" name="Slide Number Placeholder 2">
+            <a:extLst>
+              <a:ext uri="{FF2B5EF4-FFF2-40B4-BE49-F238E27FC236}">
+                <a16:creationId xmlns:a16="http://schemas.microsoft.com/office/drawing/2014/main" id="{20512F5E-112B-C083-9B4A-D9E0E826CF80}"/>
               </a:ext>
             </a:extLst>
           </p:cNvPr>
@@ -28207,7 +29025,7 @@
             <a:spLocks noGrp="1"/>
           </p:cNvSpPr>
           <p:nvPr>
-            <p:ph sz="quarter" idx="13"/>
+            <p:ph type="sldNum" sz="quarter" idx="15"/>
           </p:nvPr>
         </p:nvSpPr>
         <p:spPr/>
@@ -28215,64 +29033,21 @@
           <a:bodyPr/>
           <a:lstStyle/>
           <a:p>
-            <a:r>
-              <a:rPr lang="en-GB" sz="2400" dirty="0">
-                <a:latin typeface="Calibri" panose="020F0502020204030204" pitchFamily="34" charset="0"/>
-                <a:cs typeface="Calibri" panose="020F0502020204030204" pitchFamily="34" charset="0"/>
-              </a:rPr>
-              <a:t>Logger might crash if PC doesn't install SALEAE Logic2 application.</a:t>
-            </a:r>
-          </a:p>
-          <a:p>
-            <a:r>
-              <a:rPr lang="en-GB" sz="2400" dirty="0">
-                <a:latin typeface="Calibri" panose="020F0502020204030204" pitchFamily="34" charset="0"/>
-                <a:cs typeface="Calibri" panose="020F0502020204030204" pitchFamily="34" charset="0"/>
-              </a:rPr>
-              <a:t>Logger might crash if SALEAE Logic2 application doesn't enable "Automation Server" at Scenario B.</a:t>
-            </a:r>
-          </a:p>
-          <a:p>
-            <a:r>
-              <a:rPr lang="en-GB" sz="2400" dirty="0">
-                <a:latin typeface="Calibri" panose="020F0502020204030204" pitchFamily="34" charset="0"/>
-                <a:cs typeface="Calibri" panose="020F0502020204030204" pitchFamily="34" charset="0"/>
-              </a:rPr>
-              <a:t>Doesn't support SALEAE Logic Analyser 8ch SKU.</a:t>
-            </a:r>
-          </a:p>
-          <a:p>
-            <a:r>
-              <a:rPr lang="en-GB" sz="2400" dirty="0">
-                <a:latin typeface="Calibri" panose="020F0502020204030204" pitchFamily="34" charset="0"/>
-                <a:cs typeface="Calibri" panose="020F0502020204030204" pitchFamily="34" charset="0"/>
-              </a:rPr>
-              <a:t>DO NOT control SALEAE Logic2 application directly.</a:t>
-            </a:r>
-          </a:p>
-          <a:p>
-            <a:r>
-              <a:rPr lang="en-GB" sz="2400" dirty="0">
-                <a:latin typeface="Calibri" panose="020F0502020204030204" pitchFamily="34" charset="0"/>
-                <a:cs typeface="Calibri" panose="020F0502020204030204" pitchFamily="34" charset="0"/>
-              </a:rPr>
-              <a:t>Logger cannot rename channel names in SALEAE logs. </a:t>
-            </a:r>
-          </a:p>
-          <a:p>
-            <a:endParaRPr lang="en-GB" sz="2400" dirty="0">
-              <a:latin typeface="Calibri" panose="020F0502020204030204" pitchFamily="34" charset="0"/>
-              <a:cs typeface="Calibri" panose="020F0502020204030204" pitchFamily="34" charset="0"/>
-            </a:endParaRPr>
-          </a:p>
-        </p:txBody>
-      </p:sp>
-      <p:sp>
-        <p:nvSpPr>
-          <p:cNvPr id="3" name="Title 2">
-            <a:extLst>
-              <a:ext uri="{FF2B5EF4-FFF2-40B4-BE49-F238E27FC236}">
-                <a16:creationId xmlns:a16="http://schemas.microsoft.com/office/drawing/2014/main" id="{4281126E-6757-90CE-56A9-3B3BE534AA9B}"/>
+            <a:fld id="{ACA6C892-334C-411F-A2F0-15C6AC846B39}" type="slidenum">
+              <a:rPr lang="en-GB" smtClean="0"/>
+              <a:pPr/>
+              <a:t>20</a:t>
+            </a:fld>
+            <a:endParaRPr lang="en-GB"/>
+          </a:p>
+        </p:txBody>
+      </p:sp>
+      <p:sp>
+        <p:nvSpPr>
+          <p:cNvPr id="4" name="Title 3">
+            <a:extLst>
+              <a:ext uri="{FF2B5EF4-FFF2-40B4-BE49-F238E27FC236}">
+                <a16:creationId xmlns:a16="http://schemas.microsoft.com/office/drawing/2014/main" id="{12D197CE-E082-61EC-0B7B-A8AA81CB72CF}"/>
               </a:ext>
             </a:extLst>
           </p:cNvPr>
@@ -28293,17 +29068,52 @@
                 <a:latin typeface="Calibri" panose="020F0502020204030204" pitchFamily="34" charset="0"/>
                 <a:cs typeface="Calibri" panose="020F0502020204030204" pitchFamily="34" charset="0"/>
               </a:rPr>
-              <a:t>Infineon WCS Logger – Limitations</a:t>
-            </a:r>
-          </a:p>
-        </p:txBody>
-      </p:sp>
-      <p:sp>
-        <p:nvSpPr>
-          <p:cNvPr id="4" name="Footer Placeholder 3">
-            <a:extLst>
-              <a:ext uri="{FF2B5EF4-FFF2-40B4-BE49-F238E27FC236}">
-                <a16:creationId xmlns:a16="http://schemas.microsoft.com/office/drawing/2014/main" id="{0312F4E3-32AD-DA55-1A4A-815B1F644D43}"/>
+              <a:t>Logs submission</a:t>
+            </a:r>
+          </a:p>
+        </p:txBody>
+      </p:sp>
+      <p:pic>
+        <p:nvPicPr>
+          <p:cNvPr id="8" name="Content Placeholder 15" descr="Graphical user interface, application, Teams&#10;&#10;Description automatically generated">
+            <a:extLst>
+              <a:ext uri="{FF2B5EF4-FFF2-40B4-BE49-F238E27FC236}">
+                <a16:creationId xmlns:a16="http://schemas.microsoft.com/office/drawing/2014/main" id="{5C97427E-76BD-478F-727B-1FC33AD6B63B}"/>
+              </a:ext>
+            </a:extLst>
+          </p:cNvPr>
+          <p:cNvPicPr>
+            <a:picLocks noGrp="1" noChangeAspect="1"/>
+          </p:cNvPicPr>
+          <p:nvPr>
+            <p:ph sz="quarter" idx="13"/>
+          </p:nvPr>
+        </p:nvPicPr>
+        <p:blipFill>
+          <a:blip r:embed="rId2" cstate="print">
+            <a:extLst>
+              <a:ext uri="{28A0092B-C50C-407E-A947-70E740481C1C}">
+                <a14:useLocalDpi xmlns:a14="http://schemas.microsoft.com/office/drawing/2010/main" val="0"/>
+              </a:ext>
+            </a:extLst>
+          </a:blip>
+          <a:stretch>
+            <a:fillRect/>
+          </a:stretch>
+        </p:blipFill>
+        <p:spPr>
+          <a:xfrm>
+            <a:off x="334433" y="1366638"/>
+            <a:ext cx="5664200" cy="4916359"/>
+          </a:xfrm>
+        </p:spPr>
+      </p:pic>
+      <p:sp>
+        <p:nvSpPr>
+          <p:cNvPr id="2" name="IFXSHAPE">
+            <a:extLst>
+              <a:ext uri="{FF2B5EF4-FFF2-40B4-BE49-F238E27FC236}">
+                <a16:creationId xmlns:a16="http://schemas.microsoft.com/office/drawing/2014/main" id="{1C74157E-BDF0-6BE5-C487-283E455AFBC9}"/>
               </a:ext>
             </a:extLst>
           </p:cNvPr>
@@ -28311,24 +29121,47 @@
             <a:spLocks noGrp="1"/>
           </p:cNvSpPr>
           <p:nvPr>
-            <p:ph type="ftr" sz="quarter" idx="15"/>
-          </p:nvPr>
-        </p:nvSpPr>
-        <p:spPr/>
-        <p:txBody>
-          <a:bodyPr/>
-          <a:lstStyle/>
-          <a:p>
-            <a:endParaRPr lang="en-US" dirty="0"/>
-          </a:p>
-        </p:txBody>
-      </p:sp>
-      <p:sp>
-        <p:nvSpPr>
-          <p:cNvPr id="5" name="Slide Number Placeholder 4">
-            <a:extLst>
-              <a:ext uri="{FF2B5EF4-FFF2-40B4-BE49-F238E27FC236}">
-                <a16:creationId xmlns:a16="http://schemas.microsoft.com/office/drawing/2014/main" id="{5523256E-932F-EFAB-7038-27F280525253}"/>
+            <p:ph type="ftr" sz="quarter" idx="12"/>
+          </p:nvPr>
+        </p:nvSpPr>
+        <p:spPr>
+          <a:xfrm>
+            <a:off x="5711952" y="6541008"/>
+            <a:ext cx="768096" cy="304800"/>
+          </a:xfrm>
+        </p:spPr>
+        <p:txBody>
+          <a:bodyPr vert="horz" wrap="none" lIns="0" tIns="0" rIns="0" bIns="0" rtlCol="0" anchor="ctr">
+            <a:noAutofit/>
+          </a:bodyPr>
+          <a:lstStyle>
+            <a:lvl1pPr algn="ctr" fontAlgn="t">
+              <a:buClr>
+                <a:schemeClr val="accent2"/>
+              </a:buClr>
+              <a:defRPr sz="933" b="0">
+                <a:solidFill>
+                  <a:schemeClr val="accent2"/>
+                </a:solidFill>
+                <a:latin typeface="Arial" panose="020B0604020202020204" pitchFamily="34" charset="0"/>
+              </a:defRPr>
+            </a:lvl1pPr>
+          </a:lstStyle>
+          <a:p>
+            <a:r>
+              <a:rPr lang="en-US" dirty="0"/>
+              <a:t>Copyright © Infineon Technologies AG 2023. All rights reserved.</a:t>
+            </a:r>
+            <a:endParaRPr lang="en-GB" dirty="0"/>
+          </a:p>
+        </p:txBody>
+      </p:sp>
+      <p:sp>
+        <p:nvSpPr>
+          <p:cNvPr id="6" name="IFXSHAPE">
+            <a:extLst>
+              <a:ext uri="{FF2B5EF4-FFF2-40B4-BE49-F238E27FC236}">
+                <a16:creationId xmlns:a16="http://schemas.microsoft.com/office/drawing/2014/main" id="{282FC0F4-8664-2972-96B1-2C3E3D00C17A}"/>
               </a:ext>
             </a:extLst>
           </p:cNvPr>
@@ -28336,7 +29169,63 @@
             <a:spLocks noGrp="1"/>
           </p:cNvSpPr>
           <p:nvPr>
-            <p:ph type="sldNum" sz="quarter" idx="16"/>
+            <p:ph type="dt" sz="half" idx="11"/>
+          </p:nvPr>
+        </p:nvSpPr>
+        <p:spPr>
+          <a:xfrm>
+            <a:off x="334432" y="6541008"/>
+            <a:ext cx="384048" cy="304800"/>
+          </a:xfrm>
+        </p:spPr>
+        <p:txBody>
+          <a:bodyPr vert="horz" wrap="none" lIns="0" tIns="0" rIns="0" bIns="0" rtlCol="0" anchor="ctr">
+            <a:noAutofit/>
+          </a:bodyPr>
+          <a:lstStyle>
+            <a:lvl1pPr algn="l" fontAlgn="t">
+              <a:buClr>
+                <a:schemeClr val="accent2"/>
+              </a:buClr>
+              <a:defRPr sz="933" b="0">
+                <a:solidFill>
+                  <a:schemeClr val="accent2"/>
+                </a:solidFill>
+                <a:latin typeface="Arial" panose="020B0604020202020204" pitchFamily="34" charset="0"/>
+              </a:defRPr>
+            </a:lvl1pPr>
+          </a:lstStyle>
+          <a:p>
+            <a:fld id="{20CF0657-954C-457B-AB6C-2444DAE1F514}" type="datetime3">
+              <a:rPr lang="en-GB" smtClean="0"/>
+              <a:pPr/>
+              <a:t>9 August, 2023</a:t>
+            </a:fld>
+            <a:r>
+              <a:rPr lang="en-GB" dirty="0"/>
+              <a:t>             </a:t>
+            </a:r>
+            <a:r>
+              <a:rPr lang="en-GB" b="1" dirty="0"/>
+              <a:t>restricted</a:t>
+            </a:r>
+          </a:p>
+        </p:txBody>
+      </p:sp>
+      <p:sp>
+        <p:nvSpPr>
+          <p:cNvPr id="21" name="Content Placeholder 20">
+            <a:extLst>
+              <a:ext uri="{FF2B5EF4-FFF2-40B4-BE49-F238E27FC236}">
+                <a16:creationId xmlns:a16="http://schemas.microsoft.com/office/drawing/2014/main" id="{D9F315A5-4E42-7F2E-EA6D-A3DDBE80FA1C}"/>
+              </a:ext>
+            </a:extLst>
+          </p:cNvPr>
+          <p:cNvSpPr>
+            <a:spLocks noGrp="1"/>
+          </p:cNvSpPr>
+          <p:nvPr>
+            <p:ph sz="quarter" idx="14"/>
           </p:nvPr>
         </p:nvSpPr>
         <p:spPr/>
@@ -28345,17 +29234,69 @@
           <a:lstStyle/>
           <a:p>
             <a:r>
-              <a:rPr lang="en-US"/>
-              <a:t> </a:t>
-            </a:r>
-            <a:endParaRPr lang="en-US" dirty="0"/>
+              <a:rPr lang="en-GB" sz="2400" dirty="0">
+                <a:latin typeface="Calibri" panose="020F0502020204030204" pitchFamily="34" charset="0"/>
+                <a:cs typeface="Calibri" panose="020F0502020204030204" pitchFamily="34" charset="0"/>
+              </a:rPr>
+              <a:t>Zip all files and submit to case</a:t>
+            </a:r>
+          </a:p>
+        </p:txBody>
+      </p:sp>
+      <p:sp>
+        <p:nvSpPr>
+          <p:cNvPr id="23" name="Rectangle: Rounded Corners 22">
+            <a:extLst>
+              <a:ext uri="{FF2B5EF4-FFF2-40B4-BE49-F238E27FC236}">
+                <a16:creationId xmlns:a16="http://schemas.microsoft.com/office/drawing/2014/main" id="{DC250BD8-1DD1-FE09-4598-FE016711DEF2}"/>
+              </a:ext>
+            </a:extLst>
+          </p:cNvPr>
+          <p:cNvSpPr/>
+          <p:nvPr/>
+        </p:nvSpPr>
+        <p:spPr bwMode="auto">
+          <a:xfrm>
+            <a:off x="191344" y="4165609"/>
+            <a:ext cx="1512168" cy="319127"/>
+          </a:xfrm>
+          <a:prstGeom prst="roundRect">
+            <a:avLst/>
+          </a:prstGeom>
+          <a:noFill/>
+          <a:ln w="28575">
+            <a:solidFill>
+              <a:schemeClr val="accent1"/>
+            </a:solidFill>
+            <a:miter lim="800000"/>
+            <a:headEnd/>
+            <a:tailEnd/>
+          </a:ln>
+        </p:spPr>
+        <p:txBody>
+          <a:bodyPr wrap="square" lIns="72000" tIns="72000" rIns="72000" bIns="72000" rtlCol="0" anchor="ctr"/>
+          <a:lstStyle/>
+          <a:p>
+            <a:pPr algn="ctr" defTabSz="576000" eaLnBrk="0" hangingPunct="0">
+              <a:lnSpc>
+                <a:spcPct val="120000"/>
+              </a:lnSpc>
+            </a:pPr>
+            <a:endParaRPr lang="en-GB" sz="1600" baseline="0" dirty="0">
+              <a:solidFill>
+                <a:schemeClr val="bg1"/>
+              </a:solidFill>
+              <a:latin typeface="+mn-lt"/>
+              <a:ea typeface="+mn-ea"/>
+              <a:cs typeface="+mn-cs"/>
+            </a:endParaRPr>
           </a:p>
         </p:txBody>
       </p:sp>
     </p:spTree>
     <p:extLst>
       <p:ext uri="{BB962C8B-B14F-4D97-AF65-F5344CB8AC3E}">
-        <p14:creationId xmlns:p14="http://schemas.microsoft.com/office/powerpoint/2010/main" val="2452428533"/>
+        <p14:creationId xmlns:p14="http://schemas.microsoft.com/office/powerpoint/2010/main" val="4087149355"/>
       </p:ext>
     </p:extLst>
   </p:cSld>
@@ -28366,6 +29307,185 @@
 </file>
 
 <file path=ppt/slides/slide21.xml><?xml version="1.0" encoding="utf-8"?>
+<p:sld xmlns:a="http://schemas.openxmlformats.org/drawingml/2006/main" xmlns:r="http://schemas.openxmlformats.org/officeDocument/2006/relationships" xmlns:p="http://schemas.openxmlformats.org/presentationml/2006/main" show="0">
+  <p:cSld>
+    <p:spTree>
+      <p:nvGrpSpPr>
+        <p:cNvPr id="1" name=""/>
+        <p:cNvGrpSpPr/>
+        <p:nvPr/>
+      </p:nvGrpSpPr>
+      <p:grpSpPr>
+        <a:xfrm>
+          <a:off x="0" y="0"/>
+          <a:ext cx="0" cy="0"/>
+          <a:chOff x="0" y="0"/>
+          <a:chExt cx="0" cy="0"/>
+        </a:xfrm>
+      </p:grpSpPr>
+      <p:sp>
+        <p:nvSpPr>
+          <p:cNvPr id="8" name="Content Placeholder 7">
+            <a:extLst>
+              <a:ext uri="{FF2B5EF4-FFF2-40B4-BE49-F238E27FC236}">
+                <a16:creationId xmlns:a16="http://schemas.microsoft.com/office/drawing/2014/main" id="{3B396EB3-BA26-1A5B-25D9-E11B2ED23345}"/>
+              </a:ext>
+            </a:extLst>
+          </p:cNvPr>
+          <p:cNvSpPr>
+            <a:spLocks noGrp="1"/>
+          </p:cNvSpPr>
+          <p:nvPr>
+            <p:ph sz="quarter" idx="13"/>
+          </p:nvPr>
+        </p:nvSpPr>
+        <p:spPr/>
+        <p:txBody>
+          <a:bodyPr/>
+          <a:lstStyle/>
+          <a:p>
+            <a:r>
+              <a:rPr lang="en-GB" sz="2400" dirty="0">
+                <a:latin typeface="Calibri" panose="020F0502020204030204" pitchFamily="34" charset="0"/>
+                <a:cs typeface="Calibri" panose="020F0502020204030204" pitchFamily="34" charset="0"/>
+              </a:rPr>
+              <a:t>Logger might crash if SALEAE Logic2 application doesn't enable "Automation Server" at Scenario B.</a:t>
+            </a:r>
+          </a:p>
+          <a:p>
+            <a:r>
+              <a:rPr lang="en-GB" sz="2400" dirty="0">
+                <a:latin typeface="Calibri" panose="020F0502020204030204" pitchFamily="34" charset="0"/>
+                <a:cs typeface="Calibri" panose="020F0502020204030204" pitchFamily="34" charset="0"/>
+              </a:rPr>
+              <a:t>Doesn't support SALEAE Logic Analyser 8ch SKU.</a:t>
+            </a:r>
+          </a:p>
+          <a:p>
+            <a:r>
+              <a:rPr lang="en-GB" sz="2400" dirty="0">
+                <a:latin typeface="Calibri" panose="020F0502020204030204" pitchFamily="34" charset="0"/>
+                <a:cs typeface="Calibri" panose="020F0502020204030204" pitchFamily="34" charset="0"/>
+              </a:rPr>
+              <a:t>DO NOT control log applications directly.</a:t>
+            </a:r>
+          </a:p>
+          <a:p>
+            <a:r>
+              <a:rPr lang="en-GB" sz="2400" dirty="0">
+                <a:latin typeface="Calibri" panose="020F0502020204030204" pitchFamily="34" charset="0"/>
+                <a:cs typeface="Calibri" panose="020F0502020204030204" pitchFamily="34" charset="0"/>
+              </a:rPr>
+              <a:t>Logger cannot rename channel names in SALEAE logs. </a:t>
+            </a:r>
+          </a:p>
+          <a:p>
+            <a:endParaRPr lang="en-GB" sz="2400" dirty="0">
+              <a:latin typeface="Calibri" panose="020F0502020204030204" pitchFamily="34" charset="0"/>
+              <a:cs typeface="Calibri" panose="020F0502020204030204" pitchFamily="34" charset="0"/>
+            </a:endParaRPr>
+          </a:p>
+        </p:txBody>
+      </p:sp>
+      <p:sp>
+        <p:nvSpPr>
+          <p:cNvPr id="3" name="Title 2">
+            <a:extLst>
+              <a:ext uri="{FF2B5EF4-FFF2-40B4-BE49-F238E27FC236}">
+                <a16:creationId xmlns:a16="http://schemas.microsoft.com/office/drawing/2014/main" id="{4281126E-6757-90CE-56A9-3B3BE534AA9B}"/>
+              </a:ext>
+            </a:extLst>
+          </p:cNvPr>
+          <p:cNvSpPr>
+            <a:spLocks noGrp="1"/>
+          </p:cNvSpPr>
+          <p:nvPr>
+            <p:ph type="title"/>
+          </p:nvPr>
+        </p:nvSpPr>
+        <p:spPr/>
+        <p:txBody>
+          <a:bodyPr/>
+          <a:lstStyle/>
+          <a:p>
+            <a:r>
+              <a:rPr lang="en-GB" sz="3200" dirty="0">
+                <a:latin typeface="Calibri" panose="020F0502020204030204" pitchFamily="34" charset="0"/>
+                <a:cs typeface="Calibri" panose="020F0502020204030204" pitchFamily="34" charset="0"/>
+              </a:rPr>
+              <a:t>Infineon WCS Logger – Limitations</a:t>
+            </a:r>
+          </a:p>
+        </p:txBody>
+      </p:sp>
+      <p:sp>
+        <p:nvSpPr>
+          <p:cNvPr id="4" name="Footer Placeholder 3">
+            <a:extLst>
+              <a:ext uri="{FF2B5EF4-FFF2-40B4-BE49-F238E27FC236}">
+                <a16:creationId xmlns:a16="http://schemas.microsoft.com/office/drawing/2014/main" id="{0312F4E3-32AD-DA55-1A4A-815B1F644D43}"/>
+              </a:ext>
+            </a:extLst>
+          </p:cNvPr>
+          <p:cNvSpPr>
+            <a:spLocks noGrp="1"/>
+          </p:cNvSpPr>
+          <p:nvPr>
+            <p:ph type="ftr" sz="quarter" idx="15"/>
+          </p:nvPr>
+        </p:nvSpPr>
+        <p:spPr/>
+        <p:txBody>
+          <a:bodyPr/>
+          <a:lstStyle/>
+          <a:p>
+            <a:endParaRPr lang="en-US" dirty="0"/>
+          </a:p>
+        </p:txBody>
+      </p:sp>
+      <p:sp>
+        <p:nvSpPr>
+          <p:cNvPr id="5" name="Slide Number Placeholder 4">
+            <a:extLst>
+              <a:ext uri="{FF2B5EF4-FFF2-40B4-BE49-F238E27FC236}">
+                <a16:creationId xmlns:a16="http://schemas.microsoft.com/office/drawing/2014/main" id="{5523256E-932F-EFAB-7038-27F280525253}"/>
+              </a:ext>
+            </a:extLst>
+          </p:cNvPr>
+          <p:cNvSpPr>
+            <a:spLocks noGrp="1"/>
+          </p:cNvSpPr>
+          <p:nvPr>
+            <p:ph type="sldNum" sz="quarter" idx="16"/>
+          </p:nvPr>
+        </p:nvSpPr>
+        <p:spPr/>
+        <p:txBody>
+          <a:bodyPr/>
+          <a:lstStyle/>
+          <a:p>
+            <a:r>
+              <a:rPr lang="en-US"/>
+              <a:t> </a:t>
+            </a:r>
+            <a:endParaRPr lang="en-US" dirty="0"/>
+          </a:p>
+        </p:txBody>
+      </p:sp>
+    </p:spTree>
+    <p:extLst>
+      <p:ext uri="{BB962C8B-B14F-4D97-AF65-F5344CB8AC3E}">
+        <p14:creationId xmlns:p14="http://schemas.microsoft.com/office/powerpoint/2010/main" val="431517035"/>
+      </p:ext>
+    </p:extLst>
+  </p:cSld>
+  <p:clrMapOvr>
+    <a:masterClrMapping/>
+  </p:clrMapOvr>
+</p:sld>
+</file>
+
+<file path=ppt/slides/slide22.xml><?xml version="1.0" encoding="utf-8"?>
 <p:sld xmlns:a="http://schemas.openxmlformats.org/drawingml/2006/main" xmlns:r="http://schemas.openxmlformats.org/officeDocument/2006/relationships" xmlns:p="http://schemas.openxmlformats.org/presentationml/2006/main">
   <p:cSld>
     <p:spTree>
@@ -28700,7 +29820,7 @@
 </p:sld>
 </file>
 
-<file path=ppt/slides/slide22.xml><?xml version="1.0" encoding="utf-8"?>
+<file path=ppt/slides/slide23.xml><?xml version="1.0" encoding="utf-8"?>
 <p:sld xmlns:a="http://schemas.openxmlformats.org/drawingml/2006/main" xmlns:r="http://schemas.openxmlformats.org/officeDocument/2006/relationships" xmlns:p="http://schemas.openxmlformats.org/presentationml/2006/main">
   <p:cSld>
     <p:spTree>
@@ -29151,7 +30271,7 @@
             <a:fld id="{20CF0657-954C-457B-AB6C-2444DAE1F514}" type="datetime3">
               <a:rPr lang="en-GB" smtClean="0"/>
               <a:pPr/>
-              <a:t>24 July, 2023</a:t>
+              <a:t>9 August, 2023</a:t>
             </a:fld>
             <a:r>
               <a:rPr lang="en-GB" dirty="0"/>
@@ -29757,7 +30877,7 @@
             <a:fld id="{20CF0657-954C-457B-AB6C-2444DAE1F514}" type="datetime3">
               <a:rPr lang="en-GB" smtClean="0"/>
               <a:pPr/>
-              <a:t>24 July, 2023</a:t>
+              <a:t>9 August, 2023</a:t>
             </a:fld>
             <a:r>
               <a:rPr lang="en-GB" dirty="0"/>
@@ -30143,7 +31263,7 @@
             <a:fld id="{20CF0657-954C-457B-AB6C-2444DAE1F514}" type="datetime3">
               <a:rPr lang="en-GB" smtClean="0"/>
               <a:pPr/>
-              <a:t>24 July, 2023</a:t>
+              <a:t>9 August, 2023</a:t>
             </a:fld>
             <a:r>
               <a:rPr lang="en-GB" dirty="0"/>
@@ -30455,7 +31575,7 @@
             <a:fld id="{20CF0657-954C-457B-AB6C-2444DAE1F514}" type="datetime3">
               <a:rPr lang="en-GB" smtClean="0"/>
               <a:pPr/>
-              <a:t>24 July, 2023</a:t>
+              <a:t>9 August, 2023</a:t>
             </a:fld>
             <a:r>
               <a:rPr lang="en-GB" dirty="0"/>
@@ -30856,7 +31976,7 @@
             <a:fld id="{20CF0657-954C-457B-AB6C-2444DAE1F514}" type="datetime3">
               <a:rPr lang="en-GB" smtClean="0"/>
               <a:pPr/>
-              <a:t>24 July, 2023</a:t>
+              <a:t>9 August, 2023</a:t>
             </a:fld>
             <a:r>
               <a:rPr lang="en-GB" dirty="0"/>
@@ -31628,7 +32748,7 @@
             <a:fld id="{20CF0657-954C-457B-AB6C-2444DAE1F514}" type="datetime3">
               <a:rPr lang="en-GB" smtClean="0"/>
               <a:pPr/>
-              <a:t>24 July, 2023</a:t>
+              <a:t>9 August, 2023</a:t>
             </a:fld>
             <a:r>
               <a:rPr lang="en-GB" dirty="0"/>
@@ -34011,14 +35131,6 @@
 </file>
 
 <file path=customXml/item1.xml><?xml version="1.0" encoding="utf-8"?>
-<p:properties xmlns:p="http://schemas.microsoft.com/office/2006/metadata/properties" xmlns:xsi="http://www.w3.org/2001/XMLSchema-instance" xmlns:pc="http://schemas.microsoft.com/office/infopath/2007/PartnerControls">
-  <documentManagement>
-    <Ver xmlns="a709603d-609a-478b-a91d-3c5e984c0e79">0</Ver>
-  </documentManagement>
-</p:properties>
-</file>
-
-<file path=customXml/item2.xml><?xml version="1.0" encoding="utf-8"?>
 <?mso-contentType ?>
 <customXsn xmlns="http://schemas.microsoft.com/office/2006/metadata/customXsn">
   <xsnLocation/>
@@ -34028,7 +35140,24 @@
 </customXsn>
 </file>
 
+<file path=customXml/item2.xml><?xml version="1.0" encoding="utf-8"?>
+<p:properties xmlns:p="http://schemas.microsoft.com/office/2006/metadata/properties" xmlns:xsi="http://www.w3.org/2001/XMLSchema-instance" xmlns:pc="http://schemas.microsoft.com/office/infopath/2007/PartnerControls">
+  <documentManagement>
+    <Ver xmlns="a709603d-609a-478b-a91d-3c5e984c0e79">0</Ver>
+  </documentManagement>
+</p:properties>
+</file>
+
 <file path=customXml/item3.xml><?xml version="1.0" encoding="utf-8"?>
+<?mso-contentType ?>
+<FormTemplates xmlns="http://schemas.microsoft.com/sharepoint/v3/contenttype/forms">
+  <Display>DocumentLibraryForm</Display>
+  <Edit>DocumentLibraryForm</Edit>
+  <New>DocumentLibraryForm</New>
+</FormTemplates>
+</file>
+
+<file path=customXml/item4.xml><?xml version="1.0" encoding="utf-8"?>
 <ct:contentTypeSchema xmlns:ct="http://schemas.microsoft.com/office/2006/metadata/contentType" xmlns:ma="http://schemas.microsoft.com/office/2006/metadata/properties/metaAttributes" ct:_="" ma:_="" ma:contentTypeName="Document" ma:contentTypeID="0x010100A655AAE9148B404486CBFDD74AD2AA0B" ma:contentTypeVersion="2" ma:contentTypeDescription="Create a new document." ma:contentTypeScope="" ma:versionID="a24cc1775e4f53b56bd6bf310015a115">
   <xsd:schema xmlns:xsd="http://www.w3.org/2001/XMLSchema" xmlns:xs="http://www.w3.org/2001/XMLSchema" xmlns:p="http://schemas.microsoft.com/office/2006/metadata/properties" xmlns:ns2="a709603d-609a-478b-a91d-3c5e984c0e79" xmlns:ns3="6ef45842-284e-44e4-b2db-1749e7948b44" targetNamespace="http://schemas.microsoft.com/office/2006/metadata/properties" ma:root="true" ma:fieldsID="f8923fe8aa0ace7ab58ef4ccc8b43a85" ns2:_="" ns3:_="">
     <xsd:import namespace="a709603d-609a-478b-a91d-3c5e984c0e79"/>
@@ -34179,16 +35308,15 @@
 </ct:contentTypeSchema>
 </file>
 
-<file path=customXml/item4.xml><?xml version="1.0" encoding="utf-8"?>
-<?mso-contentType ?>
-<FormTemplates xmlns="http://schemas.microsoft.com/sharepoint/v3/contenttype/forms">
-  <Display>DocumentLibraryForm</Display>
-  <Edit>DocumentLibraryForm</Edit>
-  <New>DocumentLibraryForm</New>
-</FormTemplates>
+<file path=customXml/itemProps1.xml><?xml version="1.0" encoding="utf-8"?>
+<ds:datastoreItem xmlns:ds="http://schemas.openxmlformats.org/officeDocument/2006/customXml" ds:itemID="{EC144A13-A380-40B3-9980-61BD11F58D02}">
+  <ds:schemaRefs>
+    <ds:schemaRef ds:uri="http://schemas.microsoft.com/office/2006/metadata/customXsn"/>
+  </ds:schemaRefs>
+</ds:datastoreItem>
 </file>
 
-<file path=customXml/itemProps1.xml><?xml version="1.0" encoding="utf-8"?>
+<file path=customXml/itemProps2.xml><?xml version="1.0" encoding="utf-8"?>
 <ds:datastoreItem xmlns:ds="http://schemas.openxmlformats.org/officeDocument/2006/customXml" ds:itemID="{D299A1D5-F553-4264-9022-E0136C61CE27}">
   <ds:schemaRefs>
     <ds:schemaRef ds:uri="http://schemas.microsoft.com/office/2006/metadata/properties"/>
@@ -34205,15 +35333,15 @@
 </ds:datastoreItem>
 </file>
 
-<file path=customXml/itemProps2.xml><?xml version="1.0" encoding="utf-8"?>
-<ds:datastoreItem xmlns:ds="http://schemas.openxmlformats.org/officeDocument/2006/customXml" ds:itemID="{EC144A13-A380-40B3-9980-61BD11F58D02}">
+<file path=customXml/itemProps3.xml><?xml version="1.0" encoding="utf-8"?>
+<ds:datastoreItem xmlns:ds="http://schemas.openxmlformats.org/officeDocument/2006/customXml" ds:itemID="{63C6748B-B74E-4BE1-834C-AEBB9BCA18FB}">
   <ds:schemaRefs>
-    <ds:schemaRef ds:uri="http://schemas.microsoft.com/office/2006/metadata/customXsn"/>
+    <ds:schemaRef ds:uri="http://schemas.microsoft.com/sharepoint/v3/contenttype/forms"/>
   </ds:schemaRefs>
 </ds:datastoreItem>
 </file>
 
-<file path=customXml/itemProps3.xml><?xml version="1.0" encoding="utf-8"?>
+<file path=customXml/itemProps4.xml><?xml version="1.0" encoding="utf-8"?>
 <ds:datastoreItem xmlns:ds="http://schemas.openxmlformats.org/officeDocument/2006/customXml" ds:itemID="{AF2014AB-78C2-4F59-9D6E-9572E72F7781}">
   <ds:schemaRefs>
     <ds:schemaRef ds:uri="http://schemas.microsoft.com/office/2006/metadata/contentType"/>
@@ -34230,12 +35358,4 @@
     <ds:schemaRef ds:uri="http://schemas.microsoft.com/internal/obd"/>
   </ds:schemaRefs>
 </ds:datastoreItem>
-</file>
-
-<file path=customXml/itemProps4.xml><?xml version="1.0" encoding="utf-8"?>
-<ds:datastoreItem xmlns:ds="http://schemas.openxmlformats.org/officeDocument/2006/customXml" ds:itemID="{63C6748B-B74E-4BE1-834C-AEBB9BCA18FB}">
-  <ds:schemaRefs>
-    <ds:schemaRef ds:uri="http://schemas.microsoft.com/sharepoint/v3/contenttype/forms"/>
-  </ds:schemaRefs>
-</ds:datastoreItem>
 </file>
</xml_diff>

<commit_message>
check display language instead of system locale
</commit_message>
<xml_diff>
--- a/docs/IFX MSD cases.pptx
+++ b/docs/IFX MSD cases.pptx
@@ -4146,7 +4146,7 @@
             <a:fld id="{20CF0657-954C-457B-AB6C-2444DAE1F514}" type="datetime3">
               <a:rPr lang="en-GB" smtClean="0"/>
               <a:pPr/>
-              <a:t>21 August, 2023</a:t>
+              <a:t>24 August, 2023</a:t>
             </a:fld>
             <a:r>
               <a:rPr lang="en-GB"/>
@@ -5418,7 +5418,7 @@
             <a:fld id="{20CF0657-954C-457B-AB6C-2444DAE1F514}" type="datetime3">
               <a:rPr lang="en-GB" smtClean="0"/>
               <a:pPr/>
-              <a:t>21 August, 2023</a:t>
+              <a:t>24 August, 2023</a:t>
             </a:fld>
             <a:r>
               <a:rPr lang="en-GB"/>
@@ -7816,7 +7816,7 @@
             <a:fld id="{20CF0657-954C-457B-AB6C-2444DAE1F514}" type="datetime3">
               <a:rPr lang="en-GB" smtClean="0"/>
               <a:pPr/>
-              <a:t>21 August, 2023</a:t>
+              <a:t>24 August, 2023</a:t>
             </a:fld>
             <a:r>
               <a:rPr lang="en-GB"/>
@@ -9116,7 +9116,7 @@
             <a:fld id="{20CF0657-954C-457B-AB6C-2444DAE1F514}" type="datetime3">
               <a:rPr lang="en-GB" smtClean="0"/>
               <a:pPr/>
-              <a:t>21 August, 2023</a:t>
+              <a:t>24 August, 2023</a:t>
             </a:fld>
             <a:r>
               <a:rPr lang="en-GB"/>
@@ -10486,7 +10486,7 @@
             <a:fld id="{20CF0657-954C-457B-AB6C-2444DAE1F514}" type="datetime3">
               <a:rPr lang="en-GB" smtClean="0"/>
               <a:pPr/>
-              <a:t>21 August, 2023</a:t>
+              <a:t>24 August, 2023</a:t>
             </a:fld>
             <a:r>
               <a:rPr lang="en-GB"/>
@@ -11319,7 +11319,7 @@
             <a:fld id="{20CF0657-954C-457B-AB6C-2444DAE1F514}" type="datetime3">
               <a:rPr lang="en-GB" smtClean="0"/>
               <a:pPr/>
-              <a:t>21 August, 2023</a:t>
+              <a:t>24 August, 2023</a:t>
             </a:fld>
             <a:r>
               <a:rPr lang="en-GB"/>
@@ -12450,7 +12450,7 @@
             <a:fld id="{20CF0657-954C-457B-AB6C-2444DAE1F514}" type="datetime3">
               <a:rPr lang="en-GB" smtClean="0"/>
               <a:pPr/>
-              <a:t>21 August, 2023</a:t>
+              <a:t>24 August, 2023</a:t>
             </a:fld>
             <a:r>
               <a:rPr lang="en-GB" dirty="0"/>
@@ -13748,7 +13748,7 @@
             <a:fld id="{20CF0657-954C-457B-AB6C-2444DAE1F514}" type="datetime3">
               <a:rPr lang="en-GB" smtClean="0"/>
               <a:pPr/>
-              <a:t>21 August, 2023</a:t>
+              <a:t>24 August, 2023</a:t>
             </a:fld>
             <a:r>
               <a:rPr lang="en-GB" dirty="0"/>
@@ -15584,7 +15584,7 @@
             <a:fld id="{20CF0657-954C-457B-AB6C-2444DAE1F514}" type="datetime3">
               <a:rPr lang="en-GB" smtClean="0"/>
               <a:pPr/>
-              <a:t>21 August, 2023</a:t>
+              <a:t>24 August, 2023</a:t>
             </a:fld>
             <a:r>
               <a:rPr lang="en-GB"/>
@@ -16559,7 +16559,7 @@
             <a:fld id="{20CF0657-954C-457B-AB6C-2444DAE1F514}" type="datetime3">
               <a:rPr lang="en-GB" smtClean="0"/>
               <a:pPr/>
-              <a:t>21 August, 2023</a:t>
+              <a:t>24 August, 2023</a:t>
             </a:fld>
             <a:r>
               <a:rPr lang="en-GB"/>
@@ -17635,7 +17635,7 @@
             <a:fld id="{20CF0657-954C-457B-AB6C-2444DAE1F514}" type="datetime3">
               <a:rPr lang="en-GB" smtClean="0"/>
               <a:pPr/>
-              <a:t>21 August, 2023</a:t>
+              <a:t>24 August, 2023</a:t>
             </a:fld>
             <a:r>
               <a:rPr lang="en-GB"/>
@@ -19880,7 +19880,7 @@
             <a:fld id="{20CF0657-954C-457B-AB6C-2444DAE1F514}" type="datetime3">
               <a:rPr lang="en-GB" smtClean="0"/>
               <a:pPr/>
-              <a:t>21 August, 2023</a:t>
+              <a:t>24 August, 2023</a:t>
             </a:fld>
             <a:r>
               <a:rPr lang="en-GB"/>
@@ -22406,6 +22406,19 @@
               </a:rPr>
               <a:t>Trial solutions released</a:t>
             </a:r>
+            <a:br>
+              <a:rPr lang="en-GB" dirty="0">
+                <a:latin typeface="Calibri" panose="020F0502020204030204" pitchFamily="34" charset="0"/>
+                <a:cs typeface="Calibri" panose="020F0502020204030204" pitchFamily="34" charset="0"/>
+              </a:rPr>
+            </a:br>
+            <a:r>
+              <a:rPr lang="en-GB" dirty="0">
+                <a:latin typeface="Calibri" panose="020F0502020204030204" pitchFamily="34" charset="0"/>
+                <a:cs typeface="Calibri" panose="020F0502020204030204" pitchFamily="34" charset="0"/>
+              </a:rPr>
+              <a:t>through MSD case</a:t>
+            </a:r>
             <a:endParaRPr lang="en-GB" baseline="0" dirty="0">
               <a:latin typeface="Calibri" panose="020F0502020204030204" pitchFamily="34" charset="0"/>
               <a:cs typeface="Calibri" panose="020F0502020204030204" pitchFamily="34" charset="0"/>
@@ -22558,6 +22571,19 @@
                 <a:cs typeface="Calibri" panose="020F0502020204030204" pitchFamily="34" charset="0"/>
               </a:rPr>
               <a:t>Official release</a:t>
+            </a:r>
+            <a:br>
+              <a:rPr lang="en-GB" baseline="0" dirty="0">
+                <a:latin typeface="Calibri" panose="020F0502020204030204" pitchFamily="34" charset="0"/>
+                <a:cs typeface="Calibri" panose="020F0502020204030204" pitchFamily="34" charset="0"/>
+              </a:rPr>
+            </a:br>
+            <a:r>
+              <a:rPr lang="en-GB" baseline="0" dirty="0">
+                <a:latin typeface="Calibri" panose="020F0502020204030204" pitchFamily="34" charset="0"/>
+                <a:cs typeface="Calibri" panose="020F0502020204030204" pitchFamily="34" charset="0"/>
+              </a:rPr>
+              <a:t>through MSD case</a:t>
             </a:r>
           </a:p>
         </p:txBody>
@@ -28657,7 +28683,7 @@
             <a:fld id="{20CF0657-954C-457B-AB6C-2444DAE1F514}" type="datetime3">
               <a:rPr lang="en-GB" smtClean="0"/>
               <a:pPr/>
-              <a:t>21 August, 2023</a:t>
+              <a:t>24 August, 2023</a:t>
             </a:fld>
             <a:r>
               <a:rPr lang="en-GB" dirty="0"/>
@@ -29514,7 +29540,7 @@
             <a:fld id="{20CF0657-954C-457B-AB6C-2444DAE1F514}" type="datetime3">
               <a:rPr lang="en-GB" smtClean="0"/>
               <a:pPr/>
-              <a:t>21 August, 2023</a:t>
+              <a:t>24 August, 2023</a:t>
             </a:fld>
             <a:r>
               <a:rPr lang="en-GB" dirty="0"/>
@@ -30791,7 +30817,7 @@
             <a:fld id="{20CF0657-954C-457B-AB6C-2444DAE1F514}" type="datetime3">
               <a:rPr lang="en-GB" smtClean="0"/>
               <a:pPr/>
-              <a:t>21 August, 2023</a:t>
+              <a:t>24 August, 2023</a:t>
             </a:fld>
             <a:r>
               <a:rPr lang="en-GB" dirty="0"/>
@@ -31397,7 +31423,7 @@
             <a:fld id="{20CF0657-954C-457B-AB6C-2444DAE1F514}" type="datetime3">
               <a:rPr lang="en-GB" smtClean="0"/>
               <a:pPr/>
-              <a:t>21 August, 2023</a:t>
+              <a:t>24 August, 2023</a:t>
             </a:fld>
             <a:r>
               <a:rPr lang="en-GB" dirty="0"/>
@@ -31783,7 +31809,7 @@
             <a:fld id="{20CF0657-954C-457B-AB6C-2444DAE1F514}" type="datetime3">
               <a:rPr lang="en-GB" smtClean="0"/>
               <a:pPr/>
-              <a:t>21 August, 2023</a:t>
+              <a:t>24 August, 2023</a:t>
             </a:fld>
             <a:r>
               <a:rPr lang="en-GB" dirty="0"/>
@@ -32095,7 +32121,7 @@
             <a:fld id="{20CF0657-954C-457B-AB6C-2444DAE1F514}" type="datetime3">
               <a:rPr lang="en-GB" smtClean="0"/>
               <a:pPr/>
-              <a:t>21 August, 2023</a:t>
+              <a:t>24 August, 2023</a:t>
             </a:fld>
             <a:r>
               <a:rPr lang="en-GB" dirty="0"/>
@@ -32496,7 +32522,7 @@
             <a:fld id="{20CF0657-954C-457B-AB6C-2444DAE1F514}" type="datetime3">
               <a:rPr lang="en-GB" smtClean="0"/>
               <a:pPr/>
-              <a:t>21 August, 2023</a:t>
+              <a:t>24 August, 2023</a:t>
             </a:fld>
             <a:r>
               <a:rPr lang="en-GB" dirty="0"/>
@@ -33268,7 +33294,7 @@
             <a:fld id="{20CF0657-954C-457B-AB6C-2444DAE1F514}" type="datetime3">
               <a:rPr lang="en-GB" smtClean="0"/>
               <a:pPr/>
-              <a:t>21 August, 2023</a:t>
+              <a:t>24 August, 2023</a:t>
             </a:fld>
             <a:r>
               <a:rPr lang="en-GB" dirty="0"/>
@@ -35651,14 +35677,6 @@
 </file>
 
 <file path=customXml/item1.xml><?xml version="1.0" encoding="utf-8"?>
-<p:properties xmlns:p="http://schemas.microsoft.com/office/2006/metadata/properties" xmlns:xsi="http://www.w3.org/2001/XMLSchema-instance" xmlns:pc="http://schemas.microsoft.com/office/infopath/2007/PartnerControls">
-  <documentManagement>
-    <Ver xmlns="a709603d-609a-478b-a91d-3c5e984c0e79">0</Ver>
-  </documentManagement>
-</p:properties>
-</file>
-
-<file path=customXml/item2.xml><?xml version="1.0" encoding="utf-8"?>
 <?mso-contentType ?>
 <customXsn xmlns="http://schemas.microsoft.com/office/2006/metadata/customXsn">
   <xsnLocation/>
@@ -35668,7 +35686,24 @@
 </customXsn>
 </file>
 
+<file path=customXml/item2.xml><?xml version="1.0" encoding="utf-8"?>
+<p:properties xmlns:p="http://schemas.microsoft.com/office/2006/metadata/properties" xmlns:xsi="http://www.w3.org/2001/XMLSchema-instance" xmlns:pc="http://schemas.microsoft.com/office/infopath/2007/PartnerControls">
+  <documentManagement>
+    <Ver xmlns="a709603d-609a-478b-a91d-3c5e984c0e79">0</Ver>
+  </documentManagement>
+</p:properties>
+</file>
+
 <file path=customXml/item3.xml><?xml version="1.0" encoding="utf-8"?>
+<?mso-contentType ?>
+<FormTemplates xmlns="http://schemas.microsoft.com/sharepoint/v3/contenttype/forms">
+  <Display>DocumentLibraryForm</Display>
+  <Edit>DocumentLibraryForm</Edit>
+  <New>DocumentLibraryForm</New>
+</FormTemplates>
+</file>
+
+<file path=customXml/item4.xml><?xml version="1.0" encoding="utf-8"?>
 <ct:contentTypeSchema xmlns:ct="http://schemas.microsoft.com/office/2006/metadata/contentType" xmlns:ma="http://schemas.microsoft.com/office/2006/metadata/properties/metaAttributes" ct:_="" ma:_="" ma:contentTypeName="Document" ma:contentTypeID="0x010100A655AAE9148B404486CBFDD74AD2AA0B" ma:contentTypeVersion="2" ma:contentTypeDescription="Create a new document." ma:contentTypeScope="" ma:versionID="a24cc1775e4f53b56bd6bf310015a115">
   <xsd:schema xmlns:xsd="http://www.w3.org/2001/XMLSchema" xmlns:xs="http://www.w3.org/2001/XMLSchema" xmlns:p="http://schemas.microsoft.com/office/2006/metadata/properties" xmlns:ns2="a709603d-609a-478b-a91d-3c5e984c0e79" xmlns:ns3="6ef45842-284e-44e4-b2db-1749e7948b44" targetNamespace="http://schemas.microsoft.com/office/2006/metadata/properties" ma:root="true" ma:fieldsID="f8923fe8aa0ace7ab58ef4ccc8b43a85" ns2:_="" ns3:_="">
     <xsd:import namespace="a709603d-609a-478b-a91d-3c5e984c0e79"/>
@@ -35819,16 +35854,15 @@
 </ct:contentTypeSchema>
 </file>
 
-<file path=customXml/item4.xml><?xml version="1.0" encoding="utf-8"?>
-<?mso-contentType ?>
-<FormTemplates xmlns="http://schemas.microsoft.com/sharepoint/v3/contenttype/forms">
-  <Display>DocumentLibraryForm</Display>
-  <Edit>DocumentLibraryForm</Edit>
-  <New>DocumentLibraryForm</New>
-</FormTemplates>
+<file path=customXml/itemProps1.xml><?xml version="1.0" encoding="utf-8"?>
+<ds:datastoreItem xmlns:ds="http://schemas.openxmlformats.org/officeDocument/2006/customXml" ds:itemID="{EC144A13-A380-40B3-9980-61BD11F58D02}">
+  <ds:schemaRefs>
+    <ds:schemaRef ds:uri="http://schemas.microsoft.com/office/2006/metadata/customXsn"/>
+  </ds:schemaRefs>
+</ds:datastoreItem>
 </file>
 
-<file path=customXml/itemProps1.xml><?xml version="1.0" encoding="utf-8"?>
+<file path=customXml/itemProps2.xml><?xml version="1.0" encoding="utf-8"?>
 <ds:datastoreItem xmlns:ds="http://schemas.openxmlformats.org/officeDocument/2006/customXml" ds:itemID="{D299A1D5-F553-4264-9022-E0136C61CE27}">
   <ds:schemaRefs>
     <ds:schemaRef ds:uri="http://schemas.microsoft.com/office/2006/metadata/properties"/>
@@ -35845,15 +35879,15 @@
 </ds:datastoreItem>
 </file>
 
-<file path=customXml/itemProps2.xml><?xml version="1.0" encoding="utf-8"?>
-<ds:datastoreItem xmlns:ds="http://schemas.openxmlformats.org/officeDocument/2006/customXml" ds:itemID="{EC144A13-A380-40B3-9980-61BD11F58D02}">
+<file path=customXml/itemProps3.xml><?xml version="1.0" encoding="utf-8"?>
+<ds:datastoreItem xmlns:ds="http://schemas.openxmlformats.org/officeDocument/2006/customXml" ds:itemID="{63C6748B-B74E-4BE1-834C-AEBB9BCA18FB}">
   <ds:schemaRefs>
-    <ds:schemaRef ds:uri="http://schemas.microsoft.com/office/2006/metadata/customXsn"/>
+    <ds:schemaRef ds:uri="http://schemas.microsoft.com/sharepoint/v3/contenttype/forms"/>
   </ds:schemaRefs>
 </ds:datastoreItem>
 </file>
 
-<file path=customXml/itemProps3.xml><?xml version="1.0" encoding="utf-8"?>
+<file path=customXml/itemProps4.xml><?xml version="1.0" encoding="utf-8"?>
 <ds:datastoreItem xmlns:ds="http://schemas.openxmlformats.org/officeDocument/2006/customXml" ds:itemID="{AF2014AB-78C2-4F59-9D6E-9572E72F7781}">
   <ds:schemaRefs>
     <ds:schemaRef ds:uri="http://schemas.microsoft.com/office/2006/metadata/contentType"/>
@@ -35870,12 +35904,4 @@
     <ds:schemaRef ds:uri="http://schemas.microsoft.com/internal/obd"/>
   </ds:schemaRefs>
 </ds:datastoreItem>
-</file>
-
-<file path=customXml/itemProps4.xml><?xml version="1.0" encoding="utf-8"?>
-<ds:datastoreItem xmlns:ds="http://schemas.openxmlformats.org/officeDocument/2006/customXml" ds:itemID="{63C6748B-B74E-4BE1-834C-AEBB9BCA18FB}">
-  <ds:schemaRefs>
-    <ds:schemaRef ds:uri="http://schemas.microsoft.com/sharepoint/v3/contenttype/forms"/>
-  </ds:schemaRefs>
-</ds:datastoreItem>
 </file>
</xml_diff>